<commit_message>
Expand analysis with topics, held-out prediction and comment experiments
</commit_message>
<xml_diff>
--- a/演示文稿.pptx
+++ b/演示文稿.pptx
@@ -21,6 +21,13 @@
     <p:sldId id="269" r:id="rId21"/>
     <p:sldId id="270" r:id="rId22"/>
     <p:sldId id="271" r:id="rId23"/>
+    <p:sldId id="272" r:id="rId24"/>
+    <p:sldId id="273" r:id="rId25"/>
+    <p:sldId id="274" r:id="rId26"/>
+    <p:sldId id="275" r:id="rId27"/>
+    <p:sldId id="276" r:id="rId28"/>
+    <p:sldId id="277" r:id="rId29"/>
+    <p:sldId id="278" r:id="rId30"/>
   </p:sldIdLst>
   <p:sldSz cx="12191969" cy="6858000" type="screen4x3"/>
   <p:notesSz cx="6858000" cy="9144000"/>
@@ -587,7 +594,7 @@
           <a:lstStyle/>
           <a:p>
             <a:r>
-              <a:t>解释为什么不因长尾强行删除极端值：主模型保留，敏感性规格另行比较。PPML以原始点赞数的条件算术均值为目标，OLS刻画对数结果。</a:t>
+              <a:t>主题模型纳入至少3个有效词的正文，并排除8条成分贡献近零的记录，占全部帖25.9%。回归控制原词典及作者、日期等因素，区间未包含主题估计误差。</a:t>
             </a:r>
           </a:p>
         </p:txBody>
@@ -657,7 +664,7 @@
           <a:lstStyle/>
           <a:p>
             <a:r>
-              <a:t>这是方法上的边界检查。规则本身能复现不代表语义测量有效，未命中也不等于没有表达。没有使用结果来反复修改词典以获取显著系数。</a:t>
+              <a:t>解释同一作者发帖比较。没有曝光、粉丝与统一采集时间，固定效应没有消除全部混杂。若被问到公式，请对应报告中的模型设定部分。</a:t>
             </a:r>
           </a:p>
         </p:txBody>
@@ -727,7 +734,7 @@
           <a:lstStyle/>
           <a:p>
             <a:r>
-              <a:t>不要把所有回复都连向帖主。评论最晚到2021年8月，所以网络指标不作为发帖前影响力加入回归。金色表示样本作者，蓝色表示其他参与者；节点大小按加权入度对数缩放。</a:t>
+              <a:t>图中误差线是原始95%聚类置信区间，未做多重检验调整。积极表达虽然区间未跨0，经过五项检验校正后证据不足。不要把模型总R²约0.688都归因于文本。</a:t>
             </a:r>
           </a:p>
         </p:txBody>
@@ -797,7 +804,7 @@
           <a:lstStyle/>
           <a:p>
             <a:r>
-              <a:t>样本从100位作者帖子出发，根评论天然指向帖主，会形成中心。互惠率按有反向边的有向边占比，不按权重；两个网络节点集合不同，不能解释为行为下降。</a:t>
+              <a:t>解释为什么不因长尾强行删除极端值：主模型保留，敏感性规格另行比较。PPML以原始点赞数的条件算术均值为目标，OLS刻画对数结果。</a:t>
             </a:r>
           </a:p>
         </p:txBody>
@@ -867,7 +874,7 @@
           <a:lstStyle/>
           <a:p>
             <a:r>
-              <a:t>提出用户层面随机分组，避免同作者跨组污染；三组可为过程记录提示、面向伙伴问题提示和常规发布，固定7天，样本量先做试点再计算。不宣称已发现提升方案。</a:t>
+              <a:t>这一检查考察是否某一个作者决定结果，不新增100轮显著性判断。原始主检验和探索性检验保持分开。</a:t>
             </a:r>
           </a:p>
         </p:txBody>
@@ -937,7 +944,7 @@
           <a:lstStyle/>
           <a:p>
             <a:r>
-              <a:t>回到三个研究问题，分别给出描述、条件关联和网络结构答案。说明所有材料都可以本地复现。附参考资料：课程NLP与网络讲义；Richardson等2010；statsmodels官方文档。</a:t>
+              <a:t>岭回归alpha固定10，未在测试集调参。字符TF-IDF是2至4元组。因标签观察窗与作者属性历史时戳缺失，这不是实际部署评估。</a:t>
             </a:r>
           </a:p>
         </p:txBody>
@@ -1007,7 +1014,217 @@
           <a:lstStyle/>
           <a:p>
             <a:r>
-              <a:t>感谢听众并进入讨论。每名组员应汇报自己实际负责的内容。请在提交前替换姓名、组号与学号，并修改为真实贡献。互评需每人独立据实完成，模板不代表完成记录。</a:t>
+              <a:t>误差尺度为ln(1+点赞数)。区间以2000次作者聚类重采样固定预测结果得到，未重新训练模型。指标表及全部模型对照见报告。</a:t>
+            </a:r>
+          </a:p>
+        </p:txBody>
+      </p:sp>
+      <p:sp>
+        <p:nvSpPr>
+          <p:cNvPr id="4" name="Slide Number Placeholder 3"/>
+          <p:cNvSpPr>
+            <a:spLocks noGrp="1"/>
+          </p:cNvSpPr>
+          <p:nvPr>
+            <p:ph type="sldNum" idx="5" sz="quarter"/>
+          </p:nvPr>
+        </p:nvSpPr>
+        <p:spPr/>
+      </p:sp>
+    </p:spTree>
+  </p:cSld>
+  <p:clrMapOvr>
+    <a:masterClrMapping/>
+  </p:clrMapOvr>
+</p:notes>
+</file>
+
+<file path=ppt/notesSlides/notesSlide17.xml><?xml version="1.0" encoding="utf-8"?>
+<p:notes xmlns:a="http://schemas.openxmlformats.org/drawingml/2006/main" xmlns:p="http://schemas.openxmlformats.org/presentationml/2006/main" xmlns:r="http://schemas.openxmlformats.org/officeDocument/2006/relationships">
+  <p:cSld>
+    <p:spTree>
+      <p:nvGrpSpPr>
+        <p:cNvPr id="1" name=""/>
+        <p:cNvGrpSpPr/>
+        <p:nvPr/>
+      </p:nvGrpSpPr>
+      <p:grpSpPr>
+        <a:xfrm>
+          <a:off x="0" y="0"/>
+          <a:ext cx="0" cy="0"/>
+          <a:chOff x="0" y="0"/>
+          <a:chExt cx="0" cy="0"/>
+        </a:xfrm>
+      </p:grpSpPr>
+      <p:sp>
+        <p:nvSpPr>
+          <p:cNvPr id="2" name="Slide Image Placeholder 1"/>
+          <p:cNvSpPr>
+            <a:spLocks noGrp="1"/>
+          </p:cNvSpPr>
+          <p:nvPr>
+            <p:ph type="sldImg" idx="2"/>
+          </p:nvPr>
+        </p:nvSpPr>
+        <p:spPr/>
+      </p:sp>
+      <p:sp>
+        <p:nvSpPr>
+          <p:cNvPr id="3" name="Notes Placeholder 2"/>
+          <p:cNvSpPr>
+            <a:spLocks noGrp="1"/>
+          </p:cNvSpPr>
+          <p:nvPr>
+            <p:ph type="body" idx="3" sz="quarter"/>
+          </p:nvPr>
+        </p:nvSpPr>
+        <p:spPr/>
+        <p:txBody>
+          <a:bodyPr/>
+          <a:lstStyle/>
+          <a:p>
+            <a:r>
+              <a:t>这是方法上的边界检查。规则本身能复现不代表语义测量有效，未命中也不等于没有表达。没有使用结果来反复修改词典以获取显著系数。</a:t>
+            </a:r>
+          </a:p>
+        </p:txBody>
+      </p:sp>
+      <p:sp>
+        <p:nvSpPr>
+          <p:cNvPr id="4" name="Slide Number Placeholder 3"/>
+          <p:cNvSpPr>
+            <a:spLocks noGrp="1"/>
+          </p:cNvSpPr>
+          <p:nvPr>
+            <p:ph type="sldNum" idx="5" sz="quarter"/>
+          </p:nvPr>
+        </p:nvSpPr>
+        <p:spPr/>
+      </p:sp>
+    </p:spTree>
+  </p:cSld>
+  <p:clrMapOvr>
+    <a:masterClrMapping/>
+  </p:clrMapOvr>
+</p:notes>
+</file>
+
+<file path=ppt/notesSlides/notesSlide18.xml><?xml version="1.0" encoding="utf-8"?>
+<p:notes xmlns:a="http://schemas.openxmlformats.org/drawingml/2006/main" xmlns:p="http://schemas.openxmlformats.org/presentationml/2006/main" xmlns:r="http://schemas.openxmlformats.org/officeDocument/2006/relationships">
+  <p:cSld>
+    <p:spTree>
+      <p:nvGrpSpPr>
+        <p:cNvPr id="1" name=""/>
+        <p:cNvGrpSpPr/>
+        <p:nvPr/>
+      </p:nvGrpSpPr>
+      <p:grpSpPr>
+        <a:xfrm>
+          <a:off x="0" y="0"/>
+          <a:ext cx="0" cy="0"/>
+          <a:chOff x="0" y="0"/>
+          <a:chExt cx="0" cy="0"/>
+        </a:xfrm>
+      </p:grpSpPr>
+      <p:sp>
+        <p:nvSpPr>
+          <p:cNvPr id="2" name="Slide Image Placeholder 1"/>
+          <p:cNvSpPr>
+            <a:spLocks noGrp="1"/>
+          </p:cNvSpPr>
+          <p:nvPr>
+            <p:ph type="sldImg" idx="2"/>
+          </p:nvPr>
+        </p:nvSpPr>
+        <p:spPr/>
+      </p:sp>
+      <p:sp>
+        <p:nvSpPr>
+          <p:cNvPr id="3" name="Notes Placeholder 2"/>
+          <p:cNvSpPr>
+            <a:spLocks noGrp="1"/>
+          </p:cNvSpPr>
+          <p:nvPr>
+            <p:ph type="body" idx="3" sz="quarter"/>
+          </p:nvPr>
+        </p:nvSpPr>
+        <p:spPr/>
+        <p:txBody>
+          <a:bodyPr/>
+          <a:lstStyle/>
+          <a:p>
+            <a:r>
+              <a:t>不要把所有回复都连向帖主。评论最晚到2021年8月，所以网络指标不作为发帖前影响力加入回归。金色表示样本作者，蓝色表示其他参与者；节点大小按加权入度对数缩放。</a:t>
+            </a:r>
+          </a:p>
+        </p:txBody>
+      </p:sp>
+      <p:sp>
+        <p:nvSpPr>
+          <p:cNvPr id="4" name="Slide Number Placeholder 3"/>
+          <p:cNvSpPr>
+            <a:spLocks noGrp="1"/>
+          </p:cNvSpPr>
+          <p:nvPr>
+            <p:ph type="sldNum" idx="5" sz="quarter"/>
+          </p:nvPr>
+        </p:nvSpPr>
+        <p:spPr/>
+      </p:sp>
+    </p:spTree>
+  </p:cSld>
+  <p:clrMapOvr>
+    <a:masterClrMapping/>
+  </p:clrMapOvr>
+</p:notes>
+</file>
+
+<file path=ppt/notesSlides/notesSlide19.xml><?xml version="1.0" encoding="utf-8"?>
+<p:notes xmlns:a="http://schemas.openxmlformats.org/drawingml/2006/main" xmlns:p="http://schemas.openxmlformats.org/presentationml/2006/main" xmlns:r="http://schemas.openxmlformats.org/officeDocument/2006/relationships">
+  <p:cSld>
+    <p:spTree>
+      <p:nvGrpSpPr>
+        <p:cNvPr id="1" name=""/>
+        <p:cNvGrpSpPr/>
+        <p:nvPr/>
+      </p:nvGrpSpPr>
+      <p:grpSpPr>
+        <a:xfrm>
+          <a:off x="0" y="0"/>
+          <a:ext cx="0" cy="0"/>
+          <a:chOff x="0" y="0"/>
+          <a:chExt cx="0" cy="0"/>
+        </a:xfrm>
+      </p:grpSpPr>
+      <p:sp>
+        <p:nvSpPr>
+          <p:cNvPr id="2" name="Slide Image Placeholder 1"/>
+          <p:cNvSpPr>
+            <a:spLocks noGrp="1"/>
+          </p:cNvSpPr>
+          <p:nvPr>
+            <p:ph type="sldImg" idx="2"/>
+          </p:nvPr>
+        </p:nvSpPr>
+        <p:spPr/>
+      </p:sp>
+      <p:sp>
+        <p:nvSpPr>
+          <p:cNvPr id="3" name="Notes Placeholder 2"/>
+          <p:cNvSpPr>
+            <a:spLocks noGrp="1"/>
+          </p:cNvSpPr>
+          <p:nvPr>
+            <p:ph type="body" idx="3" sz="quarter"/>
+          </p:nvPr>
+        </p:nvSpPr>
+        <p:spPr/>
+        <p:txBody>
+          <a:bodyPr/>
+          <a:lstStyle/>
+          <a:p>
+            <a:r>
+              <a:t>样本从100位作者帖子出发，根评论天然指向帖主，会形成中心。互惠率按有反向边的有向边占比，不按权重；两个网络节点集合不同，不能解释为行为下降。</a:t>
             </a:r>
           </a:p>
         </p:txBody>
@@ -1077,7 +1294,287 @@
           <a:lstStyle/>
           <a:p>
             <a:r>
-              <a:t>用三个问题串联描述、解释与建议。强调研究观察统计关联，不能回答改写文案是否会因果提高点赞。</a:t>
+              <a:t>用四个问题串联描述、解释与建议。强调研究观察统计关联，不能回答改写文案是否会因果提高点赞。</a:t>
+            </a:r>
+          </a:p>
+        </p:txBody>
+      </p:sp>
+      <p:sp>
+        <p:nvSpPr>
+          <p:cNvPr id="4" name="Slide Number Placeholder 3"/>
+          <p:cNvSpPr>
+            <a:spLocks noGrp="1"/>
+          </p:cNvSpPr>
+          <p:nvPr>
+            <p:ph type="sldNum" idx="5" sz="quarter"/>
+          </p:nvPr>
+        </p:nvSpPr>
+        <p:spPr/>
+      </p:sp>
+    </p:spTree>
+  </p:cSld>
+  <p:clrMapOvr>
+    <a:masterClrMapping/>
+  </p:clrMapOvr>
+</p:notes>
+</file>
+
+<file path=ppt/notesSlides/notesSlide20.xml><?xml version="1.0" encoding="utf-8"?>
+<p:notes xmlns:a="http://schemas.openxmlformats.org/drawingml/2006/main" xmlns:p="http://schemas.openxmlformats.org/presentationml/2006/main" xmlns:r="http://schemas.openxmlformats.org/officeDocument/2006/relationships">
+  <p:cSld>
+    <p:spTree>
+      <p:nvGrpSpPr>
+        <p:cNvPr id="1" name=""/>
+        <p:cNvGrpSpPr/>
+        <p:nvPr/>
+      </p:nvGrpSpPr>
+      <p:grpSpPr>
+        <a:xfrm>
+          <a:off x="0" y="0"/>
+          <a:ext cx="0" cy="0"/>
+          <a:chOff x="0" y="0"/>
+          <a:chExt cx="0" cy="0"/>
+        </a:xfrm>
+      </p:grpSpPr>
+      <p:sp>
+        <p:nvSpPr>
+          <p:cNvPr id="2" name="Slide Image Placeholder 1"/>
+          <p:cNvSpPr>
+            <a:spLocks noGrp="1"/>
+          </p:cNvSpPr>
+          <p:nvPr>
+            <p:ph type="sldImg" idx="2"/>
+          </p:nvPr>
+        </p:nvSpPr>
+        <p:spPr/>
+      </p:sp>
+      <p:sp>
+        <p:nvSpPr>
+          <p:cNvPr id="3" name="Notes Placeholder 2"/>
+          <p:cNvSpPr>
+            <a:spLocks noGrp="1"/>
+          </p:cNvSpPr>
+          <p:nvPr>
+            <p:ph type="body" idx="3" sz="quarter"/>
+          </p:nvPr>
+        </p:nvSpPr>
+        <p:spPr/>
+        <p:txBody>
+          <a:bodyPr/>
+          <a:lstStyle/>
+          <a:p>
+            <a:r>
+              <a:t>比例都以已采集记录为条件。首次帖主回应的中位时延2.05小时仅在观测到回应的线程中计算，未见回应不等于没有回应。</a:t>
+            </a:r>
+          </a:p>
+        </p:txBody>
+      </p:sp>
+      <p:sp>
+        <p:nvSpPr>
+          <p:cNvPr id="4" name="Slide Number Placeholder 3"/>
+          <p:cNvSpPr>
+            <a:spLocks noGrp="1"/>
+          </p:cNvSpPr>
+          <p:nvPr>
+            <p:ph type="sldNum" idx="5" sz="quarter"/>
+          </p:nvPr>
+        </p:nvSpPr>
+        <p:spPr/>
+      </p:sp>
+    </p:spTree>
+  </p:cSld>
+  <p:clrMapOvr>
+    <a:masterClrMapping/>
+  </p:clrMapOvr>
+</p:notes>
+</file>
+
+<file path=ppt/notesSlides/notesSlide21.xml><?xml version="1.0" encoding="utf-8"?>
+<p:notes xmlns:a="http://schemas.openxmlformats.org/drawingml/2006/main" xmlns:p="http://schemas.openxmlformats.org/presentationml/2006/main" xmlns:r="http://schemas.openxmlformats.org/officeDocument/2006/relationships">
+  <p:cSld>
+    <p:spTree>
+      <p:nvGrpSpPr>
+        <p:cNvPr id="1" name=""/>
+        <p:cNvGrpSpPr/>
+        <p:nvPr/>
+      </p:nvGrpSpPr>
+      <p:grpSpPr>
+        <a:xfrm>
+          <a:off x="0" y="0"/>
+          <a:ext cx="0" cy="0"/>
+          <a:chOff x="0" y="0"/>
+          <a:chExt cx="0" cy="0"/>
+        </a:xfrm>
+      </p:grpSpPr>
+      <p:sp>
+        <p:nvSpPr>
+          <p:cNvPr id="2" name="Slide Image Placeholder 1"/>
+          <p:cNvSpPr>
+            <a:spLocks noGrp="1"/>
+          </p:cNvSpPr>
+          <p:nvPr>
+            <p:ph type="sldImg" idx="2"/>
+          </p:nvPr>
+        </p:nvSpPr>
+        <p:spPr/>
+      </p:sp>
+      <p:sp>
+        <p:nvSpPr>
+          <p:cNvPr id="3" name="Notes Placeholder 2"/>
+          <p:cNvSpPr>
+            <a:spLocks noGrp="1"/>
+          </p:cNvSpPr>
+          <p:nvPr>
+            <p:ph type="body" idx="3" sz="quarter"/>
+          </p:nvPr>
+        </p:nvSpPr>
+        <p:spPr/>
+        <p:txBody>
+          <a:bodyPr/>
+          <a:lstStyle/>
+          <a:p>
+            <a:r>
+              <a:t>提出用户层面随机分组，避免同作者跨组污染；三组可为过程记录提示、面向伙伴问题提示和常规发布，固定7天，样本量先做试点再计算。不宣称已发现提升方案。</a:t>
+            </a:r>
+          </a:p>
+        </p:txBody>
+      </p:sp>
+      <p:sp>
+        <p:nvSpPr>
+          <p:cNvPr id="4" name="Slide Number Placeholder 3"/>
+          <p:cNvSpPr>
+            <a:spLocks noGrp="1"/>
+          </p:cNvSpPr>
+          <p:nvPr>
+            <p:ph type="sldNum" idx="5" sz="quarter"/>
+          </p:nvPr>
+        </p:nvSpPr>
+        <p:spPr/>
+      </p:sp>
+    </p:spTree>
+  </p:cSld>
+  <p:clrMapOvr>
+    <a:masterClrMapping/>
+  </p:clrMapOvr>
+</p:notes>
+</file>
+
+<file path=ppt/notesSlides/notesSlide22.xml><?xml version="1.0" encoding="utf-8"?>
+<p:notes xmlns:a="http://schemas.openxmlformats.org/drawingml/2006/main" xmlns:p="http://schemas.openxmlformats.org/presentationml/2006/main" xmlns:r="http://schemas.openxmlformats.org/officeDocument/2006/relationships">
+  <p:cSld>
+    <p:spTree>
+      <p:nvGrpSpPr>
+        <p:cNvPr id="1" name=""/>
+        <p:cNvGrpSpPr/>
+        <p:nvPr/>
+      </p:nvGrpSpPr>
+      <p:grpSpPr>
+        <a:xfrm>
+          <a:off x="0" y="0"/>
+          <a:ext cx="0" cy="0"/>
+          <a:chOff x="0" y="0"/>
+          <a:chExt cx="0" cy="0"/>
+        </a:xfrm>
+      </p:grpSpPr>
+      <p:sp>
+        <p:nvSpPr>
+          <p:cNvPr id="2" name="Slide Image Placeholder 1"/>
+          <p:cNvSpPr>
+            <a:spLocks noGrp="1"/>
+          </p:cNvSpPr>
+          <p:nvPr>
+            <p:ph type="sldImg" idx="2"/>
+          </p:nvPr>
+        </p:nvSpPr>
+        <p:spPr/>
+      </p:sp>
+      <p:sp>
+        <p:nvSpPr>
+          <p:cNvPr id="3" name="Notes Placeholder 2"/>
+          <p:cNvSpPr>
+            <a:spLocks noGrp="1"/>
+          </p:cNvSpPr>
+          <p:nvPr>
+            <p:ph type="body" idx="3" sz="quarter"/>
+          </p:nvPr>
+        </p:nvSpPr>
+        <p:spPr/>
+        <p:txBody>
+          <a:bodyPr/>
+          <a:lstStyle/>
+          <a:p>
+            <a:r>
+              <a:t>回到四个研究问题，概括内容分布、条件关联、预测增量和互动结构的结果。扩展分析为探索性工作，完整参数及输出见附带Notebook与代码。</a:t>
+            </a:r>
+          </a:p>
+        </p:txBody>
+      </p:sp>
+      <p:sp>
+        <p:nvSpPr>
+          <p:cNvPr id="4" name="Slide Number Placeholder 3"/>
+          <p:cNvSpPr>
+            <a:spLocks noGrp="1"/>
+          </p:cNvSpPr>
+          <p:nvPr>
+            <p:ph type="sldNum" idx="5" sz="quarter"/>
+          </p:nvPr>
+        </p:nvSpPr>
+        <p:spPr/>
+      </p:sp>
+    </p:spTree>
+  </p:cSld>
+  <p:clrMapOvr>
+    <a:masterClrMapping/>
+  </p:clrMapOvr>
+</p:notes>
+</file>
+
+<file path=ppt/notesSlides/notesSlide23.xml><?xml version="1.0" encoding="utf-8"?>
+<p:notes xmlns:a="http://schemas.openxmlformats.org/drawingml/2006/main" xmlns:p="http://schemas.openxmlformats.org/presentationml/2006/main" xmlns:r="http://schemas.openxmlformats.org/officeDocument/2006/relationships">
+  <p:cSld>
+    <p:spTree>
+      <p:nvGrpSpPr>
+        <p:cNvPr id="1" name=""/>
+        <p:cNvGrpSpPr/>
+        <p:nvPr/>
+      </p:nvGrpSpPr>
+      <p:grpSpPr>
+        <a:xfrm>
+          <a:off x="0" y="0"/>
+          <a:ext cx="0" cy="0"/>
+          <a:chOff x="0" y="0"/>
+          <a:chExt cx="0" cy="0"/>
+        </a:xfrm>
+      </p:grpSpPr>
+      <p:sp>
+        <p:nvSpPr>
+          <p:cNvPr id="2" name="Slide Image Placeholder 1"/>
+          <p:cNvSpPr>
+            <a:spLocks noGrp="1"/>
+          </p:cNvSpPr>
+          <p:nvPr>
+            <p:ph type="sldImg" idx="2"/>
+          </p:nvPr>
+        </p:nvSpPr>
+        <p:spPr/>
+      </p:sp>
+      <p:sp>
+        <p:nvSpPr>
+          <p:cNvPr id="3" name="Notes Placeholder 2"/>
+          <p:cNvSpPr>
+            <a:spLocks noGrp="1"/>
+          </p:cNvSpPr>
+          <p:nvPr>
+            <p:ph type="body" idx="3" sz="quarter"/>
+          </p:nvPr>
+        </p:nvSpPr>
+        <p:spPr/>
+        <p:txBody>
+          <a:bodyPr/>
+          <a:lstStyle/>
+          <a:p>
+            <a:r>
+              <a:t>感谢听众并进入讨论。每名组员应汇报自己实际负责的内容。请在提交前替换姓名、组号与学号，并修改为真实贡献。互评需每人独立据实完成，模板不代表完成记录。</a:t>
             </a:r>
           </a:p>
         </p:txBody>
@@ -1287,7 +1784,7 @@
           <a:lstStyle/>
           <a:p>
             <a:r>
-              <a:t>先解释对数图横轴。作者发帖中位数66条，最多783条，同一作者帖子不独立，后续聚类标准误对应100位作者。</a:t>
+              <a:t>说明正文缺失不是均匀分布现象。记录生成方式和采集逻辑可能参与其中，无法凭这些字段认定缺失原因。</a:t>
             </a:r>
           </a:p>
         </p:txBody>
@@ -1357,7 +1854,7 @@
           <a:lstStyle/>
           <a:p>
             <a:r>
-              <a:t>用夜跑打卡生成self_discipline=1的例子说明非结构化到结构化过程。补充has_text、has_tag、表情和课程标记控制。词典拟合前固定，但没有事前注册。</a:t>
+              <a:t>先解释对数图横轴。作者发帖中位数66条，最多783条，同一作者帖子不独立，后续聚类标准误对应100位作者。</a:t>
             </a:r>
           </a:p>
         </p:txBody>
@@ -1427,7 +1924,7 @@
           <a:lstStyle/>
           <a:p>
             <a:r>
-              <a:t>解释有正文的5548帖与所有9532帖两个分母。社交词和问号分别仅42和32位作者提供内部变化，区间会较宽。</a:t>
+              <a:t>用夜跑打卡生成self_discipline=1的例子说明非结构化到结构化过程。补充has_text、has_tag、表情和课程标记控制。词典拟合前固定，但没有事前注册。</a:t>
             </a:r>
           </a:p>
         </p:txBody>
@@ -1497,7 +1994,7 @@
           <a:lstStyle/>
           <a:p>
             <a:r>
-              <a:t>解释同一作者发帖比较。没有曝光、粉丝与统一采集时间，固定效应没有消除全部混杂。若被问到公式，请对应报告第09节。</a:t>
+              <a:t>解释有正文的5548帖与所有9532帖两个分母。社交词和问号分别仅42和32位作者提供内部变化，区间会较宽。</a:t>
             </a:r>
           </a:p>
         </p:txBody>
@@ -1567,7 +2064,7 @@
           <a:lstStyle/>
           <a:p>
             <a:r>
-              <a:t>图中误差线是原始95%聚类置信区间，未做多重检验调整。积极表达虽然区间未跨0，经过五项检验校正后证据不足。不要把模型总R²约0.688都归因于文本。</a:t>
+              <a:t>主题根据不含点赞数的词项和例文命名。主导类别互斥，软权重可以混合。静蹲主题最大作者占91.8%，骑行主题68.2%。</a:t>
             </a:r>
           </a:p>
         </p:txBody>
@@ -4950,35 +5447,119 @@
                 <a:latin typeface="Microsoft YaHei"/>
                 <a:ea typeface="Microsoft YaHei"/>
               </a:rPr>
-              <a:t>稳健性：结论依赖尺度与规格</a:t>
-            </a:r>
-          </a:p>
-        </p:txBody>
-      </p:sp>
-      <p:pic>
-        <p:nvPicPr>
-          <p:cNvPr id="4" name="Picture 3" descr="05_robustness.png"/>
-          <p:cNvPicPr>
-            <a:picLocks noChangeAspect="1"/>
-          </p:cNvPicPr>
+              <a:t>主题回归仍未提供明确的增量证据</a:t>
+            </a:r>
+          </a:p>
+        </p:txBody>
+      </p:sp>
+      <p:sp>
+        <p:nvSpPr>
+          <p:cNvPr id="4" name="TextBox 3"/>
+          <p:cNvSpPr txBox="1"/>
           <p:nvPr/>
-        </p:nvPicPr>
-        <p:blipFill>
-          <a:blip r:embed="rId2"/>
-          <a:stretch>
-            <a:fillRect/>
-          </a:stretch>
-        </p:blipFill>
-        <p:spPr>
-          <a:xfrm>
-            <a:off x="480060" y="2716421"/>
-            <a:ext cx="7452360" cy="2293837"/>
-          </a:xfrm>
-          <a:prstGeom prst="rect">
-            <a:avLst/>
-          </a:prstGeom>
-        </p:spPr>
-      </p:pic>
+        </p:nvSpPr>
+        <p:spPr>
+          <a:xfrm>
+            <a:off x="731520" y="1874519"/>
+            <a:ext cx="10698480" cy="4297680"/>
+          </a:xfrm>
+          <a:prstGeom prst="rect">
+            <a:avLst/>
+          </a:prstGeom>
+          <a:noFill/>
+        </p:spPr>
+        <p:txBody>
+          <a:bodyPr wrap="square" lIns="0" rIns="0" tIns="0" bIns="0">
+            <a:spAutoFit/>
+          </a:bodyPr>
+          <a:lstStyle/>
+          <a:p>
+            <a:pPr>
+              <a:spcAft>
+                <a:spcPts val="900"/>
+              </a:spcAft>
+            </a:pPr>
+            <a:r>
+              <a:rPr sz="2400" b="0">
+                <a:solidFill>
+                  <a:srgbClr val="213444"/>
+                </a:solidFill>
+                <a:latin typeface="Microsoft YaHei"/>
+                <a:ea typeface="Microsoft YaHei"/>
+              </a:rPr>
+              <a:t>以“运动与训练交流”为基准，加入4个主题权重。</a:t>
+            </a:r>
+          </a:p>
+          <a:p>
+            <a:pPr>
+              <a:spcAft>
+                <a:spcPts val="900"/>
+              </a:spcAft>
+            </a:pPr>
+            <a:r>
+              <a:rPr sz="2400" b="0">
+                <a:solidFill>
+                  <a:srgbClr val="213444"/>
+                </a:solidFill>
+                <a:latin typeface="Microsoft YaHei"/>
+                <a:ea typeface="Microsoft YaHei"/>
+              </a:rPr>
+              <a:t/>
+            </a:r>
+          </a:p>
+          <a:p>
+            <a:pPr>
+              <a:spcAft>
+                <a:spcPts val="900"/>
+              </a:spcAft>
+            </a:pPr>
+            <a:r>
+              <a:rPr sz="2400" b="0">
+                <a:solidFill>
+                  <a:srgbClr val="213444"/>
+                </a:solidFill>
+                <a:latin typeface="Microsoft YaHei"/>
+                <a:ea typeface="Microsoft YaHei"/>
+              </a:rPr>
+              <a:t>联合检验p=0.166；4项BH校正后均未达到5%显著性水平。</a:t>
+            </a:r>
+          </a:p>
+          <a:p>
+            <a:pPr>
+              <a:spcAft>
+                <a:spcPts val="900"/>
+              </a:spcAft>
+            </a:pPr>
+            <a:r>
+              <a:rPr sz="2400" b="0">
+                <a:solidFill>
+                  <a:srgbClr val="213444"/>
+                </a:solidFill>
+                <a:latin typeface="Microsoft YaHei"/>
+                <a:ea typeface="Microsoft YaHei"/>
+              </a:rPr>
+              <a:t/>
+            </a:r>
+          </a:p>
+          <a:p>
+            <a:pPr>
+              <a:spcAft>
+                <a:spcPts val="900"/>
+              </a:spcAft>
+            </a:pPr>
+            <a:r>
+              <a:rPr sz="2400" b="0">
+                <a:solidFill>
+                  <a:srgbClr val="213444"/>
+                </a:solidFill>
+                <a:latin typeface="Microsoft YaHei"/>
+                <a:ea typeface="Microsoft YaHei"/>
+              </a:rPr>
+              <a:t>初始化关键词稳定，但不能代替抽样稳定性和测量效度。</a:t>
+            </a:r>
+          </a:p>
+        </p:txBody>
+      </p:sp>
       <p:sp>
         <p:nvSpPr>
           <p:cNvPr id="5" name="TextBox 4"/>
@@ -4987,8 +5568,8 @@
         </p:nvSpPr>
         <p:spPr>
           <a:xfrm>
-            <a:off x="8229600" y="1828800"/>
-            <a:ext cx="3383280" cy="4297680"/>
+            <a:off x="502920" y="6419088"/>
+            <a:ext cx="10789920" cy="228600"/>
           </a:xfrm>
           <a:prstGeom prst="rect">
             <a:avLst/>
@@ -5007,82 +5588,14 @@
               </a:spcAft>
             </a:pPr>
             <a:r>
-              <a:rPr sz="1900" b="0">
-                <a:solidFill>
-                  <a:srgbClr val="213444"/>
-                </a:solidFill>
-                <a:latin typeface="Microsoft YaHei"/>
-                <a:ea typeface="Microsoft YaHei"/>
-              </a:rPr>
-              <a:t>检查仅可见正文、去最高1%点赞、作者等权、PPML计数模型。</a:t>
-            </a:r>
-          </a:p>
-          <a:p>
-            <a:pPr>
-              <a:spcAft>
-                <a:spcPts val="900"/>
-              </a:spcAft>
-            </a:pPr>
-            <a:r>
-              <a:rPr sz="1900" b="0">
-                <a:solidFill>
-                  <a:srgbClr val="213444"/>
-                </a:solidFill>
-                <a:latin typeface="Microsoft YaHei"/>
-                <a:ea typeface="Microsoft YaHei"/>
-              </a:rPr>
-              <a:t/>
-            </a:r>
-          </a:p>
-          <a:p>
-            <a:pPr>
-              <a:spcAft>
-                <a:spcPts val="900"/>
-              </a:spcAft>
-            </a:pPr>
-            <a:r>
-              <a:rPr sz="1900" b="0">
-                <a:solidFill>
-                  <a:srgbClr val="213444"/>
-                </a:solidFill>
-                <a:latin typeface="Microsoft YaHei"/>
-                <a:ea typeface="Microsoft YaHei"/>
-              </a:rPr>
-              <a:t>积极表达词的PPML区间包含0，原始p=0.103。</a:t>
-            </a:r>
-          </a:p>
-          <a:p>
-            <a:pPr>
-              <a:spcAft>
-                <a:spcPts val="900"/>
-              </a:spcAft>
-            </a:pPr>
-            <a:r>
-              <a:rPr sz="1900" b="0">
-                <a:solidFill>
-                  <a:srgbClr val="213444"/>
-                </a:solidFill>
-                <a:latin typeface="Microsoft YaHei"/>
-                <a:ea typeface="Microsoft YaHei"/>
-              </a:rPr>
-              <a:t/>
-            </a:r>
-          </a:p>
-          <a:p>
-            <a:pPr>
-              <a:spcAft>
-                <a:spcPts val="900"/>
-              </a:spcAft>
-            </a:pPr>
-            <a:r>
-              <a:rPr sz="1900" b="0">
-                <a:solidFill>
-                  <a:srgbClr val="213444"/>
-                </a:solidFill>
-                <a:latin typeface="Microsoft YaHei"/>
-                <a:ea typeface="Microsoft YaHei"/>
-              </a:rPr>
-              <a:t>OLS与PPML的估计量不同；不能以某个规格显著就宣称稳健。</a:t>
+              <a:rPr sz="1000" b="0">
+                <a:solidFill>
+                  <a:srgbClr val="71818B"/>
+                </a:solidFill>
+                <a:latin typeface="Microsoft YaHei"/>
+                <a:ea typeface="Microsoft YaHei"/>
+              </a:rPr>
+              <a:t>Keep课程样本；观察性分析。全部数值与口径见分析报告及附带结果。</a:t>
             </a:r>
           </a:p>
         </p:txBody>
@@ -5090,46 +5603,6 @@
       <p:sp>
         <p:nvSpPr>
           <p:cNvPr id="6" name="TextBox 5"/>
-          <p:cNvSpPr txBox="1"/>
-          <p:nvPr/>
-        </p:nvSpPr>
-        <p:spPr>
-          <a:xfrm>
-            <a:off x="502920" y="6419088"/>
-            <a:ext cx="10789920" cy="228600"/>
-          </a:xfrm>
-          <a:prstGeom prst="rect">
-            <a:avLst/>
-          </a:prstGeom>
-          <a:noFill/>
-        </p:spPr>
-        <p:txBody>
-          <a:bodyPr wrap="square" lIns="0" rIns="0" tIns="0" bIns="0">
-            <a:spAutoFit/>
-          </a:bodyPr>
-          <a:lstStyle/>
-          <a:p>
-            <a:pPr>
-              <a:spcAft>
-                <a:spcPts val="900"/>
-              </a:spcAft>
-            </a:pPr>
-            <a:r>
-              <a:rPr sz="1000" b="0">
-                <a:solidFill>
-                  <a:srgbClr val="71818B"/>
-                </a:solidFill>
-                <a:latin typeface="Microsoft YaHei"/>
-                <a:ea typeface="Microsoft YaHei"/>
-              </a:rPr>
-              <a:t>Keep课程样本；观察性分析。全部数值与口径见分析报告及附带结果。</a:t>
-            </a:r>
-          </a:p>
-        </p:txBody>
-      </p:sp>
-      <p:sp>
-        <p:nvSpPr>
-          <p:cNvPr id="7" name="TextBox 6"/>
           <p:cNvSpPr txBox="1"/>
           <p:nvPr/>
         </p:nvSpPr>
@@ -5268,7 +5741,7 @@
                 <a:latin typeface="Microsoft YaHei"/>
                 <a:ea typeface="Microsoft YaHei"/>
               </a:rPr>
-              <a:t>词典测量也需要接受检查</a:t>
+              <a:t>主模型：控制作者和日期</a:t>
             </a:r>
           </a:p>
         </p:txBody>
@@ -5301,24 +5774,24 @@
               </a:spcAft>
             </a:pPr>
             <a:r>
-              <a:rPr sz="2400" b="0">
-                <a:solidFill>
-                  <a:srgbClr val="213444"/>
-                </a:solidFill>
-                <a:latin typeface="Microsoft YaHei"/>
-                <a:ea typeface="Microsoft YaHei"/>
-              </a:rPr>
-              <a:t>40个帖子—特征检查单元：按规则命中分层抽样，无点赞展示。</a:t>
-            </a:r>
-          </a:p>
-          <a:p>
-            <a:pPr>
-              <a:spcAft>
-                <a:spcPts val="900"/>
-              </a:spcAft>
-            </a:pPr>
-            <a:r>
-              <a:rPr sz="2400" b="0">
+              <a:rPr sz="2100" b="0">
+                <a:solidFill>
+                  <a:srgbClr val="213444"/>
+                </a:solidFill>
+                <a:latin typeface="Microsoft YaHei"/>
+                <a:ea typeface="Microsoft YaHei"/>
+              </a:rPr>
+              <a:t>因变量 ln(1+likes)；全部9,532帖，100位作者。</a:t>
+            </a:r>
+          </a:p>
+          <a:p>
+            <a:pPr>
+              <a:spcAft>
+                <a:spcPts val="900"/>
+              </a:spcAft>
+            </a:pPr>
+            <a:r>
+              <a:rPr sz="2100" b="0">
                 <a:solidFill>
                   <a:srgbClr val="213444"/>
                 </a:solidFill>
@@ -5335,24 +5808,24 @@
               </a:spcAft>
             </a:pPr>
             <a:r>
-              <a:rPr sz="2400" b="0">
-                <a:solidFill>
-                  <a:srgbClr val="213444"/>
-                </a:solidFill>
-                <a:latin typeface="Microsoft YaHei"/>
-                <a:ea typeface="Microsoft YaHei"/>
-              </a:rPr>
-              <a:t>“完成”可能指绘画；“一起”可能描述线下朋友；问号可能是反问。</a:t>
-            </a:r>
-          </a:p>
-          <a:p>
-            <a:pPr>
-              <a:spcAft>
-                <a:spcPts val="900"/>
-              </a:spcAft>
-            </a:pPr>
-            <a:r>
-              <a:rPr sz="2400" b="0">
+              <a:rPr sz="2100" b="0">
+                <a:solidFill>
+                  <a:srgbClr val="213444"/>
+                </a:solidFill>
+                <a:latin typeface="Microsoft YaHei"/>
+                <a:ea typeface="Microsoft YaHei"/>
+              </a:rPr>
+              <a:t>作者固定效应 + 日期固定效应 + 内容形式/类型/时段及文本标记。</a:t>
+            </a:r>
+          </a:p>
+          <a:p>
+            <a:pPr>
+              <a:spcAft>
+                <a:spcPts val="900"/>
+              </a:spcAft>
+            </a:pPr>
+            <a:r>
+              <a:rPr sz="2100" b="0">
                 <a:solidFill>
                   <a:srgbClr val="213444"/>
                 </a:solidFill>
@@ -5369,14 +5842,48 @@
               </a:spcAft>
             </a:pPr>
             <a:r>
-              <a:rPr sz="2400" b="0">
-                <a:solidFill>
-                  <a:srgbClr val="213444"/>
-                </a:solidFill>
-                <a:latin typeface="Microsoft YaHei"/>
-                <a:ea typeface="Microsoft YaHei"/>
-              </a:rPr>
-              <a:t>Codex辅助抽查，未做独立人工双编码；不宣称准确率。</a:t>
+              <a:rPr sz="2100" b="0">
+                <a:solidFill>
+                  <a:srgbClr val="213444"/>
+                </a:solidFill>
+                <a:latin typeface="Microsoft YaHei"/>
+                <a:ea typeface="Microsoft YaHei"/>
+              </a:rPr>
+              <a:t>作者聚类CR1标准误；t分布df=99；五项核心检验BH校正。</a:t>
+            </a:r>
+          </a:p>
+          <a:p>
+            <a:pPr>
+              <a:spcAft>
+                <a:spcPts val="900"/>
+              </a:spcAft>
+            </a:pPr>
+            <a:r>
+              <a:rPr sz="2100" b="0">
+                <a:solidFill>
+                  <a:srgbClr val="213444"/>
+                </a:solidFill>
+                <a:latin typeface="Microsoft YaHei"/>
+                <a:ea typeface="Microsoft YaHei"/>
+              </a:rPr>
+              <a:t/>
+            </a:r>
+          </a:p>
+          <a:p>
+            <a:pPr>
+              <a:spcAft>
+                <a:spcPts val="900"/>
+              </a:spcAft>
+            </a:pPr>
+            <a:r>
+              <a:rPr sz="2100" b="0">
+                <a:solidFill>
+                  <a:srgbClr val="213444"/>
+                </a:solidFill>
+                <a:latin typeface="Microsoft YaHei"/>
+                <a:ea typeface="Microsoft YaHei"/>
+              </a:rPr>
+              <a:t>作者内不变的性别、会员、等级等由作者固定效应吸收。</a:t>
             </a:r>
           </a:p>
         </p:txBody>
@@ -5562,14 +6069,14 @@
                 <a:latin typeface="Microsoft YaHei"/>
                 <a:ea typeface="Microsoft YaHei"/>
               </a:rPr>
-              <a:t>评论网络：明确每条边的指向</a:t>
+              <a:t>主结果：核心文本特征的关联证据有限</a:t>
             </a:r>
           </a:p>
         </p:txBody>
       </p:sp>
       <p:pic>
         <p:nvPicPr>
-          <p:cNvPr id="4" name="Picture 3" descr="06_comment_network.png"/>
+          <p:cNvPr id="4" name="Picture 3" descr="04_main_coefficients.png"/>
           <p:cNvPicPr>
             <a:picLocks noChangeAspect="1"/>
           </p:cNvPicPr>
@@ -5583,8 +6090,8 @@
         </p:blipFill>
         <p:spPr>
           <a:xfrm>
-            <a:off x="578279" y="1851660"/>
-            <a:ext cx="7255921" cy="4023360"/>
+            <a:off x="480060" y="2397089"/>
+            <a:ext cx="7452360" cy="2932501"/>
           </a:xfrm>
           <a:prstGeom prst="rect">
             <a:avLst/>
@@ -5626,7 +6133,7 @@
                 <a:latin typeface="Microsoft YaHei"/>
                 <a:ea typeface="Microsoft YaHei"/>
               </a:rPr>
-              <a:t>根评论：评论者→帖主；明确回复：回复者→replyUserId。</a:t>
+              <a:t>五项核心特征联合检验p=0.130；新增R²仅0.065个百分点。</a:t>
             </a:r>
           </a:p>
           <a:p>
@@ -5660,7 +6167,7 @@
                 <a:latin typeface="Microsoft YaHei"/>
                 <a:ea typeface="Microsoft YaHei"/>
               </a:rPr>
-              <a:t>去重后移除84次自我互动；11,511事件合并为4,069条边。</a:t>
+              <a:t>积极表达词β=-0.086；原始p=0.016，BH q=0.079。</a:t>
             </a:r>
           </a:p>
           <a:p>
@@ -5694,7 +6201,7 @@
                 <a:latin typeface="Microsoft YaHei"/>
                 <a:ea typeface="Microsoft YaHei"/>
               </a:rPr>
-              <a:t>2,932个有边节点；箭头在图中省略，原数据保持有向。</a:t>
+              <a:t>不显著不是证明无作用；现有测量下证据不足。</a:t>
             </a:r>
           </a:p>
         </p:txBody>
@@ -5880,14 +6387,14 @@
                 <a:latin typeface="Microsoft YaHei"/>
                 <a:ea typeface="Microsoft YaHei"/>
               </a:rPr>
-              <a:t>互动集中，但样本边界影响很大</a:t>
+              <a:t>稳健性：结论依赖尺度与规格</a:t>
             </a:r>
           </a:p>
         </p:txBody>
       </p:sp>
       <p:pic>
         <p:nvPicPr>
-          <p:cNvPr id="4" name="Picture 3" descr="07_network_concentration.png"/>
+          <p:cNvPr id="4" name="Picture 3" descr="05_robustness.png"/>
           <p:cNvPicPr>
             <a:picLocks noChangeAspect="1"/>
           </p:cNvPicPr>
@@ -5901,8 +6408,8 @@
         </p:blipFill>
         <p:spPr>
           <a:xfrm>
-            <a:off x="480060" y="2614975"/>
-            <a:ext cx="7452360" cy="2496729"/>
+            <a:off x="480060" y="2716421"/>
+            <a:ext cx="7452360" cy="2293837"/>
           </a:xfrm>
           <a:prstGeom prst="rect">
             <a:avLst/>
@@ -5944,7 +6451,7 @@
                 <a:latin typeface="Microsoft YaHei"/>
                 <a:ea typeface="Microsoft YaHei"/>
               </a:rPr>
-              <a:t>前10位接收者获得54.0%互动；第一位12.0%。</a:t>
+              <a:t>检查仅可见正文、去最高1%点赞、作者等权、PPML计数模型。</a:t>
             </a:r>
           </a:p>
           <a:p>
@@ -5978,7 +6485,7 @@
                 <a:latin typeface="Microsoft YaHei"/>
                 <a:ea typeface="Microsoft YaHei"/>
               </a:rPr>
-              <a:t>整体互惠率49.6%；仅明确回复子网络29.9%。</a:t>
+              <a:t>积极表达词的PPML区间包含0，原始p=0.103。</a:t>
             </a:r>
           </a:p>
           <a:p>
@@ -6012,7 +6519,7 @@
                 <a:latin typeface="Microsoft YaHei"/>
                 <a:ea typeface="Microsoft YaHei"/>
               </a:rPr>
-              <a:t>这是采集网络的接收事件数，不是平台影响力或独立粉丝数。</a:t>
+              <a:t>OLS与PPML的估计量不同；不能以某个规格显著就宣称稳健。</a:t>
             </a:r>
           </a:p>
         </p:txBody>
@@ -6198,21 +6705,45 @@
                 <a:latin typeface="Microsoft YaHei"/>
                 <a:ea typeface="Microsoft YaHei"/>
               </a:rPr>
-              <a:t>建议：把表达方案交给对照实验</a:t>
-            </a:r>
-          </a:p>
-        </p:txBody>
-      </p:sp>
-      <p:sp>
-        <p:nvSpPr>
-          <p:cNvPr id="4" name="TextBox 3"/>
+              <a:t>逐作者剔除：点估计与统计证据分开判断</a:t>
+            </a:r>
+          </a:p>
+        </p:txBody>
+      </p:sp>
+      <p:pic>
+        <p:nvPicPr>
+          <p:cNvPr id="4" name="Picture 3" descr="12_author_influence.png"/>
+          <p:cNvPicPr>
+            <a:picLocks noChangeAspect="1"/>
+          </p:cNvPicPr>
+          <p:nvPr/>
+        </p:nvPicPr>
+        <p:blipFill>
+          <a:blip r:embed="rId2"/>
+          <a:stretch>
+            <a:fillRect/>
+          </a:stretch>
+        </p:blipFill>
+        <p:spPr>
+          <a:xfrm>
+            <a:off x="480060" y="2456960"/>
+            <a:ext cx="7452360" cy="2812758"/>
+          </a:xfrm>
+          <a:prstGeom prst="rect">
+            <a:avLst/>
+          </a:prstGeom>
+        </p:spPr>
+      </p:pic>
+      <p:sp>
+        <p:nvSpPr>
+          <p:cNvPr id="5" name="TextBox 4"/>
           <p:cNvSpPr txBox="1"/>
           <p:nvPr/>
         </p:nvSpPr>
         <p:spPr>
           <a:xfrm>
-            <a:off x="731520" y="1874519"/>
-            <a:ext cx="10698480" cy="4297680"/>
+            <a:off x="8229600" y="1828800"/>
+            <a:ext cx="3383280" cy="4297680"/>
           </a:xfrm>
           <a:prstGeom prst="rect">
             <a:avLst/>
@@ -6231,24 +6762,24 @@
               </a:spcAft>
             </a:pPr>
             <a:r>
-              <a:rPr sz="2100" b="0">
-                <a:solidFill>
-                  <a:srgbClr val="213444"/>
-                </a:solidFill>
-                <a:latin typeface="Microsoft YaHei"/>
-                <a:ea typeface="Microsoft YaHei"/>
-              </a:rPr>
-              <a:t>不承诺“加某个词就会涨赞”；先保证真实、完整且易交流的内容。</a:t>
-            </a:r>
-          </a:p>
-          <a:p>
-            <a:pPr>
-              <a:spcAft>
-                <a:spcPts val="900"/>
-              </a:spcAft>
-            </a:pPr>
-            <a:r>
-              <a:rPr sz="2100" b="0">
+              <a:rPr sz="1900" b="0">
+                <a:solidFill>
+                  <a:srgbClr val="213444"/>
+                </a:solidFill>
+                <a:latin typeface="Microsoft YaHei"/>
+                <a:ea typeface="Microsoft YaHei"/>
+              </a:rPr>
+              <a:t>逐次剔除1位作者，重复100次主模型估计。</a:t>
+            </a:r>
+          </a:p>
+          <a:p>
+            <a:pPr>
+              <a:spcAft>
+                <a:spcPts val="900"/>
+              </a:spcAft>
+            </a:pPr>
+            <a:r>
+              <a:rPr sz="1900" b="0">
                 <a:solidFill>
                   <a:srgbClr val="213444"/>
                 </a:solidFill>
@@ -6265,24 +6796,24 @@
               </a:spcAft>
             </a:pPr>
             <a:r>
-              <a:rPr sz="2100" b="0">
-                <a:solidFill>
-                  <a:srgbClr val="213444"/>
-                </a:solidFill>
-                <a:latin typeface="Microsoft YaHei"/>
-                <a:ea typeface="Microsoft YaHei"/>
-              </a:rPr>
-              <a:t>固定观察窗口、记录真实曝光；按作者随机分组评估提示文案。</a:t>
-            </a:r>
-          </a:p>
-          <a:p>
-            <a:pPr>
-              <a:spcAft>
-                <a:spcPts val="900"/>
-              </a:spcAft>
-            </a:pPr>
-            <a:r>
-              <a:rPr sz="2100" b="0">
+              <a:rPr sz="1900" b="0">
+                <a:solidFill>
+                  <a:srgbClr val="213444"/>
+                </a:solidFill>
+                <a:latin typeface="Microsoft YaHei"/>
+                <a:ea typeface="Microsoft YaHei"/>
+              </a:rPr>
+              <a:t>积极表达词始终为负，范围[-0.100,-0.074]。</a:t>
+            </a:r>
+          </a:p>
+          <a:p>
+            <a:pPr>
+              <a:spcAft>
+                <a:spcPts val="900"/>
+              </a:spcAft>
+            </a:pPr>
+            <a:r>
+              <a:rPr sz="1900" b="0">
                 <a:solidFill>
                   <a:srgbClr val="213444"/>
                 </a:solidFill>
@@ -6299,55 +6830,21 @@
               </a:spcAft>
             </a:pPr>
             <a:r>
-              <a:rPr sz="2100" b="0">
-                <a:solidFill>
-                  <a:srgbClr val="213444"/>
-                </a:solidFill>
-                <a:latin typeface="Microsoft YaHei"/>
-                <a:ea typeface="Microsoft YaHei"/>
-              </a:rPr>
-              <a:t>关注低反馈用户与回复质量，同时验证抽样是否造成集中。</a:t>
-            </a:r>
-          </a:p>
-          <a:p>
-            <a:pPr>
-              <a:spcAft>
-                <a:spcPts val="900"/>
-              </a:spcAft>
-            </a:pPr>
-            <a:r>
-              <a:rPr sz="2100" b="0">
-                <a:solidFill>
-                  <a:srgbClr val="213444"/>
-                </a:solidFill>
-                <a:latin typeface="Microsoft YaHei"/>
-                <a:ea typeface="Microsoft YaHei"/>
-              </a:rPr>
-              <a:t/>
-            </a:r>
-          </a:p>
-          <a:p>
-            <a:pPr>
-              <a:spcAft>
-                <a:spcPts val="900"/>
-              </a:spcAft>
-            </a:pPr>
-            <a:r>
-              <a:rPr sz="2100" b="0">
-                <a:solidFill>
-                  <a:srgbClr val="213444"/>
-                </a:solidFill>
-                <a:latin typeface="Microsoft YaHei"/>
-                <a:ea typeface="Microsoft YaHei"/>
-              </a:rPr>
-              <a:t>未执行的实验是后续设计，不是已证实的增长方案。</a:t>
-            </a:r>
-          </a:p>
-        </p:txBody>
-      </p:sp>
-      <p:sp>
-        <p:nvSpPr>
-          <p:cNvPr id="5" name="TextBox 4"/>
+              <a:rPr sz="1900" b="0">
+                <a:solidFill>
+                  <a:srgbClr val="213444"/>
+                </a:solidFill>
+                <a:latin typeface="Microsoft YaHei"/>
+                <a:ea typeface="Microsoft YaHei"/>
+              </a:rPr>
+              <a:t>符号稳定不能替代BH校正和PPML结果；社交词在11次剔除后转正。</a:t>
+            </a:r>
+          </a:p>
+        </p:txBody>
+      </p:sp>
+      <p:sp>
+        <p:nvSpPr>
+          <p:cNvPr id="6" name="TextBox 5"/>
           <p:cNvSpPr txBox="1"/>
           <p:nvPr/>
         </p:nvSpPr>
@@ -6387,7 +6884,7 @@
       </p:sp>
       <p:sp>
         <p:nvSpPr>
-          <p:cNvPr id="6" name="TextBox 5"/>
+          <p:cNvPr id="7" name="TextBox 6"/>
           <p:cNvSpPr txBox="1"/>
           <p:nvPr/>
         </p:nvSpPr>
@@ -6526,7 +7023,7 @@
                 <a:latin typeface="Microsoft YaHei"/>
                 <a:ea typeface="Microsoft YaHei"/>
               </a:rPr>
-              <a:t>结论、局限与可复现性</a:t>
+              <a:t>预测对照：文本是否帮助样本外泛化？</a:t>
             </a:r>
           </a:p>
         </p:txBody>
@@ -6559,24 +7056,24 @@
               </a:spcAft>
             </a:pPr>
             <a:r>
-              <a:rPr sz="2100" b="0">
-                <a:solidFill>
-                  <a:srgbClr val="213444"/>
-                </a:solidFill>
-                <a:latin typeface="Microsoft YaHei"/>
-                <a:ea typeface="Microsoft YaHei"/>
-              </a:rPr>
-              <a:t>主结论：没有充分证据支持稳定的高赞词汇策略。</a:t>
-            </a:r>
-          </a:p>
-          <a:p>
-            <a:pPr>
-              <a:spcAft>
-                <a:spcPts val="900"/>
-              </a:spcAft>
-            </a:pPr>
-            <a:r>
-              <a:rPr sz="2100" b="0">
+              <a:rPr sz="2400" b="0">
+                <a:solidFill>
+                  <a:srgbClr val="213444"/>
+                </a:solidFill>
+                <a:latin typeface="Microsoft YaHei"/>
+                <a:ea typeface="Microsoft YaHei"/>
+              </a:rPr>
+              <a:t>时间留出：7,098帖训练、2,434帖测试。</a:t>
+            </a:r>
+          </a:p>
+          <a:p>
+            <a:pPr>
+              <a:spcAft>
+                <a:spcPts val="900"/>
+              </a:spcAft>
+            </a:pPr>
+            <a:r>
+              <a:rPr sz="2400" b="0">
                 <a:solidFill>
                   <a:srgbClr val="213444"/>
                 </a:solidFill>
@@ -6593,24 +7090,24 @@
               </a:spcAft>
             </a:pPr>
             <a:r>
-              <a:rPr sz="2100" b="0">
-                <a:solidFill>
-                  <a:srgbClr val="213444"/>
-                </a:solidFill>
-                <a:latin typeface="Microsoft YaHei"/>
-                <a:ea typeface="Microsoft YaHei"/>
-              </a:rPr>
-              <a:t>100位作者课程样本，抽样机制不明；正文/视觉缺失；曝光和统一采集时点未知。</a:t>
-            </a:r>
-          </a:p>
-          <a:p>
-            <a:pPr>
-              <a:spcAft>
-                <a:spcPts val="900"/>
-              </a:spcAft>
-            </a:pPr>
-            <a:r>
-              <a:rPr sz="2100" b="0">
+              <a:rPr sz="2400" b="0">
+                <a:solidFill>
+                  <a:srgbClr val="213444"/>
+                </a:solidFill>
+                <a:latin typeface="Microsoft YaHei"/>
+                <a:ea typeface="Microsoft YaHei"/>
+              </a:rPr>
+              <a:t>作者分组五折：同一作者只在一个测试折出现。</a:t>
+            </a:r>
+          </a:p>
+          <a:p>
+            <a:pPr>
+              <a:spcAft>
+                <a:spcPts val="900"/>
+              </a:spcAft>
+            </a:pPr>
+            <a:r>
+              <a:rPr sz="2400" b="0">
                 <a:solidFill>
                   <a:srgbClr val="213444"/>
                 </a:solidFill>
@@ -6627,48 +7124,14 @@
               </a:spcAft>
             </a:pPr>
             <a:r>
-              <a:rPr sz="2100" b="0">
-                <a:solidFill>
-                  <a:srgbClr val="213444"/>
-                </a:solidFill>
-                <a:latin typeface="Microsoft YaHei"/>
-                <a:ea typeface="Microsoft YaHei"/>
-              </a:rPr>
-              <a:t>代码、原始Keep数据、特征表、回归结果与已执行Notebook全部随附。</a:t>
-            </a:r>
-          </a:p>
-          <a:p>
-            <a:pPr>
-              <a:spcAft>
-                <a:spcPts val="900"/>
-              </a:spcAft>
-            </a:pPr>
-            <a:r>
-              <a:rPr sz="2100" b="0">
-                <a:solidFill>
-                  <a:srgbClr val="213444"/>
-                </a:solidFill>
-                <a:latin typeface="Microsoft YaHei"/>
-                <a:ea typeface="Microsoft YaHei"/>
-              </a:rPr>
-              <a:t/>
-            </a:r>
-          </a:p>
-          <a:p>
-            <a:pPr>
-              <a:spcAft>
-                <a:spcPts val="900"/>
-              </a:spcAft>
-            </a:pPr>
-            <a:r>
-              <a:rPr sz="2100" b="0">
-                <a:solidFill>
-                  <a:srgbClr val="213444"/>
-                </a:solidFill>
-                <a:latin typeface="Microsoft YaHei"/>
-                <a:ea typeface="Microsoft YaHei"/>
-              </a:rPr>
-              <a:t>数值独立复核；填好组号、成员后按课程要求打包提交。</a:t>
+              <a:rPr sz="2400" b="0">
+                <a:solidFill>
+                  <a:srgbClr val="213444"/>
+                </a:solidFill>
+                <a:latin typeface="Microsoft YaHei"/>
+                <a:ea typeface="Microsoft YaHei"/>
+              </a:rPr>
+              <a:t>同一划分比较均值、结构化、加词典、加字符文本；编码仅拟合训练集。</a:t>
             </a:r>
           </a:p>
         </p:txBody>
@@ -6854,7 +7317,325 @@
                 <a:latin typeface="Microsoft YaHei"/>
                 <a:ea typeface="Microsoft YaHei"/>
               </a:rPr>
-              <a:t>小组分工与讨论</a:t>
+              <a:t>两种留出评估均未显示稳定的文本增益</a:t>
+            </a:r>
+          </a:p>
+        </p:txBody>
+      </p:sp>
+      <p:pic>
+        <p:nvPicPr>
+          <p:cNvPr id="4" name="Picture 3" descr="10_prediction_comparison.png"/>
+          <p:cNvPicPr>
+            <a:picLocks noChangeAspect="1"/>
+          </p:cNvPicPr>
+          <p:nvPr/>
+        </p:nvPicPr>
+        <p:blipFill>
+          <a:blip r:embed="rId2"/>
+          <a:stretch>
+            <a:fillRect/>
+          </a:stretch>
+        </p:blipFill>
+        <p:spPr>
+          <a:xfrm>
+            <a:off x="480060" y="2616990"/>
+            <a:ext cx="7452360" cy="2492698"/>
+          </a:xfrm>
+          <a:prstGeom prst="rect">
+            <a:avLst/>
+          </a:prstGeom>
+        </p:spPr>
+      </p:pic>
+      <p:sp>
+        <p:nvSpPr>
+          <p:cNvPr id="5" name="TextBox 4"/>
+          <p:cNvSpPr txBox="1"/>
+          <p:nvPr/>
+        </p:nvSpPr>
+        <p:spPr>
+          <a:xfrm>
+            <a:off x="8229600" y="1828800"/>
+            <a:ext cx="3383280" cy="4297680"/>
+          </a:xfrm>
+          <a:prstGeom prst="rect">
+            <a:avLst/>
+          </a:prstGeom>
+          <a:noFill/>
+        </p:spPr>
+        <p:txBody>
+          <a:bodyPr wrap="square" lIns="0" rIns="0" tIns="0" bIns="0">
+            <a:spAutoFit/>
+          </a:bodyPr>
+          <a:lstStyle/>
+          <a:p>
+            <a:pPr>
+              <a:spcAft>
+                <a:spcPts val="900"/>
+              </a:spcAft>
+            </a:pPr>
+            <a:r>
+              <a:rPr sz="1900" b="0">
+                <a:solidFill>
+                  <a:srgbClr val="213444"/>
+                </a:solidFill>
+                <a:latin typeface="Microsoft YaHei"/>
+                <a:ea typeface="Microsoft YaHei"/>
+              </a:rPr>
+              <a:t>时间留出MAE：结构化0.5641，加字符文本0.5656。</a:t>
+            </a:r>
+          </a:p>
+          <a:p>
+            <a:pPr>
+              <a:spcAft>
+                <a:spcPts val="900"/>
+              </a:spcAft>
+            </a:pPr>
+            <a:r>
+              <a:rPr sz="1900" b="0">
+                <a:solidFill>
+                  <a:srgbClr val="213444"/>
+                </a:solidFill>
+                <a:latin typeface="Microsoft YaHei"/>
+                <a:ea typeface="Microsoft YaHei"/>
+              </a:rPr>
+              <a:t/>
+            </a:r>
+          </a:p>
+          <a:p>
+            <a:pPr>
+              <a:spcAft>
+                <a:spcPts val="900"/>
+              </a:spcAft>
+            </a:pPr>
+            <a:r>
+              <a:rPr sz="1900" b="0">
+                <a:solidFill>
+                  <a:srgbClr val="213444"/>
+                </a:solidFill>
+                <a:latin typeface="Microsoft YaHei"/>
+                <a:ea typeface="Microsoft YaHei"/>
+              </a:rPr>
+              <a:t>作者分组MAE：结构化0.7180，加字符文本0.7164。</a:t>
+            </a:r>
+          </a:p>
+          <a:p>
+            <a:pPr>
+              <a:spcAft>
+                <a:spcPts val="900"/>
+              </a:spcAft>
+            </a:pPr>
+            <a:r>
+              <a:rPr sz="1900" b="0">
+                <a:solidFill>
+                  <a:srgbClr val="213444"/>
+                </a:solidFill>
+                <a:latin typeface="Microsoft YaHei"/>
+                <a:ea typeface="Microsoft YaHei"/>
+              </a:rPr>
+              <a:t/>
+            </a:r>
+          </a:p>
+          <a:p>
+            <a:pPr>
+              <a:spcAft>
+                <a:spcPts val="900"/>
+              </a:spcAft>
+            </a:pPr>
+            <a:r>
+              <a:rPr sz="1900" b="0">
+                <a:solidFill>
+                  <a:srgbClr val="213444"/>
+                </a:solidFill>
+                <a:latin typeface="Microsoft YaHei"/>
+                <a:ea typeface="Microsoft YaHei"/>
+              </a:rPr>
+              <a:t>配对作者聚类区间均跨0；未见正文子集也未改变判断。</a:t>
+            </a:r>
+          </a:p>
+        </p:txBody>
+      </p:sp>
+      <p:sp>
+        <p:nvSpPr>
+          <p:cNvPr id="6" name="TextBox 5"/>
+          <p:cNvSpPr txBox="1"/>
+          <p:nvPr/>
+        </p:nvSpPr>
+        <p:spPr>
+          <a:xfrm>
+            <a:off x="502920" y="6419088"/>
+            <a:ext cx="10789920" cy="228600"/>
+          </a:xfrm>
+          <a:prstGeom prst="rect">
+            <a:avLst/>
+          </a:prstGeom>
+          <a:noFill/>
+        </p:spPr>
+        <p:txBody>
+          <a:bodyPr wrap="square" lIns="0" rIns="0" tIns="0" bIns="0">
+            <a:spAutoFit/>
+          </a:bodyPr>
+          <a:lstStyle/>
+          <a:p>
+            <a:pPr>
+              <a:spcAft>
+                <a:spcPts val="900"/>
+              </a:spcAft>
+            </a:pPr>
+            <a:r>
+              <a:rPr sz="1000" b="0">
+                <a:solidFill>
+                  <a:srgbClr val="71818B"/>
+                </a:solidFill>
+                <a:latin typeface="Microsoft YaHei"/>
+                <a:ea typeface="Microsoft YaHei"/>
+              </a:rPr>
+              <a:t>Keep课程样本；观察性分析。全部数值与口径见分析报告及附带结果。</a:t>
+            </a:r>
+          </a:p>
+        </p:txBody>
+      </p:sp>
+      <p:sp>
+        <p:nvSpPr>
+          <p:cNvPr id="7" name="TextBox 6"/>
+          <p:cNvSpPr txBox="1"/>
+          <p:nvPr/>
+        </p:nvSpPr>
+        <p:spPr>
+          <a:xfrm>
+            <a:off x="11201400" y="6419088"/>
+            <a:ext cx="548640" cy="228600"/>
+          </a:xfrm>
+          <a:prstGeom prst="rect">
+            <a:avLst/>
+          </a:prstGeom>
+          <a:noFill/>
+        </p:spPr>
+        <p:txBody>
+          <a:bodyPr wrap="square" lIns="0" rIns="0" tIns="0" bIns="0">
+            <a:spAutoFit/>
+          </a:bodyPr>
+          <a:lstStyle/>
+          <a:p>
+            <a:pPr>
+              <a:spcAft>
+                <a:spcPts val="900"/>
+              </a:spcAft>
+            </a:pPr>
+            <a:r>
+              <a:rPr sz="1000" b="0">
+                <a:solidFill>
+                  <a:srgbClr val="356D9A"/>
+                </a:solidFill>
+                <a:latin typeface="Microsoft YaHei"/>
+                <a:ea typeface="Microsoft YaHei"/>
+              </a:rPr>
+              <a:t>16</a:t>
+            </a:r>
+          </a:p>
+        </p:txBody>
+      </p:sp>
+    </p:spTree>
+  </p:cSld>
+  <p:clrMapOvr>
+    <a:masterClrMapping/>
+  </p:clrMapOvr>
+</p:sld>
+</file>
+
+<file path=ppt/slides/slide17.xml><?xml version="1.0" encoding="utf-8"?>
+<p:sld xmlns:a="http://schemas.openxmlformats.org/drawingml/2006/main" xmlns:p="http://schemas.openxmlformats.org/presentationml/2006/main" xmlns:r="http://schemas.openxmlformats.org/officeDocument/2006/relationships">
+  <p:cSld>
+    <p:bg>
+      <p:bgPr>
+        <a:solidFill>
+          <a:srgbClr val="FFFFFF"/>
+        </a:solidFill>
+        <a:effectLst/>
+      </p:bgPr>
+    </p:bg>
+    <p:spTree>
+      <p:nvGrpSpPr>
+        <p:cNvPr id="1" name=""/>
+        <p:cNvGrpSpPr/>
+        <p:nvPr/>
+      </p:nvGrpSpPr>
+      <p:grpSpPr/>
+      <p:sp>
+        <p:nvSpPr>
+          <p:cNvPr id="2" name="TextBox 1"/>
+          <p:cNvSpPr txBox="1"/>
+          <p:nvPr/>
+        </p:nvSpPr>
+        <p:spPr>
+          <a:xfrm>
+            <a:off x="502920" y="256032"/>
+            <a:ext cx="10972800" cy="274320"/>
+          </a:xfrm>
+          <a:prstGeom prst="rect">
+            <a:avLst/>
+          </a:prstGeom>
+          <a:noFill/>
+        </p:spPr>
+        <p:txBody>
+          <a:bodyPr wrap="square" lIns="0" rIns="0" tIns="0" bIns="0">
+            <a:spAutoFit/>
+          </a:bodyPr>
+          <a:lstStyle/>
+          <a:p>
+            <a:pPr>
+              <a:spcAft>
+                <a:spcPts val="900"/>
+              </a:spcAft>
+            </a:pPr>
+            <a:r>
+              <a:rPr sz="1100" b="0">
+                <a:solidFill>
+                  <a:srgbClr val="356D9A"/>
+                </a:solidFill>
+                <a:latin typeface="Microsoft YaHei"/>
+                <a:ea typeface="Microsoft YaHei"/>
+              </a:rPr>
+              <a:t>KEEP COMMUNITY  /  小组项目  /  17</a:t>
+            </a:r>
+          </a:p>
+        </p:txBody>
+      </p:sp>
+      <p:sp>
+        <p:nvSpPr>
+          <p:cNvPr id="3" name="TextBox 2"/>
+          <p:cNvSpPr txBox="1"/>
+          <p:nvPr/>
+        </p:nvSpPr>
+        <p:spPr>
+          <a:xfrm>
+            <a:off x="502920" y="749808"/>
+            <a:ext cx="11155680" cy="822960"/>
+          </a:xfrm>
+          <a:prstGeom prst="rect">
+            <a:avLst/>
+          </a:prstGeom>
+          <a:noFill/>
+        </p:spPr>
+        <p:txBody>
+          <a:bodyPr wrap="square" lIns="0" rIns="0" tIns="0" bIns="0">
+            <a:spAutoFit/>
+          </a:bodyPr>
+          <a:lstStyle/>
+          <a:p>
+            <a:pPr>
+              <a:spcAft>
+                <a:spcPts val="900"/>
+              </a:spcAft>
+            </a:pPr>
+            <a:r>
+              <a:rPr sz="3000" b="1">
+                <a:solidFill>
+                  <a:srgbClr val="213444"/>
+                </a:solidFill>
+                <a:latin typeface="Microsoft YaHei"/>
+                <a:ea typeface="Microsoft YaHei"/>
+              </a:rPr>
+              <a:t>词典测量也需要接受检查</a:t>
             </a:r>
           </a:p>
         </p:txBody>
@@ -6887,24 +7668,24 @@
               </a:spcAft>
             </a:pPr>
             <a:r>
-              <a:rPr sz="2100" b="0">
-                <a:solidFill>
-                  <a:srgbClr val="213444"/>
-                </a:solidFill>
-                <a:latin typeface="Microsoft YaHei"/>
-                <a:ea typeface="Microsoft YaHei"/>
-              </a:rPr>
-              <a:t>成员A【待填写】：研究问题与背景（1—3页）</a:t>
-            </a:r>
-          </a:p>
-          <a:p>
-            <a:pPr>
-              <a:spcAft>
-                <a:spcPts val="900"/>
-              </a:spcAft>
-            </a:pPr>
-            <a:r>
-              <a:rPr sz="2100" b="0">
+              <a:rPr sz="2400" b="0">
+                <a:solidFill>
+                  <a:srgbClr val="213444"/>
+                </a:solidFill>
+                <a:latin typeface="Microsoft YaHei"/>
+                <a:ea typeface="Microsoft YaHei"/>
+              </a:rPr>
+              <a:t>40个帖子—特征检查单元：按规则命中分层抽样，无点赞展示。</a:t>
+            </a:r>
+          </a:p>
+          <a:p>
+            <a:pPr>
+              <a:spcAft>
+                <a:spcPts val="900"/>
+              </a:spcAft>
+            </a:pPr>
+            <a:r>
+              <a:rPr sz="2400" b="0">
                 <a:solidFill>
                   <a:srgbClr val="213444"/>
                 </a:solidFill>
@@ -6921,24 +7702,24 @@
               </a:spcAft>
             </a:pPr>
             <a:r>
-              <a:rPr sz="2100" b="0">
-                <a:solidFill>
-                  <a:srgbClr val="213444"/>
-                </a:solidFill>
-                <a:latin typeface="Microsoft YaHei"/>
-                <a:ea typeface="Microsoft YaHei"/>
-              </a:rPr>
-              <a:t>成员B【待填写】：数据与文本（4—7页）</a:t>
-            </a:r>
-          </a:p>
-          <a:p>
-            <a:pPr>
-              <a:spcAft>
-                <a:spcPts val="900"/>
-              </a:spcAft>
-            </a:pPr>
-            <a:r>
-              <a:rPr sz="2100" b="0">
+              <a:rPr sz="2400" b="0">
+                <a:solidFill>
+                  <a:srgbClr val="213444"/>
+                </a:solidFill>
+                <a:latin typeface="Microsoft YaHei"/>
+                <a:ea typeface="Microsoft YaHei"/>
+              </a:rPr>
+              <a:t>“完成”可能指绘画；“一起”可能描述线下朋友；问号可能是反问。</a:t>
+            </a:r>
+          </a:p>
+          <a:p>
+            <a:pPr>
+              <a:spcAft>
+                <a:spcPts val="900"/>
+              </a:spcAft>
+            </a:pPr>
+            <a:r>
+              <a:rPr sz="2400" b="0">
                 <a:solidFill>
                   <a:srgbClr val="213444"/>
                 </a:solidFill>
@@ -6955,82 +7736,14 @@
               </a:spcAft>
             </a:pPr>
             <a:r>
-              <a:rPr sz="2100" b="0">
-                <a:solidFill>
-                  <a:srgbClr val="213444"/>
-                </a:solidFill>
-                <a:latin typeface="Microsoft YaHei"/>
-                <a:ea typeface="Microsoft YaHei"/>
-              </a:rPr>
-              <a:t>成员C【待填写】：模型与检验（8—11页）</a:t>
-            </a:r>
-          </a:p>
-          <a:p>
-            <a:pPr>
-              <a:spcAft>
-                <a:spcPts val="900"/>
-              </a:spcAft>
-            </a:pPr>
-            <a:r>
-              <a:rPr sz="2100" b="0">
-                <a:solidFill>
-                  <a:srgbClr val="213444"/>
-                </a:solidFill>
-                <a:latin typeface="Microsoft YaHei"/>
-                <a:ea typeface="Microsoft YaHei"/>
-              </a:rPr>
-              <a:t/>
-            </a:r>
-          </a:p>
-          <a:p>
-            <a:pPr>
-              <a:spcAft>
-                <a:spcPts val="900"/>
-              </a:spcAft>
-            </a:pPr>
-            <a:r>
-              <a:rPr sz="2100" b="0">
-                <a:solidFill>
-                  <a:srgbClr val="213444"/>
-                </a:solidFill>
-                <a:latin typeface="Microsoft YaHei"/>
-                <a:ea typeface="Microsoft YaHei"/>
-              </a:rPr>
-              <a:t>成员D【待填写】：网络、建议与总结（12—16页）</a:t>
-            </a:r>
-          </a:p>
-          <a:p>
-            <a:pPr>
-              <a:spcAft>
-                <a:spcPts val="900"/>
-              </a:spcAft>
-            </a:pPr>
-            <a:r>
-              <a:rPr sz="2100" b="0">
-                <a:solidFill>
-                  <a:srgbClr val="213444"/>
-                </a:solidFill>
-                <a:latin typeface="Microsoft YaHei"/>
-                <a:ea typeface="Microsoft YaHei"/>
-              </a:rPr>
-              <a:t/>
-            </a:r>
-          </a:p>
-          <a:p>
-            <a:pPr>
-              <a:spcAft>
-                <a:spcPts val="900"/>
-              </a:spcAft>
-            </a:pPr>
-            <a:r>
-              <a:rPr sz="2100" b="0">
-                <a:solidFill>
-                  <a:srgbClr val="213444"/>
-                </a:solidFill>
-                <a:latin typeface="Microsoft YaHei"/>
-                <a:ea typeface="Microsoft YaHei"/>
-              </a:rPr>
-              <a:t>此为建议分工，须按真实人数和贡献修订。</a:t>
+              <a:rPr sz="2400" b="0">
+                <a:solidFill>
+                  <a:srgbClr val="213444"/>
+                </a:solidFill>
+                <a:latin typeface="Microsoft YaHei"/>
+                <a:ea typeface="Microsoft YaHei"/>
+              </a:rPr>
+              <a:t>Codex辅助抽查，未做独立人工双编码；不宣称准确率。</a:t>
             </a:r>
           </a:p>
         </p:txBody>
@@ -7110,7 +7823,643 @@
                 <a:latin typeface="Microsoft YaHei"/>
                 <a:ea typeface="Microsoft YaHei"/>
               </a:rPr>
-              <a:t>16</a:t>
+              <a:t>17</a:t>
+            </a:r>
+          </a:p>
+        </p:txBody>
+      </p:sp>
+    </p:spTree>
+  </p:cSld>
+  <p:clrMapOvr>
+    <a:masterClrMapping/>
+  </p:clrMapOvr>
+</p:sld>
+</file>
+
+<file path=ppt/slides/slide18.xml><?xml version="1.0" encoding="utf-8"?>
+<p:sld xmlns:a="http://schemas.openxmlformats.org/drawingml/2006/main" xmlns:p="http://schemas.openxmlformats.org/presentationml/2006/main" xmlns:r="http://schemas.openxmlformats.org/officeDocument/2006/relationships">
+  <p:cSld>
+    <p:bg>
+      <p:bgPr>
+        <a:solidFill>
+          <a:srgbClr val="FFFFFF"/>
+        </a:solidFill>
+        <a:effectLst/>
+      </p:bgPr>
+    </p:bg>
+    <p:spTree>
+      <p:nvGrpSpPr>
+        <p:cNvPr id="1" name=""/>
+        <p:cNvGrpSpPr/>
+        <p:nvPr/>
+      </p:nvGrpSpPr>
+      <p:grpSpPr/>
+      <p:sp>
+        <p:nvSpPr>
+          <p:cNvPr id="2" name="TextBox 1"/>
+          <p:cNvSpPr txBox="1"/>
+          <p:nvPr/>
+        </p:nvSpPr>
+        <p:spPr>
+          <a:xfrm>
+            <a:off x="502920" y="256032"/>
+            <a:ext cx="10972800" cy="274320"/>
+          </a:xfrm>
+          <a:prstGeom prst="rect">
+            <a:avLst/>
+          </a:prstGeom>
+          <a:noFill/>
+        </p:spPr>
+        <p:txBody>
+          <a:bodyPr wrap="square" lIns="0" rIns="0" tIns="0" bIns="0">
+            <a:spAutoFit/>
+          </a:bodyPr>
+          <a:lstStyle/>
+          <a:p>
+            <a:pPr>
+              <a:spcAft>
+                <a:spcPts val="900"/>
+              </a:spcAft>
+            </a:pPr>
+            <a:r>
+              <a:rPr sz="1100" b="0">
+                <a:solidFill>
+                  <a:srgbClr val="356D9A"/>
+                </a:solidFill>
+                <a:latin typeface="Microsoft YaHei"/>
+                <a:ea typeface="Microsoft YaHei"/>
+              </a:rPr>
+              <a:t>KEEP COMMUNITY  /  小组项目  /  18</a:t>
+            </a:r>
+          </a:p>
+        </p:txBody>
+      </p:sp>
+      <p:sp>
+        <p:nvSpPr>
+          <p:cNvPr id="3" name="TextBox 2"/>
+          <p:cNvSpPr txBox="1"/>
+          <p:nvPr/>
+        </p:nvSpPr>
+        <p:spPr>
+          <a:xfrm>
+            <a:off x="502920" y="749808"/>
+            <a:ext cx="11155680" cy="822960"/>
+          </a:xfrm>
+          <a:prstGeom prst="rect">
+            <a:avLst/>
+          </a:prstGeom>
+          <a:noFill/>
+        </p:spPr>
+        <p:txBody>
+          <a:bodyPr wrap="square" lIns="0" rIns="0" tIns="0" bIns="0">
+            <a:spAutoFit/>
+          </a:bodyPr>
+          <a:lstStyle/>
+          <a:p>
+            <a:pPr>
+              <a:spcAft>
+                <a:spcPts val="900"/>
+              </a:spcAft>
+            </a:pPr>
+            <a:r>
+              <a:rPr sz="3000" b="1">
+                <a:solidFill>
+                  <a:srgbClr val="213444"/>
+                </a:solidFill>
+                <a:latin typeface="Microsoft YaHei"/>
+                <a:ea typeface="Microsoft YaHei"/>
+              </a:rPr>
+              <a:t>评论网络：明确每条边的指向</a:t>
+            </a:r>
+          </a:p>
+        </p:txBody>
+      </p:sp>
+      <p:pic>
+        <p:nvPicPr>
+          <p:cNvPr id="4" name="Picture 3" descr="06_comment_network.png"/>
+          <p:cNvPicPr>
+            <a:picLocks noChangeAspect="1"/>
+          </p:cNvPicPr>
+          <p:nvPr/>
+        </p:nvPicPr>
+        <p:blipFill>
+          <a:blip r:embed="rId2"/>
+          <a:stretch>
+            <a:fillRect/>
+          </a:stretch>
+        </p:blipFill>
+        <p:spPr>
+          <a:xfrm>
+            <a:off x="578279" y="1851660"/>
+            <a:ext cx="7255921" cy="4023360"/>
+          </a:xfrm>
+          <a:prstGeom prst="rect">
+            <a:avLst/>
+          </a:prstGeom>
+        </p:spPr>
+      </p:pic>
+      <p:sp>
+        <p:nvSpPr>
+          <p:cNvPr id="5" name="TextBox 4"/>
+          <p:cNvSpPr txBox="1"/>
+          <p:nvPr/>
+        </p:nvSpPr>
+        <p:spPr>
+          <a:xfrm>
+            <a:off x="8229600" y="1828800"/>
+            <a:ext cx="3383280" cy="4297680"/>
+          </a:xfrm>
+          <a:prstGeom prst="rect">
+            <a:avLst/>
+          </a:prstGeom>
+          <a:noFill/>
+        </p:spPr>
+        <p:txBody>
+          <a:bodyPr wrap="square" lIns="0" rIns="0" tIns="0" bIns="0">
+            <a:spAutoFit/>
+          </a:bodyPr>
+          <a:lstStyle/>
+          <a:p>
+            <a:pPr>
+              <a:spcAft>
+                <a:spcPts val="900"/>
+              </a:spcAft>
+            </a:pPr>
+            <a:r>
+              <a:rPr sz="1900" b="0">
+                <a:solidFill>
+                  <a:srgbClr val="213444"/>
+                </a:solidFill>
+                <a:latin typeface="Microsoft YaHei"/>
+                <a:ea typeface="Microsoft YaHei"/>
+              </a:rPr>
+              <a:t>根评论：评论者→帖主；明确回复：回复者→replyUserId。</a:t>
+            </a:r>
+          </a:p>
+          <a:p>
+            <a:pPr>
+              <a:spcAft>
+                <a:spcPts val="900"/>
+              </a:spcAft>
+            </a:pPr>
+            <a:r>
+              <a:rPr sz="1900" b="0">
+                <a:solidFill>
+                  <a:srgbClr val="213444"/>
+                </a:solidFill>
+                <a:latin typeface="Microsoft YaHei"/>
+                <a:ea typeface="Microsoft YaHei"/>
+              </a:rPr>
+              <a:t/>
+            </a:r>
+          </a:p>
+          <a:p>
+            <a:pPr>
+              <a:spcAft>
+                <a:spcPts val="900"/>
+              </a:spcAft>
+            </a:pPr>
+            <a:r>
+              <a:rPr sz="1900" b="0">
+                <a:solidFill>
+                  <a:srgbClr val="213444"/>
+                </a:solidFill>
+                <a:latin typeface="Microsoft YaHei"/>
+                <a:ea typeface="Microsoft YaHei"/>
+              </a:rPr>
+              <a:t>去重后移除84次自我互动；11,511事件合并为4,069条边。</a:t>
+            </a:r>
+          </a:p>
+          <a:p>
+            <a:pPr>
+              <a:spcAft>
+                <a:spcPts val="900"/>
+              </a:spcAft>
+            </a:pPr>
+            <a:r>
+              <a:rPr sz="1900" b="0">
+                <a:solidFill>
+                  <a:srgbClr val="213444"/>
+                </a:solidFill>
+                <a:latin typeface="Microsoft YaHei"/>
+                <a:ea typeface="Microsoft YaHei"/>
+              </a:rPr>
+              <a:t/>
+            </a:r>
+          </a:p>
+          <a:p>
+            <a:pPr>
+              <a:spcAft>
+                <a:spcPts val="900"/>
+              </a:spcAft>
+            </a:pPr>
+            <a:r>
+              <a:rPr sz="1900" b="0">
+                <a:solidFill>
+                  <a:srgbClr val="213444"/>
+                </a:solidFill>
+                <a:latin typeface="Microsoft YaHei"/>
+                <a:ea typeface="Microsoft YaHei"/>
+              </a:rPr>
+              <a:t>2,932个有边节点；箭头在图中省略，原数据保持有向。</a:t>
+            </a:r>
+          </a:p>
+        </p:txBody>
+      </p:sp>
+      <p:sp>
+        <p:nvSpPr>
+          <p:cNvPr id="6" name="TextBox 5"/>
+          <p:cNvSpPr txBox="1"/>
+          <p:nvPr/>
+        </p:nvSpPr>
+        <p:spPr>
+          <a:xfrm>
+            <a:off x="502920" y="6419088"/>
+            <a:ext cx="10789920" cy="228600"/>
+          </a:xfrm>
+          <a:prstGeom prst="rect">
+            <a:avLst/>
+          </a:prstGeom>
+          <a:noFill/>
+        </p:spPr>
+        <p:txBody>
+          <a:bodyPr wrap="square" lIns="0" rIns="0" tIns="0" bIns="0">
+            <a:spAutoFit/>
+          </a:bodyPr>
+          <a:lstStyle/>
+          <a:p>
+            <a:pPr>
+              <a:spcAft>
+                <a:spcPts val="900"/>
+              </a:spcAft>
+            </a:pPr>
+            <a:r>
+              <a:rPr sz="1000" b="0">
+                <a:solidFill>
+                  <a:srgbClr val="71818B"/>
+                </a:solidFill>
+                <a:latin typeface="Microsoft YaHei"/>
+                <a:ea typeface="Microsoft YaHei"/>
+              </a:rPr>
+              <a:t>Keep课程样本；观察性分析。全部数值与口径见分析报告及附带结果。</a:t>
+            </a:r>
+          </a:p>
+        </p:txBody>
+      </p:sp>
+      <p:sp>
+        <p:nvSpPr>
+          <p:cNvPr id="7" name="TextBox 6"/>
+          <p:cNvSpPr txBox="1"/>
+          <p:nvPr/>
+        </p:nvSpPr>
+        <p:spPr>
+          <a:xfrm>
+            <a:off x="11201400" y="6419088"/>
+            <a:ext cx="548640" cy="228600"/>
+          </a:xfrm>
+          <a:prstGeom prst="rect">
+            <a:avLst/>
+          </a:prstGeom>
+          <a:noFill/>
+        </p:spPr>
+        <p:txBody>
+          <a:bodyPr wrap="square" lIns="0" rIns="0" tIns="0" bIns="0">
+            <a:spAutoFit/>
+          </a:bodyPr>
+          <a:lstStyle/>
+          <a:p>
+            <a:pPr>
+              <a:spcAft>
+                <a:spcPts val="900"/>
+              </a:spcAft>
+            </a:pPr>
+            <a:r>
+              <a:rPr sz="1000" b="0">
+                <a:solidFill>
+                  <a:srgbClr val="356D9A"/>
+                </a:solidFill>
+                <a:latin typeface="Microsoft YaHei"/>
+                <a:ea typeface="Microsoft YaHei"/>
+              </a:rPr>
+              <a:t>18</a:t>
+            </a:r>
+          </a:p>
+        </p:txBody>
+      </p:sp>
+    </p:spTree>
+  </p:cSld>
+  <p:clrMapOvr>
+    <a:masterClrMapping/>
+  </p:clrMapOvr>
+</p:sld>
+</file>
+
+<file path=ppt/slides/slide19.xml><?xml version="1.0" encoding="utf-8"?>
+<p:sld xmlns:a="http://schemas.openxmlformats.org/drawingml/2006/main" xmlns:p="http://schemas.openxmlformats.org/presentationml/2006/main" xmlns:r="http://schemas.openxmlformats.org/officeDocument/2006/relationships">
+  <p:cSld>
+    <p:bg>
+      <p:bgPr>
+        <a:solidFill>
+          <a:srgbClr val="FFFFFF"/>
+        </a:solidFill>
+        <a:effectLst/>
+      </p:bgPr>
+    </p:bg>
+    <p:spTree>
+      <p:nvGrpSpPr>
+        <p:cNvPr id="1" name=""/>
+        <p:cNvGrpSpPr/>
+        <p:nvPr/>
+      </p:nvGrpSpPr>
+      <p:grpSpPr/>
+      <p:sp>
+        <p:nvSpPr>
+          <p:cNvPr id="2" name="TextBox 1"/>
+          <p:cNvSpPr txBox="1"/>
+          <p:nvPr/>
+        </p:nvSpPr>
+        <p:spPr>
+          <a:xfrm>
+            <a:off x="502920" y="256032"/>
+            <a:ext cx="10972800" cy="274320"/>
+          </a:xfrm>
+          <a:prstGeom prst="rect">
+            <a:avLst/>
+          </a:prstGeom>
+          <a:noFill/>
+        </p:spPr>
+        <p:txBody>
+          <a:bodyPr wrap="square" lIns="0" rIns="0" tIns="0" bIns="0">
+            <a:spAutoFit/>
+          </a:bodyPr>
+          <a:lstStyle/>
+          <a:p>
+            <a:pPr>
+              <a:spcAft>
+                <a:spcPts val="900"/>
+              </a:spcAft>
+            </a:pPr>
+            <a:r>
+              <a:rPr sz="1100" b="0">
+                <a:solidFill>
+                  <a:srgbClr val="356D9A"/>
+                </a:solidFill>
+                <a:latin typeface="Microsoft YaHei"/>
+                <a:ea typeface="Microsoft YaHei"/>
+              </a:rPr>
+              <a:t>KEEP COMMUNITY  /  小组项目  /  19</a:t>
+            </a:r>
+          </a:p>
+        </p:txBody>
+      </p:sp>
+      <p:sp>
+        <p:nvSpPr>
+          <p:cNvPr id="3" name="TextBox 2"/>
+          <p:cNvSpPr txBox="1"/>
+          <p:nvPr/>
+        </p:nvSpPr>
+        <p:spPr>
+          <a:xfrm>
+            <a:off x="502920" y="749808"/>
+            <a:ext cx="11155680" cy="822960"/>
+          </a:xfrm>
+          <a:prstGeom prst="rect">
+            <a:avLst/>
+          </a:prstGeom>
+          <a:noFill/>
+        </p:spPr>
+        <p:txBody>
+          <a:bodyPr wrap="square" lIns="0" rIns="0" tIns="0" bIns="0">
+            <a:spAutoFit/>
+          </a:bodyPr>
+          <a:lstStyle/>
+          <a:p>
+            <a:pPr>
+              <a:spcAft>
+                <a:spcPts val="900"/>
+              </a:spcAft>
+            </a:pPr>
+            <a:r>
+              <a:rPr sz="3000" b="1">
+                <a:solidFill>
+                  <a:srgbClr val="213444"/>
+                </a:solidFill>
+                <a:latin typeface="Microsoft YaHei"/>
+                <a:ea typeface="Microsoft YaHei"/>
+              </a:rPr>
+              <a:t>互动集中，但样本边界影响很大</a:t>
+            </a:r>
+          </a:p>
+        </p:txBody>
+      </p:sp>
+      <p:pic>
+        <p:nvPicPr>
+          <p:cNvPr id="4" name="Picture 3" descr="07_network_concentration.png"/>
+          <p:cNvPicPr>
+            <a:picLocks noChangeAspect="1"/>
+          </p:cNvPicPr>
+          <p:nvPr/>
+        </p:nvPicPr>
+        <p:blipFill>
+          <a:blip r:embed="rId2"/>
+          <a:stretch>
+            <a:fillRect/>
+          </a:stretch>
+        </p:blipFill>
+        <p:spPr>
+          <a:xfrm>
+            <a:off x="480060" y="2614975"/>
+            <a:ext cx="7452360" cy="2496729"/>
+          </a:xfrm>
+          <a:prstGeom prst="rect">
+            <a:avLst/>
+          </a:prstGeom>
+        </p:spPr>
+      </p:pic>
+      <p:sp>
+        <p:nvSpPr>
+          <p:cNvPr id="5" name="TextBox 4"/>
+          <p:cNvSpPr txBox="1"/>
+          <p:nvPr/>
+        </p:nvSpPr>
+        <p:spPr>
+          <a:xfrm>
+            <a:off x="8229600" y="1828800"/>
+            <a:ext cx="3383280" cy="4297680"/>
+          </a:xfrm>
+          <a:prstGeom prst="rect">
+            <a:avLst/>
+          </a:prstGeom>
+          <a:noFill/>
+        </p:spPr>
+        <p:txBody>
+          <a:bodyPr wrap="square" lIns="0" rIns="0" tIns="0" bIns="0">
+            <a:spAutoFit/>
+          </a:bodyPr>
+          <a:lstStyle/>
+          <a:p>
+            <a:pPr>
+              <a:spcAft>
+                <a:spcPts val="900"/>
+              </a:spcAft>
+            </a:pPr>
+            <a:r>
+              <a:rPr sz="1900" b="0">
+                <a:solidFill>
+                  <a:srgbClr val="213444"/>
+                </a:solidFill>
+                <a:latin typeface="Microsoft YaHei"/>
+                <a:ea typeface="Microsoft YaHei"/>
+              </a:rPr>
+              <a:t>前10位接收者获得54.0%互动；第一位12.0%。</a:t>
+            </a:r>
+          </a:p>
+          <a:p>
+            <a:pPr>
+              <a:spcAft>
+                <a:spcPts val="900"/>
+              </a:spcAft>
+            </a:pPr>
+            <a:r>
+              <a:rPr sz="1900" b="0">
+                <a:solidFill>
+                  <a:srgbClr val="213444"/>
+                </a:solidFill>
+                <a:latin typeface="Microsoft YaHei"/>
+                <a:ea typeface="Microsoft YaHei"/>
+              </a:rPr>
+              <a:t/>
+            </a:r>
+          </a:p>
+          <a:p>
+            <a:pPr>
+              <a:spcAft>
+                <a:spcPts val="900"/>
+              </a:spcAft>
+            </a:pPr>
+            <a:r>
+              <a:rPr sz="1900" b="0">
+                <a:solidFill>
+                  <a:srgbClr val="213444"/>
+                </a:solidFill>
+                <a:latin typeface="Microsoft YaHei"/>
+                <a:ea typeface="Microsoft YaHei"/>
+              </a:rPr>
+              <a:t>整体互惠率49.6%；仅明确回复子网络29.9%。</a:t>
+            </a:r>
+          </a:p>
+          <a:p>
+            <a:pPr>
+              <a:spcAft>
+                <a:spcPts val="900"/>
+              </a:spcAft>
+            </a:pPr>
+            <a:r>
+              <a:rPr sz="1900" b="0">
+                <a:solidFill>
+                  <a:srgbClr val="213444"/>
+                </a:solidFill>
+                <a:latin typeface="Microsoft YaHei"/>
+                <a:ea typeface="Microsoft YaHei"/>
+              </a:rPr>
+              <a:t/>
+            </a:r>
+          </a:p>
+          <a:p>
+            <a:pPr>
+              <a:spcAft>
+                <a:spcPts val="900"/>
+              </a:spcAft>
+            </a:pPr>
+            <a:r>
+              <a:rPr sz="1900" b="0">
+                <a:solidFill>
+                  <a:srgbClr val="213444"/>
+                </a:solidFill>
+                <a:latin typeface="Microsoft YaHei"/>
+                <a:ea typeface="Microsoft YaHei"/>
+              </a:rPr>
+              <a:t>这是采集网络的接收事件数，不是平台影响力或独立粉丝数。</a:t>
+            </a:r>
+          </a:p>
+        </p:txBody>
+      </p:sp>
+      <p:sp>
+        <p:nvSpPr>
+          <p:cNvPr id="6" name="TextBox 5"/>
+          <p:cNvSpPr txBox="1"/>
+          <p:nvPr/>
+        </p:nvSpPr>
+        <p:spPr>
+          <a:xfrm>
+            <a:off x="502920" y="6419088"/>
+            <a:ext cx="10789920" cy="228600"/>
+          </a:xfrm>
+          <a:prstGeom prst="rect">
+            <a:avLst/>
+          </a:prstGeom>
+          <a:noFill/>
+        </p:spPr>
+        <p:txBody>
+          <a:bodyPr wrap="square" lIns="0" rIns="0" tIns="0" bIns="0">
+            <a:spAutoFit/>
+          </a:bodyPr>
+          <a:lstStyle/>
+          <a:p>
+            <a:pPr>
+              <a:spcAft>
+                <a:spcPts val="900"/>
+              </a:spcAft>
+            </a:pPr>
+            <a:r>
+              <a:rPr sz="1000" b="0">
+                <a:solidFill>
+                  <a:srgbClr val="71818B"/>
+                </a:solidFill>
+                <a:latin typeface="Microsoft YaHei"/>
+                <a:ea typeface="Microsoft YaHei"/>
+              </a:rPr>
+              <a:t>Keep课程样本；观察性分析。全部数值与口径见分析报告及附带结果。</a:t>
+            </a:r>
+          </a:p>
+        </p:txBody>
+      </p:sp>
+      <p:sp>
+        <p:nvSpPr>
+          <p:cNvPr id="7" name="TextBox 6"/>
+          <p:cNvSpPr txBox="1"/>
+          <p:nvPr/>
+        </p:nvSpPr>
+        <p:spPr>
+          <a:xfrm>
+            <a:off x="11201400" y="6419088"/>
+            <a:ext cx="548640" cy="228600"/>
+          </a:xfrm>
+          <a:prstGeom prst="rect">
+            <a:avLst/>
+          </a:prstGeom>
+          <a:noFill/>
+        </p:spPr>
+        <p:txBody>
+          <a:bodyPr wrap="square" lIns="0" rIns="0" tIns="0" bIns="0">
+            <a:spAutoFit/>
+          </a:bodyPr>
+          <a:lstStyle/>
+          <a:p>
+            <a:pPr>
+              <a:spcAft>
+                <a:spcPts val="900"/>
+              </a:spcAft>
+            </a:pPr>
+            <a:r>
+              <a:rPr sz="1000" b="0">
+                <a:solidFill>
+                  <a:srgbClr val="356D9A"/>
+                </a:solidFill>
+                <a:latin typeface="Microsoft YaHei"/>
+                <a:ea typeface="Microsoft YaHei"/>
+              </a:rPr>
+              <a:t>19</a:t>
             </a:r>
           </a:p>
         </p:txBody>
@@ -7249,7 +8598,7 @@
               </a:spcAft>
             </a:pPr>
             <a:r>
-              <a:rPr sz="2400" b="0">
+              <a:rPr sz="2100" b="0">
                 <a:solidFill>
                   <a:srgbClr val="213444"/>
                 </a:solidFill>
@@ -7266,7 +8615,7 @@
               </a:spcAft>
             </a:pPr>
             <a:r>
-              <a:rPr sz="2400" b="0">
+              <a:rPr sz="2100" b="0">
                 <a:solidFill>
                   <a:srgbClr val="213444"/>
                 </a:solidFill>
@@ -7283,7 +8632,7 @@
               </a:spcAft>
             </a:pPr>
             <a:r>
-              <a:rPr sz="2400" b="0">
+              <a:rPr sz="2100" b="0">
                 <a:solidFill>
                   <a:srgbClr val="213444"/>
                 </a:solidFill>
@@ -7300,7 +8649,7 @@
               </a:spcAft>
             </a:pPr>
             <a:r>
-              <a:rPr sz="2400" b="0">
+              <a:rPr sz="2100" b="0">
                 <a:solidFill>
                   <a:srgbClr val="213444"/>
                 </a:solidFill>
@@ -7317,7 +8666,7 @@
               </a:spcAft>
             </a:pPr>
             <a:r>
-              <a:rPr sz="2400" b="0">
+              <a:rPr sz="2100" b="0">
                 <a:solidFill>
                   <a:srgbClr val="213444"/>
                 </a:solidFill>
@@ -7325,6 +8674,40 @@
                 <a:ea typeface="Microsoft YaHei"/>
               </a:rPr>
               <a:t>RQ3：评论连接了谁，互动是否集中？</a:t>
+            </a:r>
+          </a:p>
+          <a:p>
+            <a:pPr>
+              <a:spcAft>
+                <a:spcPts val="900"/>
+              </a:spcAft>
+            </a:pPr>
+            <a:r>
+              <a:rPr sz="2100" b="0">
+                <a:solidFill>
+                  <a:srgbClr val="213444"/>
+                </a:solidFill>
+                <a:latin typeface="Microsoft YaHei"/>
+                <a:ea typeface="Microsoft YaHei"/>
+              </a:rPr>
+              <a:t/>
+            </a:r>
+          </a:p>
+          <a:p>
+            <a:pPr>
+              <a:spcAft>
+                <a:spcPts val="900"/>
+              </a:spcAft>
+            </a:pPr>
+            <a:r>
+              <a:rPr sz="2100" b="0">
+                <a:solidFill>
+                  <a:srgbClr val="213444"/>
+                </a:solidFill>
+                <a:latin typeface="Microsoft YaHei"/>
+                <a:ea typeface="Microsoft YaHei"/>
+              </a:rPr>
+              <a:t>RQ4：文本能否改善样本外点赞预测？</a:t>
             </a:r>
           </a:p>
         </p:txBody>
@@ -7405,6 +8788,1342 @@
                 <a:ea typeface="Microsoft YaHei"/>
               </a:rPr>
               <a:t>2</a:t>
+            </a:r>
+          </a:p>
+        </p:txBody>
+      </p:sp>
+    </p:spTree>
+  </p:cSld>
+  <p:clrMapOvr>
+    <a:masterClrMapping/>
+  </p:clrMapOvr>
+</p:sld>
+</file>
+
+<file path=ppt/slides/slide20.xml><?xml version="1.0" encoding="utf-8"?>
+<p:sld xmlns:a="http://schemas.openxmlformats.org/drawingml/2006/main" xmlns:p="http://schemas.openxmlformats.org/presentationml/2006/main" xmlns:r="http://schemas.openxmlformats.org/officeDocument/2006/relationships">
+  <p:cSld>
+    <p:bg>
+      <p:bgPr>
+        <a:solidFill>
+          <a:srgbClr val="FFFFFF"/>
+        </a:solidFill>
+        <a:effectLst/>
+      </p:bgPr>
+    </p:bg>
+    <p:spTree>
+      <p:nvGrpSpPr>
+        <p:cNvPr id="1" name=""/>
+        <p:cNvGrpSpPr/>
+        <p:nvPr/>
+      </p:nvGrpSpPr>
+      <p:grpSpPr/>
+      <p:sp>
+        <p:nvSpPr>
+          <p:cNvPr id="2" name="TextBox 1"/>
+          <p:cNvSpPr txBox="1"/>
+          <p:nvPr/>
+        </p:nvSpPr>
+        <p:spPr>
+          <a:xfrm>
+            <a:off x="502920" y="256032"/>
+            <a:ext cx="10972800" cy="274320"/>
+          </a:xfrm>
+          <a:prstGeom prst="rect">
+            <a:avLst/>
+          </a:prstGeom>
+          <a:noFill/>
+        </p:spPr>
+        <p:txBody>
+          <a:bodyPr wrap="square" lIns="0" rIns="0" tIns="0" bIns="0">
+            <a:spAutoFit/>
+          </a:bodyPr>
+          <a:lstStyle/>
+          <a:p>
+            <a:pPr>
+              <a:spcAft>
+                <a:spcPts val="900"/>
+              </a:spcAft>
+            </a:pPr>
+            <a:r>
+              <a:rPr sz="1100" b="0">
+                <a:solidFill>
+                  <a:srgbClr val="356D9A"/>
+                </a:solidFill>
+                <a:latin typeface="Microsoft YaHei"/>
+                <a:ea typeface="Microsoft YaHei"/>
+              </a:rPr>
+              <a:t>KEEP COMMUNITY  /  小组项目  /  20</a:t>
+            </a:r>
+          </a:p>
+        </p:txBody>
+      </p:sp>
+      <p:sp>
+        <p:nvSpPr>
+          <p:cNvPr id="3" name="TextBox 2"/>
+          <p:cNvSpPr txBox="1"/>
+          <p:nvPr/>
+        </p:nvSpPr>
+        <p:spPr>
+          <a:xfrm>
+            <a:off x="502920" y="749808"/>
+            <a:ext cx="11155680" cy="822960"/>
+          </a:xfrm>
+          <a:prstGeom prst="rect">
+            <a:avLst/>
+          </a:prstGeom>
+          <a:noFill/>
+        </p:spPr>
+        <p:txBody>
+          <a:bodyPr wrap="square" lIns="0" rIns="0" tIns="0" bIns="0">
+            <a:spAutoFit/>
+          </a:bodyPr>
+          <a:lstStyle/>
+          <a:p>
+            <a:pPr>
+              <a:spcAft>
+                <a:spcPts val="900"/>
+              </a:spcAft>
+            </a:pPr>
+            <a:r>
+              <a:rPr sz="3000" b="1">
+                <a:solidFill>
+                  <a:srgbClr val="213444"/>
+                </a:solidFill>
+                <a:latin typeface="Microsoft YaHei"/>
+                <a:ea typeface="Microsoft YaHei"/>
+              </a:rPr>
+              <a:t>网络互惠主要体现围绕帖主的回应</a:t>
+            </a:r>
+          </a:p>
+        </p:txBody>
+      </p:sp>
+      <p:pic>
+        <p:nvPicPr>
+          <p:cNvPr id="4" name="Picture 3" descr="13_comment_timing_roles.png"/>
+          <p:cNvPicPr>
+            <a:picLocks noChangeAspect="1"/>
+          </p:cNvPicPr>
+          <p:nvPr/>
+        </p:nvPicPr>
+        <p:blipFill>
+          <a:blip r:embed="rId2"/>
+          <a:stretch>
+            <a:fillRect/>
+          </a:stretch>
+        </p:blipFill>
+        <p:spPr>
+          <a:xfrm>
+            <a:off x="480060" y="2649480"/>
+            <a:ext cx="7452360" cy="2427718"/>
+          </a:xfrm>
+          <a:prstGeom prst="rect">
+            <a:avLst/>
+          </a:prstGeom>
+        </p:spPr>
+      </p:pic>
+      <p:sp>
+        <p:nvSpPr>
+          <p:cNvPr id="5" name="TextBox 4"/>
+          <p:cNvSpPr txBox="1"/>
+          <p:nvPr/>
+        </p:nvSpPr>
+        <p:spPr>
+          <a:xfrm>
+            <a:off x="8229600" y="1828800"/>
+            <a:ext cx="3383280" cy="4297680"/>
+          </a:xfrm>
+          <a:prstGeom prst="rect">
+            <a:avLst/>
+          </a:prstGeom>
+          <a:noFill/>
+        </p:spPr>
+        <p:txBody>
+          <a:bodyPr wrap="square" lIns="0" rIns="0" tIns="0" bIns="0">
+            <a:spAutoFit/>
+          </a:bodyPr>
+          <a:lstStyle/>
+          <a:p>
+            <a:pPr>
+              <a:spcAft>
+                <a:spcPts val="900"/>
+              </a:spcAft>
+            </a:pPr>
+            <a:r>
+              <a:rPr sz="1900" b="0">
+                <a:solidFill>
+                  <a:srgbClr val="213444"/>
+                </a:solidFill>
+                <a:latin typeface="Microsoft YaHei"/>
+                <a:ea typeface="Microsoft YaHei"/>
+              </a:rPr>
+              <a:t>已采集评论中64.5%在24小时内，82.2%在7天内。</a:t>
+            </a:r>
+          </a:p>
+          <a:p>
+            <a:pPr>
+              <a:spcAft>
+                <a:spcPts val="900"/>
+              </a:spcAft>
+            </a:pPr>
+            <a:r>
+              <a:rPr sz="1900" b="0">
+                <a:solidFill>
+                  <a:srgbClr val="213444"/>
+                </a:solidFill>
+                <a:latin typeface="Microsoft YaHei"/>
+                <a:ea typeface="Microsoft YaHei"/>
+              </a:rPr>
+              <a:t/>
+            </a:r>
+          </a:p>
+          <a:p>
+            <a:pPr>
+              <a:spcAft>
+                <a:spcPts val="900"/>
+              </a:spcAft>
+            </a:pPr>
+            <a:r>
+              <a:rPr sz="1900" b="0">
+                <a:solidFill>
+                  <a:srgbClr val="213444"/>
+                </a:solidFill>
+                <a:latin typeface="Microsoft YaHei"/>
+                <a:ea typeface="Microsoft YaHei"/>
+              </a:rPr>
+              <a:t>4,902次明确回复中，89.0%由帖主发出；用户彼此回复仅2.0%。</a:t>
+            </a:r>
+          </a:p>
+          <a:p>
+            <a:pPr>
+              <a:spcAft>
+                <a:spcPts val="900"/>
+              </a:spcAft>
+            </a:pPr>
+            <a:r>
+              <a:rPr sz="1900" b="0">
+                <a:solidFill>
+                  <a:srgbClr val="213444"/>
+                </a:solidFill>
+                <a:latin typeface="Microsoft YaHei"/>
+                <a:ea typeface="Microsoft YaHei"/>
+              </a:rPr>
+              <a:t/>
+            </a:r>
+          </a:p>
+          <a:p>
+            <a:pPr>
+              <a:spcAft>
+                <a:spcPts val="900"/>
+              </a:spcAft>
+            </a:pPr>
+            <a:r>
+              <a:rPr sz="1900" b="0">
+                <a:solidFill>
+                  <a:srgbClr val="213444"/>
+                </a:solidFill>
+                <a:latin typeface="Microsoft YaHei"/>
+                <a:ea typeface="Microsoft YaHei"/>
+              </a:rPr>
+              <a:t>首周互惠率74.1%，全部记录49.6%；窗口和采集边界影响结构。</a:t>
+            </a:r>
+          </a:p>
+        </p:txBody>
+      </p:sp>
+      <p:sp>
+        <p:nvSpPr>
+          <p:cNvPr id="6" name="TextBox 5"/>
+          <p:cNvSpPr txBox="1"/>
+          <p:nvPr/>
+        </p:nvSpPr>
+        <p:spPr>
+          <a:xfrm>
+            <a:off x="502920" y="6419088"/>
+            <a:ext cx="10789920" cy="228600"/>
+          </a:xfrm>
+          <a:prstGeom prst="rect">
+            <a:avLst/>
+          </a:prstGeom>
+          <a:noFill/>
+        </p:spPr>
+        <p:txBody>
+          <a:bodyPr wrap="square" lIns="0" rIns="0" tIns="0" bIns="0">
+            <a:spAutoFit/>
+          </a:bodyPr>
+          <a:lstStyle/>
+          <a:p>
+            <a:pPr>
+              <a:spcAft>
+                <a:spcPts val="900"/>
+              </a:spcAft>
+            </a:pPr>
+            <a:r>
+              <a:rPr sz="1000" b="0">
+                <a:solidFill>
+                  <a:srgbClr val="71818B"/>
+                </a:solidFill>
+                <a:latin typeface="Microsoft YaHei"/>
+                <a:ea typeface="Microsoft YaHei"/>
+              </a:rPr>
+              <a:t>Keep课程样本；观察性分析。全部数值与口径见分析报告及附带结果。</a:t>
+            </a:r>
+          </a:p>
+        </p:txBody>
+      </p:sp>
+      <p:sp>
+        <p:nvSpPr>
+          <p:cNvPr id="7" name="TextBox 6"/>
+          <p:cNvSpPr txBox="1"/>
+          <p:nvPr/>
+        </p:nvSpPr>
+        <p:spPr>
+          <a:xfrm>
+            <a:off x="11201400" y="6419088"/>
+            <a:ext cx="548640" cy="228600"/>
+          </a:xfrm>
+          <a:prstGeom prst="rect">
+            <a:avLst/>
+          </a:prstGeom>
+          <a:noFill/>
+        </p:spPr>
+        <p:txBody>
+          <a:bodyPr wrap="square" lIns="0" rIns="0" tIns="0" bIns="0">
+            <a:spAutoFit/>
+          </a:bodyPr>
+          <a:lstStyle/>
+          <a:p>
+            <a:pPr>
+              <a:spcAft>
+                <a:spcPts val="900"/>
+              </a:spcAft>
+            </a:pPr>
+            <a:r>
+              <a:rPr sz="1000" b="0">
+                <a:solidFill>
+                  <a:srgbClr val="356D9A"/>
+                </a:solidFill>
+                <a:latin typeface="Microsoft YaHei"/>
+                <a:ea typeface="Microsoft YaHei"/>
+              </a:rPr>
+              <a:t>20</a:t>
+            </a:r>
+          </a:p>
+        </p:txBody>
+      </p:sp>
+    </p:spTree>
+  </p:cSld>
+  <p:clrMapOvr>
+    <a:masterClrMapping/>
+  </p:clrMapOvr>
+</p:sld>
+</file>
+
+<file path=ppt/slides/slide21.xml><?xml version="1.0" encoding="utf-8"?>
+<p:sld xmlns:a="http://schemas.openxmlformats.org/drawingml/2006/main" xmlns:p="http://schemas.openxmlformats.org/presentationml/2006/main" xmlns:r="http://schemas.openxmlformats.org/officeDocument/2006/relationships">
+  <p:cSld>
+    <p:bg>
+      <p:bgPr>
+        <a:solidFill>
+          <a:srgbClr val="FFFFFF"/>
+        </a:solidFill>
+        <a:effectLst/>
+      </p:bgPr>
+    </p:bg>
+    <p:spTree>
+      <p:nvGrpSpPr>
+        <p:cNvPr id="1" name=""/>
+        <p:cNvGrpSpPr/>
+        <p:nvPr/>
+      </p:nvGrpSpPr>
+      <p:grpSpPr/>
+      <p:sp>
+        <p:nvSpPr>
+          <p:cNvPr id="2" name="TextBox 1"/>
+          <p:cNvSpPr txBox="1"/>
+          <p:nvPr/>
+        </p:nvSpPr>
+        <p:spPr>
+          <a:xfrm>
+            <a:off x="502920" y="256032"/>
+            <a:ext cx="10972800" cy="274320"/>
+          </a:xfrm>
+          <a:prstGeom prst="rect">
+            <a:avLst/>
+          </a:prstGeom>
+          <a:noFill/>
+        </p:spPr>
+        <p:txBody>
+          <a:bodyPr wrap="square" lIns="0" rIns="0" tIns="0" bIns="0">
+            <a:spAutoFit/>
+          </a:bodyPr>
+          <a:lstStyle/>
+          <a:p>
+            <a:pPr>
+              <a:spcAft>
+                <a:spcPts val="900"/>
+              </a:spcAft>
+            </a:pPr>
+            <a:r>
+              <a:rPr sz="1100" b="0">
+                <a:solidFill>
+                  <a:srgbClr val="356D9A"/>
+                </a:solidFill>
+                <a:latin typeface="Microsoft YaHei"/>
+                <a:ea typeface="Microsoft YaHei"/>
+              </a:rPr>
+              <a:t>KEEP COMMUNITY  /  小组项目  /  21</a:t>
+            </a:r>
+          </a:p>
+        </p:txBody>
+      </p:sp>
+      <p:sp>
+        <p:nvSpPr>
+          <p:cNvPr id="3" name="TextBox 2"/>
+          <p:cNvSpPr txBox="1"/>
+          <p:nvPr/>
+        </p:nvSpPr>
+        <p:spPr>
+          <a:xfrm>
+            <a:off x="502920" y="749808"/>
+            <a:ext cx="11155680" cy="822960"/>
+          </a:xfrm>
+          <a:prstGeom prst="rect">
+            <a:avLst/>
+          </a:prstGeom>
+          <a:noFill/>
+        </p:spPr>
+        <p:txBody>
+          <a:bodyPr wrap="square" lIns="0" rIns="0" tIns="0" bIns="0">
+            <a:spAutoFit/>
+          </a:bodyPr>
+          <a:lstStyle/>
+          <a:p>
+            <a:pPr>
+              <a:spcAft>
+                <a:spcPts val="900"/>
+              </a:spcAft>
+            </a:pPr>
+            <a:r>
+              <a:rPr sz="3000" b="1">
+                <a:solidFill>
+                  <a:srgbClr val="213444"/>
+                </a:solidFill>
+                <a:latin typeface="Microsoft YaHei"/>
+                <a:ea typeface="Microsoft YaHei"/>
+              </a:rPr>
+              <a:t>建议：把表达方案交给对照实验</a:t>
+            </a:r>
+          </a:p>
+        </p:txBody>
+      </p:sp>
+      <p:sp>
+        <p:nvSpPr>
+          <p:cNvPr id="4" name="TextBox 3"/>
+          <p:cNvSpPr txBox="1"/>
+          <p:nvPr/>
+        </p:nvSpPr>
+        <p:spPr>
+          <a:xfrm>
+            <a:off x="731520" y="1874519"/>
+            <a:ext cx="10698480" cy="4297680"/>
+          </a:xfrm>
+          <a:prstGeom prst="rect">
+            <a:avLst/>
+          </a:prstGeom>
+          <a:noFill/>
+        </p:spPr>
+        <p:txBody>
+          <a:bodyPr wrap="square" lIns="0" rIns="0" tIns="0" bIns="0">
+            <a:spAutoFit/>
+          </a:bodyPr>
+          <a:lstStyle/>
+          <a:p>
+            <a:pPr>
+              <a:spcAft>
+                <a:spcPts val="900"/>
+              </a:spcAft>
+            </a:pPr>
+            <a:r>
+              <a:rPr sz="2100" b="0">
+                <a:solidFill>
+                  <a:srgbClr val="213444"/>
+                </a:solidFill>
+                <a:latin typeface="Microsoft YaHei"/>
+                <a:ea typeface="Microsoft YaHei"/>
+              </a:rPr>
+              <a:t>不承诺“加某个词就会涨赞”；先保证真实、完整且易交流的内容。</a:t>
+            </a:r>
+          </a:p>
+          <a:p>
+            <a:pPr>
+              <a:spcAft>
+                <a:spcPts val="900"/>
+              </a:spcAft>
+            </a:pPr>
+            <a:r>
+              <a:rPr sz="2100" b="0">
+                <a:solidFill>
+                  <a:srgbClr val="213444"/>
+                </a:solidFill>
+                <a:latin typeface="Microsoft YaHei"/>
+                <a:ea typeface="Microsoft YaHei"/>
+              </a:rPr>
+              <a:t/>
+            </a:r>
+          </a:p>
+          <a:p>
+            <a:pPr>
+              <a:spcAft>
+                <a:spcPts val="900"/>
+              </a:spcAft>
+            </a:pPr>
+            <a:r>
+              <a:rPr sz="2100" b="0">
+                <a:solidFill>
+                  <a:srgbClr val="213444"/>
+                </a:solidFill>
+                <a:latin typeface="Microsoft YaHei"/>
+                <a:ea typeface="Microsoft YaHei"/>
+              </a:rPr>
+              <a:t>固定观察窗口、记录真实曝光；按作者随机分组评估提示文案。</a:t>
+            </a:r>
+          </a:p>
+          <a:p>
+            <a:pPr>
+              <a:spcAft>
+                <a:spcPts val="900"/>
+              </a:spcAft>
+            </a:pPr>
+            <a:r>
+              <a:rPr sz="2100" b="0">
+                <a:solidFill>
+                  <a:srgbClr val="213444"/>
+                </a:solidFill>
+                <a:latin typeface="Microsoft YaHei"/>
+                <a:ea typeface="Microsoft YaHei"/>
+              </a:rPr>
+              <a:t/>
+            </a:r>
+          </a:p>
+          <a:p>
+            <a:pPr>
+              <a:spcAft>
+                <a:spcPts val="900"/>
+              </a:spcAft>
+            </a:pPr>
+            <a:r>
+              <a:rPr sz="2100" b="0">
+                <a:solidFill>
+                  <a:srgbClr val="213444"/>
+                </a:solidFill>
+                <a:latin typeface="Microsoft YaHei"/>
+                <a:ea typeface="Microsoft YaHei"/>
+              </a:rPr>
+              <a:t>关注低反馈用户与回复质量，同时验证抽样是否造成集中。</a:t>
+            </a:r>
+          </a:p>
+          <a:p>
+            <a:pPr>
+              <a:spcAft>
+                <a:spcPts val="900"/>
+              </a:spcAft>
+            </a:pPr>
+            <a:r>
+              <a:rPr sz="2100" b="0">
+                <a:solidFill>
+                  <a:srgbClr val="213444"/>
+                </a:solidFill>
+                <a:latin typeface="Microsoft YaHei"/>
+                <a:ea typeface="Microsoft YaHei"/>
+              </a:rPr>
+              <a:t/>
+            </a:r>
+          </a:p>
+          <a:p>
+            <a:pPr>
+              <a:spcAft>
+                <a:spcPts val="900"/>
+              </a:spcAft>
+            </a:pPr>
+            <a:r>
+              <a:rPr sz="2100" b="0">
+                <a:solidFill>
+                  <a:srgbClr val="213444"/>
+                </a:solidFill>
+                <a:latin typeface="Microsoft YaHei"/>
+                <a:ea typeface="Microsoft YaHei"/>
+              </a:rPr>
+              <a:t>未执行的实验是后续设计，不是已证实的增长方案。</a:t>
+            </a:r>
+          </a:p>
+        </p:txBody>
+      </p:sp>
+      <p:sp>
+        <p:nvSpPr>
+          <p:cNvPr id="5" name="TextBox 4"/>
+          <p:cNvSpPr txBox="1"/>
+          <p:nvPr/>
+        </p:nvSpPr>
+        <p:spPr>
+          <a:xfrm>
+            <a:off x="502920" y="6419088"/>
+            <a:ext cx="10789920" cy="228600"/>
+          </a:xfrm>
+          <a:prstGeom prst="rect">
+            <a:avLst/>
+          </a:prstGeom>
+          <a:noFill/>
+        </p:spPr>
+        <p:txBody>
+          <a:bodyPr wrap="square" lIns="0" rIns="0" tIns="0" bIns="0">
+            <a:spAutoFit/>
+          </a:bodyPr>
+          <a:lstStyle/>
+          <a:p>
+            <a:pPr>
+              <a:spcAft>
+                <a:spcPts val="900"/>
+              </a:spcAft>
+            </a:pPr>
+            <a:r>
+              <a:rPr sz="1000" b="0">
+                <a:solidFill>
+                  <a:srgbClr val="71818B"/>
+                </a:solidFill>
+                <a:latin typeface="Microsoft YaHei"/>
+                <a:ea typeface="Microsoft YaHei"/>
+              </a:rPr>
+              <a:t>Keep课程样本；观察性分析。全部数值与口径见分析报告及附带结果。</a:t>
+            </a:r>
+          </a:p>
+        </p:txBody>
+      </p:sp>
+      <p:sp>
+        <p:nvSpPr>
+          <p:cNvPr id="6" name="TextBox 5"/>
+          <p:cNvSpPr txBox="1"/>
+          <p:nvPr/>
+        </p:nvSpPr>
+        <p:spPr>
+          <a:xfrm>
+            <a:off x="11201400" y="6419088"/>
+            <a:ext cx="548640" cy="228600"/>
+          </a:xfrm>
+          <a:prstGeom prst="rect">
+            <a:avLst/>
+          </a:prstGeom>
+          <a:noFill/>
+        </p:spPr>
+        <p:txBody>
+          <a:bodyPr wrap="square" lIns="0" rIns="0" tIns="0" bIns="0">
+            <a:spAutoFit/>
+          </a:bodyPr>
+          <a:lstStyle/>
+          <a:p>
+            <a:pPr>
+              <a:spcAft>
+                <a:spcPts val="900"/>
+              </a:spcAft>
+            </a:pPr>
+            <a:r>
+              <a:rPr sz="1000" b="0">
+                <a:solidFill>
+                  <a:srgbClr val="356D9A"/>
+                </a:solidFill>
+                <a:latin typeface="Microsoft YaHei"/>
+                <a:ea typeface="Microsoft YaHei"/>
+              </a:rPr>
+              <a:t>21</a:t>
+            </a:r>
+          </a:p>
+        </p:txBody>
+      </p:sp>
+    </p:spTree>
+  </p:cSld>
+  <p:clrMapOvr>
+    <a:masterClrMapping/>
+  </p:clrMapOvr>
+</p:sld>
+</file>
+
+<file path=ppt/slides/slide22.xml><?xml version="1.0" encoding="utf-8"?>
+<p:sld xmlns:a="http://schemas.openxmlformats.org/drawingml/2006/main" xmlns:p="http://schemas.openxmlformats.org/presentationml/2006/main" xmlns:r="http://schemas.openxmlformats.org/officeDocument/2006/relationships">
+  <p:cSld>
+    <p:bg>
+      <p:bgPr>
+        <a:solidFill>
+          <a:srgbClr val="FFFFFF"/>
+        </a:solidFill>
+        <a:effectLst/>
+      </p:bgPr>
+    </p:bg>
+    <p:spTree>
+      <p:nvGrpSpPr>
+        <p:cNvPr id="1" name=""/>
+        <p:cNvGrpSpPr/>
+        <p:nvPr/>
+      </p:nvGrpSpPr>
+      <p:grpSpPr/>
+      <p:sp>
+        <p:nvSpPr>
+          <p:cNvPr id="2" name="TextBox 1"/>
+          <p:cNvSpPr txBox="1"/>
+          <p:nvPr/>
+        </p:nvSpPr>
+        <p:spPr>
+          <a:xfrm>
+            <a:off x="502920" y="256032"/>
+            <a:ext cx="10972800" cy="274320"/>
+          </a:xfrm>
+          <a:prstGeom prst="rect">
+            <a:avLst/>
+          </a:prstGeom>
+          <a:noFill/>
+        </p:spPr>
+        <p:txBody>
+          <a:bodyPr wrap="square" lIns="0" rIns="0" tIns="0" bIns="0">
+            <a:spAutoFit/>
+          </a:bodyPr>
+          <a:lstStyle/>
+          <a:p>
+            <a:pPr>
+              <a:spcAft>
+                <a:spcPts val="900"/>
+              </a:spcAft>
+            </a:pPr>
+            <a:r>
+              <a:rPr sz="1100" b="0">
+                <a:solidFill>
+                  <a:srgbClr val="356D9A"/>
+                </a:solidFill>
+                <a:latin typeface="Microsoft YaHei"/>
+                <a:ea typeface="Microsoft YaHei"/>
+              </a:rPr>
+              <a:t>KEEP COMMUNITY  /  小组项目  /  22</a:t>
+            </a:r>
+          </a:p>
+        </p:txBody>
+      </p:sp>
+      <p:sp>
+        <p:nvSpPr>
+          <p:cNvPr id="3" name="TextBox 2"/>
+          <p:cNvSpPr txBox="1"/>
+          <p:nvPr/>
+        </p:nvSpPr>
+        <p:spPr>
+          <a:xfrm>
+            <a:off x="502920" y="749808"/>
+            <a:ext cx="11155680" cy="822960"/>
+          </a:xfrm>
+          <a:prstGeom prst="rect">
+            <a:avLst/>
+          </a:prstGeom>
+          <a:noFill/>
+        </p:spPr>
+        <p:txBody>
+          <a:bodyPr wrap="square" lIns="0" rIns="0" tIns="0" bIns="0">
+            <a:spAutoFit/>
+          </a:bodyPr>
+          <a:lstStyle/>
+          <a:p>
+            <a:pPr>
+              <a:spcAft>
+                <a:spcPts val="900"/>
+              </a:spcAft>
+            </a:pPr>
+            <a:r>
+              <a:rPr sz="3000" b="1">
+                <a:solidFill>
+                  <a:srgbClr val="213444"/>
+                </a:solidFill>
+                <a:latin typeface="Microsoft YaHei"/>
+                <a:ea typeface="Microsoft YaHei"/>
+              </a:rPr>
+              <a:t>结论、局限与可复现性</a:t>
+            </a:r>
+          </a:p>
+        </p:txBody>
+      </p:sp>
+      <p:sp>
+        <p:nvSpPr>
+          <p:cNvPr id="4" name="TextBox 3"/>
+          <p:cNvSpPr txBox="1"/>
+          <p:nvPr/>
+        </p:nvSpPr>
+        <p:spPr>
+          <a:xfrm>
+            <a:off x="731520" y="1874519"/>
+            <a:ext cx="10698480" cy="4297680"/>
+          </a:xfrm>
+          <a:prstGeom prst="rect">
+            <a:avLst/>
+          </a:prstGeom>
+          <a:noFill/>
+        </p:spPr>
+        <p:txBody>
+          <a:bodyPr wrap="square" lIns="0" rIns="0" tIns="0" bIns="0">
+            <a:spAutoFit/>
+          </a:bodyPr>
+          <a:lstStyle/>
+          <a:p>
+            <a:pPr>
+              <a:spcAft>
+                <a:spcPts val="900"/>
+              </a:spcAft>
+            </a:pPr>
+            <a:r>
+              <a:rPr sz="2100" b="0">
+                <a:solidFill>
+                  <a:srgbClr val="213444"/>
+                </a:solidFill>
+                <a:latin typeface="Microsoft YaHei"/>
+                <a:ea typeface="Microsoft YaHei"/>
+              </a:rPr>
+              <a:t>词典、主题与留出评估均未提供稳定的文本增益证据。</a:t>
+            </a:r>
+          </a:p>
+          <a:p>
+            <a:pPr>
+              <a:spcAft>
+                <a:spcPts val="900"/>
+              </a:spcAft>
+            </a:pPr>
+            <a:r>
+              <a:rPr sz="2100" b="0">
+                <a:solidFill>
+                  <a:srgbClr val="213444"/>
+                </a:solidFill>
+                <a:latin typeface="Microsoft YaHei"/>
+                <a:ea typeface="Microsoft YaHei"/>
+              </a:rPr>
+              <a:t/>
+            </a:r>
+          </a:p>
+          <a:p>
+            <a:pPr>
+              <a:spcAft>
+                <a:spcPts val="900"/>
+              </a:spcAft>
+            </a:pPr>
+            <a:r>
+              <a:rPr sz="2100" b="0">
+                <a:solidFill>
+                  <a:srgbClr val="213444"/>
+                </a:solidFill>
+                <a:latin typeface="Microsoft YaHei"/>
+                <a:ea typeface="Microsoft YaHei"/>
+              </a:rPr>
+              <a:t>100位作者课程样本，抽样机制不明；正文/视觉缺失；曝光和统一采集时点未知。</a:t>
+            </a:r>
+          </a:p>
+          <a:p>
+            <a:pPr>
+              <a:spcAft>
+                <a:spcPts val="900"/>
+              </a:spcAft>
+            </a:pPr>
+            <a:r>
+              <a:rPr sz="2100" b="0">
+                <a:solidFill>
+                  <a:srgbClr val="213444"/>
+                </a:solidFill>
+                <a:latin typeface="Microsoft YaHei"/>
+                <a:ea typeface="Microsoft YaHei"/>
+              </a:rPr>
+              <a:t/>
+            </a:r>
+          </a:p>
+          <a:p>
+            <a:pPr>
+              <a:spcAft>
+                <a:spcPts val="900"/>
+              </a:spcAft>
+            </a:pPr>
+            <a:r>
+              <a:rPr sz="2100" b="0">
+                <a:solidFill>
+                  <a:srgbClr val="213444"/>
+                </a:solidFill>
+                <a:latin typeface="Microsoft YaHei"/>
+                <a:ea typeface="Microsoft YaHei"/>
+              </a:rPr>
+              <a:t>代码、原始Keep数据、特征表、回归结果与已执行Notebook全部随附。</a:t>
+            </a:r>
+          </a:p>
+          <a:p>
+            <a:pPr>
+              <a:spcAft>
+                <a:spcPts val="900"/>
+              </a:spcAft>
+            </a:pPr>
+            <a:r>
+              <a:rPr sz="2100" b="0">
+                <a:solidFill>
+                  <a:srgbClr val="213444"/>
+                </a:solidFill>
+                <a:latin typeface="Microsoft YaHei"/>
+                <a:ea typeface="Microsoft YaHei"/>
+              </a:rPr>
+              <a:t/>
+            </a:r>
+          </a:p>
+          <a:p>
+            <a:pPr>
+              <a:spcAft>
+                <a:spcPts val="900"/>
+              </a:spcAft>
+            </a:pPr>
+            <a:r>
+              <a:rPr sz="2100" b="0">
+                <a:solidFill>
+                  <a:srgbClr val="213444"/>
+                </a:solidFill>
+                <a:latin typeface="Microsoft YaHei"/>
+                <a:ea typeface="Microsoft YaHei"/>
+              </a:rPr>
+              <a:t>数值独立复核；填好组号、成员后按课程要求打包提交。</a:t>
+            </a:r>
+          </a:p>
+        </p:txBody>
+      </p:sp>
+      <p:sp>
+        <p:nvSpPr>
+          <p:cNvPr id="5" name="TextBox 4"/>
+          <p:cNvSpPr txBox="1"/>
+          <p:nvPr/>
+        </p:nvSpPr>
+        <p:spPr>
+          <a:xfrm>
+            <a:off x="502920" y="6419088"/>
+            <a:ext cx="10789920" cy="228600"/>
+          </a:xfrm>
+          <a:prstGeom prst="rect">
+            <a:avLst/>
+          </a:prstGeom>
+          <a:noFill/>
+        </p:spPr>
+        <p:txBody>
+          <a:bodyPr wrap="square" lIns="0" rIns="0" tIns="0" bIns="0">
+            <a:spAutoFit/>
+          </a:bodyPr>
+          <a:lstStyle/>
+          <a:p>
+            <a:pPr>
+              <a:spcAft>
+                <a:spcPts val="900"/>
+              </a:spcAft>
+            </a:pPr>
+            <a:r>
+              <a:rPr sz="1000" b="0">
+                <a:solidFill>
+                  <a:srgbClr val="71818B"/>
+                </a:solidFill>
+                <a:latin typeface="Microsoft YaHei"/>
+                <a:ea typeface="Microsoft YaHei"/>
+              </a:rPr>
+              <a:t>Keep课程样本；观察性分析。全部数值与口径见分析报告及附带结果。</a:t>
+            </a:r>
+          </a:p>
+        </p:txBody>
+      </p:sp>
+      <p:sp>
+        <p:nvSpPr>
+          <p:cNvPr id="6" name="TextBox 5"/>
+          <p:cNvSpPr txBox="1"/>
+          <p:nvPr/>
+        </p:nvSpPr>
+        <p:spPr>
+          <a:xfrm>
+            <a:off x="11201400" y="6419088"/>
+            <a:ext cx="548640" cy="228600"/>
+          </a:xfrm>
+          <a:prstGeom prst="rect">
+            <a:avLst/>
+          </a:prstGeom>
+          <a:noFill/>
+        </p:spPr>
+        <p:txBody>
+          <a:bodyPr wrap="square" lIns="0" rIns="0" tIns="0" bIns="0">
+            <a:spAutoFit/>
+          </a:bodyPr>
+          <a:lstStyle/>
+          <a:p>
+            <a:pPr>
+              <a:spcAft>
+                <a:spcPts val="900"/>
+              </a:spcAft>
+            </a:pPr>
+            <a:r>
+              <a:rPr sz="1000" b="0">
+                <a:solidFill>
+                  <a:srgbClr val="356D9A"/>
+                </a:solidFill>
+                <a:latin typeface="Microsoft YaHei"/>
+                <a:ea typeface="Microsoft YaHei"/>
+              </a:rPr>
+              <a:t>22</a:t>
+            </a:r>
+          </a:p>
+        </p:txBody>
+      </p:sp>
+    </p:spTree>
+  </p:cSld>
+  <p:clrMapOvr>
+    <a:masterClrMapping/>
+  </p:clrMapOvr>
+</p:sld>
+</file>
+
+<file path=ppt/slides/slide23.xml><?xml version="1.0" encoding="utf-8"?>
+<p:sld xmlns:a="http://schemas.openxmlformats.org/drawingml/2006/main" xmlns:p="http://schemas.openxmlformats.org/presentationml/2006/main" xmlns:r="http://schemas.openxmlformats.org/officeDocument/2006/relationships">
+  <p:cSld>
+    <p:bg>
+      <p:bgPr>
+        <a:solidFill>
+          <a:srgbClr val="FFFFFF"/>
+        </a:solidFill>
+        <a:effectLst/>
+      </p:bgPr>
+    </p:bg>
+    <p:spTree>
+      <p:nvGrpSpPr>
+        <p:cNvPr id="1" name=""/>
+        <p:cNvGrpSpPr/>
+        <p:nvPr/>
+      </p:nvGrpSpPr>
+      <p:grpSpPr/>
+      <p:sp>
+        <p:nvSpPr>
+          <p:cNvPr id="2" name="TextBox 1"/>
+          <p:cNvSpPr txBox="1"/>
+          <p:nvPr/>
+        </p:nvSpPr>
+        <p:spPr>
+          <a:xfrm>
+            <a:off x="502920" y="256032"/>
+            <a:ext cx="10972800" cy="274320"/>
+          </a:xfrm>
+          <a:prstGeom prst="rect">
+            <a:avLst/>
+          </a:prstGeom>
+          <a:noFill/>
+        </p:spPr>
+        <p:txBody>
+          <a:bodyPr wrap="square" lIns="0" rIns="0" tIns="0" bIns="0">
+            <a:spAutoFit/>
+          </a:bodyPr>
+          <a:lstStyle/>
+          <a:p>
+            <a:pPr>
+              <a:spcAft>
+                <a:spcPts val="900"/>
+              </a:spcAft>
+            </a:pPr>
+            <a:r>
+              <a:rPr sz="1100" b="0">
+                <a:solidFill>
+                  <a:srgbClr val="356D9A"/>
+                </a:solidFill>
+                <a:latin typeface="Microsoft YaHei"/>
+                <a:ea typeface="Microsoft YaHei"/>
+              </a:rPr>
+              <a:t>KEEP COMMUNITY  /  小组项目  /  23</a:t>
+            </a:r>
+          </a:p>
+        </p:txBody>
+      </p:sp>
+      <p:sp>
+        <p:nvSpPr>
+          <p:cNvPr id="3" name="TextBox 2"/>
+          <p:cNvSpPr txBox="1"/>
+          <p:nvPr/>
+        </p:nvSpPr>
+        <p:spPr>
+          <a:xfrm>
+            <a:off x="502920" y="749808"/>
+            <a:ext cx="11155680" cy="822960"/>
+          </a:xfrm>
+          <a:prstGeom prst="rect">
+            <a:avLst/>
+          </a:prstGeom>
+          <a:noFill/>
+        </p:spPr>
+        <p:txBody>
+          <a:bodyPr wrap="square" lIns="0" rIns="0" tIns="0" bIns="0">
+            <a:spAutoFit/>
+          </a:bodyPr>
+          <a:lstStyle/>
+          <a:p>
+            <a:pPr>
+              <a:spcAft>
+                <a:spcPts val="900"/>
+              </a:spcAft>
+            </a:pPr>
+            <a:r>
+              <a:rPr sz="3000" b="1">
+                <a:solidFill>
+                  <a:srgbClr val="213444"/>
+                </a:solidFill>
+                <a:latin typeface="Microsoft YaHei"/>
+                <a:ea typeface="Microsoft YaHei"/>
+              </a:rPr>
+              <a:t>小组分工与讨论</a:t>
+            </a:r>
+          </a:p>
+        </p:txBody>
+      </p:sp>
+      <p:sp>
+        <p:nvSpPr>
+          <p:cNvPr id="4" name="TextBox 3"/>
+          <p:cNvSpPr txBox="1"/>
+          <p:nvPr/>
+        </p:nvSpPr>
+        <p:spPr>
+          <a:xfrm>
+            <a:off x="731520" y="1874519"/>
+            <a:ext cx="10698480" cy="4297680"/>
+          </a:xfrm>
+          <a:prstGeom prst="rect">
+            <a:avLst/>
+          </a:prstGeom>
+          <a:noFill/>
+        </p:spPr>
+        <p:txBody>
+          <a:bodyPr wrap="square" lIns="0" rIns="0" tIns="0" bIns="0">
+            <a:spAutoFit/>
+          </a:bodyPr>
+          <a:lstStyle/>
+          <a:p>
+            <a:pPr>
+              <a:spcAft>
+                <a:spcPts val="900"/>
+              </a:spcAft>
+            </a:pPr>
+            <a:r>
+              <a:rPr sz="2100" b="0">
+                <a:solidFill>
+                  <a:srgbClr val="213444"/>
+                </a:solidFill>
+                <a:latin typeface="Microsoft YaHei"/>
+                <a:ea typeface="Microsoft YaHei"/>
+              </a:rPr>
+              <a:t>成员A【待填写】：研究问题与背景（1—3页）</a:t>
+            </a:r>
+          </a:p>
+          <a:p>
+            <a:pPr>
+              <a:spcAft>
+                <a:spcPts val="900"/>
+              </a:spcAft>
+            </a:pPr>
+            <a:r>
+              <a:rPr sz="2100" b="0">
+                <a:solidFill>
+                  <a:srgbClr val="213444"/>
+                </a:solidFill>
+                <a:latin typeface="Microsoft YaHei"/>
+                <a:ea typeface="Microsoft YaHei"/>
+              </a:rPr>
+              <a:t/>
+            </a:r>
+          </a:p>
+          <a:p>
+            <a:pPr>
+              <a:spcAft>
+                <a:spcPts val="900"/>
+              </a:spcAft>
+            </a:pPr>
+            <a:r>
+              <a:rPr sz="2100" b="0">
+                <a:solidFill>
+                  <a:srgbClr val="213444"/>
+                </a:solidFill>
+                <a:latin typeface="Microsoft YaHei"/>
+                <a:ea typeface="Microsoft YaHei"/>
+              </a:rPr>
+              <a:t>成员B【待填写】：数据、文本与主题（4—10页）</a:t>
+            </a:r>
+          </a:p>
+          <a:p>
+            <a:pPr>
+              <a:spcAft>
+                <a:spcPts val="900"/>
+              </a:spcAft>
+            </a:pPr>
+            <a:r>
+              <a:rPr sz="2100" b="0">
+                <a:solidFill>
+                  <a:srgbClr val="213444"/>
+                </a:solidFill>
+                <a:latin typeface="Microsoft YaHei"/>
+                <a:ea typeface="Microsoft YaHei"/>
+              </a:rPr>
+              <a:t/>
+            </a:r>
+          </a:p>
+          <a:p>
+            <a:pPr>
+              <a:spcAft>
+                <a:spcPts val="900"/>
+              </a:spcAft>
+            </a:pPr>
+            <a:r>
+              <a:rPr sz="2100" b="0">
+                <a:solidFill>
+                  <a:srgbClr val="213444"/>
+                </a:solidFill>
+                <a:latin typeface="Microsoft YaHei"/>
+                <a:ea typeface="Microsoft YaHei"/>
+              </a:rPr>
+              <a:t>成员C【待填写】：回归、预测与检验（11—17页）</a:t>
+            </a:r>
+          </a:p>
+          <a:p>
+            <a:pPr>
+              <a:spcAft>
+                <a:spcPts val="900"/>
+              </a:spcAft>
+            </a:pPr>
+            <a:r>
+              <a:rPr sz="2100" b="0">
+                <a:solidFill>
+                  <a:srgbClr val="213444"/>
+                </a:solidFill>
+                <a:latin typeface="Microsoft YaHei"/>
+                <a:ea typeface="Microsoft YaHei"/>
+              </a:rPr>
+              <a:t/>
+            </a:r>
+          </a:p>
+          <a:p>
+            <a:pPr>
+              <a:spcAft>
+                <a:spcPts val="900"/>
+              </a:spcAft>
+            </a:pPr>
+            <a:r>
+              <a:rPr sz="2100" b="0">
+                <a:solidFill>
+                  <a:srgbClr val="213444"/>
+                </a:solidFill>
+                <a:latin typeface="Microsoft YaHei"/>
+                <a:ea typeface="Microsoft YaHei"/>
+              </a:rPr>
+              <a:t>成员D【待填写】：网络、建议与总结（18—23页）</a:t>
+            </a:r>
+          </a:p>
+          <a:p>
+            <a:pPr>
+              <a:spcAft>
+                <a:spcPts val="900"/>
+              </a:spcAft>
+            </a:pPr>
+            <a:r>
+              <a:rPr sz="2100" b="0">
+                <a:solidFill>
+                  <a:srgbClr val="213444"/>
+                </a:solidFill>
+                <a:latin typeface="Microsoft YaHei"/>
+                <a:ea typeface="Microsoft YaHei"/>
+              </a:rPr>
+              <a:t/>
+            </a:r>
+          </a:p>
+          <a:p>
+            <a:pPr>
+              <a:spcAft>
+                <a:spcPts val="900"/>
+              </a:spcAft>
+            </a:pPr>
+            <a:r>
+              <a:rPr sz="2100" b="0">
+                <a:solidFill>
+                  <a:srgbClr val="213444"/>
+                </a:solidFill>
+                <a:latin typeface="Microsoft YaHei"/>
+                <a:ea typeface="Microsoft YaHei"/>
+              </a:rPr>
+              <a:t>建议分工须按真实人数和贡献修订。</a:t>
+            </a:r>
+          </a:p>
+        </p:txBody>
+      </p:sp>
+      <p:sp>
+        <p:nvSpPr>
+          <p:cNvPr id="5" name="TextBox 4"/>
+          <p:cNvSpPr txBox="1"/>
+          <p:nvPr/>
+        </p:nvSpPr>
+        <p:spPr>
+          <a:xfrm>
+            <a:off x="502920" y="6419088"/>
+            <a:ext cx="10789920" cy="228600"/>
+          </a:xfrm>
+          <a:prstGeom prst="rect">
+            <a:avLst/>
+          </a:prstGeom>
+          <a:noFill/>
+        </p:spPr>
+        <p:txBody>
+          <a:bodyPr wrap="square" lIns="0" rIns="0" tIns="0" bIns="0">
+            <a:spAutoFit/>
+          </a:bodyPr>
+          <a:lstStyle/>
+          <a:p>
+            <a:pPr>
+              <a:spcAft>
+                <a:spcPts val="900"/>
+              </a:spcAft>
+            </a:pPr>
+            <a:r>
+              <a:rPr sz="1000" b="0">
+                <a:solidFill>
+                  <a:srgbClr val="71818B"/>
+                </a:solidFill>
+                <a:latin typeface="Microsoft YaHei"/>
+                <a:ea typeface="Microsoft YaHei"/>
+              </a:rPr>
+              <a:t>Keep课程样本；观察性分析。全部数值与口径见分析报告及附带结果。</a:t>
+            </a:r>
+          </a:p>
+        </p:txBody>
+      </p:sp>
+      <p:sp>
+        <p:nvSpPr>
+          <p:cNvPr id="6" name="TextBox 5"/>
+          <p:cNvSpPr txBox="1"/>
+          <p:nvPr/>
+        </p:nvSpPr>
+        <p:spPr>
+          <a:xfrm>
+            <a:off x="11201400" y="6419088"/>
+            <a:ext cx="548640" cy="228600"/>
+          </a:xfrm>
+          <a:prstGeom prst="rect">
+            <a:avLst/>
+          </a:prstGeom>
+          <a:noFill/>
+        </p:spPr>
+        <p:txBody>
+          <a:bodyPr wrap="square" lIns="0" rIns="0" tIns="0" bIns="0">
+            <a:spAutoFit/>
+          </a:bodyPr>
+          <a:lstStyle/>
+          <a:p>
+            <a:pPr>
+              <a:spcAft>
+                <a:spcPts val="900"/>
+              </a:spcAft>
+            </a:pPr>
+            <a:r>
+              <a:rPr sz="1000" b="0">
+                <a:solidFill>
+                  <a:srgbClr val="356D9A"/>
+                </a:solidFill>
+                <a:latin typeface="Microsoft YaHei"/>
+                <a:ea typeface="Microsoft YaHei"/>
+              </a:rPr>
+              <a:t>23</a:t>
             </a:r>
           </a:p>
         </p:txBody>
@@ -8172,14 +10891,14 @@
                 <a:latin typeface="Microsoft YaHei"/>
                 <a:ea typeface="Microsoft YaHei"/>
               </a:rPr>
-              <a:t>点赞分布存在长尾</a:t>
+              <a:t>正文覆盖取决于帖子形式与作者</a:t>
             </a:r>
           </a:p>
         </p:txBody>
       </p:sp>
       <p:pic>
         <p:nvPicPr>
-          <p:cNvPr id="4" name="Picture 3" descr="01_sample_and_likes.png"/>
+          <p:cNvPr id="4" name="Picture 3" descr="08_text_coverage.png"/>
           <p:cNvPicPr>
             <a:picLocks noChangeAspect="1"/>
           </p:cNvPicPr>
@@ -8193,8 +10912,8 @@
         </p:blipFill>
         <p:spPr>
           <a:xfrm>
-            <a:off x="480060" y="2650122"/>
-            <a:ext cx="7452360" cy="2426435"/>
+            <a:off x="480060" y="2645838"/>
+            <a:ext cx="7452360" cy="2435002"/>
           </a:xfrm>
           <a:prstGeom prst="rect">
             <a:avLst/>
@@ -8236,7 +10955,7 @@
                 <a:latin typeface="Microsoft YaHei"/>
                 <a:ea typeface="Microsoft YaHei"/>
               </a:rPr>
-              <a:t>均值37.05，中位数25，最大5,126；零点赞占3.8%。</a:t>
+              <a:t>无媒体帖正文覆盖率0.1%，图片76.0%，视频89.1%，纯文字100%。</a:t>
             </a:r>
           </a:p>
           <a:p>
@@ -8270,7 +10989,7 @@
                 <a:latin typeface="Microsoft YaHei"/>
                 <a:ea typeface="Microsoft YaHei"/>
               </a:rPr>
-              <a:t>用ln(1+点赞数)；按作者聚类；另检查计数模型。</a:t>
+              <a:t>5位作者无可用正文；26位作者全部帖子有正文。</a:t>
             </a:r>
           </a:p>
           <a:p>
@@ -8304,7 +11023,7 @@
                 <a:latin typeface="Microsoft YaHei"/>
                 <a:ea typeface="Microsoft YaHei"/>
               </a:rPr>
-              <a:t>首末本地日期不完整，不解释末尾下降为活跃度骤降。</a:t>
+              <a:t>保留缺失指示和形式控制；主题分析只使用信息较充分的正文。</a:t>
             </a:r>
           </a:p>
         </p:txBody>
@@ -8490,21 +11209,45 @@
                 <a:latin typeface="Microsoft YaHei"/>
                 <a:ea typeface="Microsoft YaHei"/>
               </a:rPr>
-              <a:t>如何把正文变成回归变量</a:t>
-            </a:r>
-          </a:p>
-        </p:txBody>
-      </p:sp>
-      <p:sp>
-        <p:nvSpPr>
-          <p:cNvPr id="4" name="TextBox 3"/>
+              <a:t>点赞分布存在长尾</a:t>
+            </a:r>
+          </a:p>
+        </p:txBody>
+      </p:sp>
+      <p:pic>
+        <p:nvPicPr>
+          <p:cNvPr id="4" name="Picture 3" descr="01_sample_and_likes.png"/>
+          <p:cNvPicPr>
+            <a:picLocks noChangeAspect="1"/>
+          </p:cNvPicPr>
+          <p:nvPr/>
+        </p:nvPicPr>
+        <p:blipFill>
+          <a:blip r:embed="rId2"/>
+          <a:stretch>
+            <a:fillRect/>
+          </a:stretch>
+        </p:blipFill>
+        <p:spPr>
+          <a:xfrm>
+            <a:off x="480060" y="2650122"/>
+            <a:ext cx="7452360" cy="2426435"/>
+          </a:xfrm>
+          <a:prstGeom prst="rect">
+            <a:avLst/>
+          </a:prstGeom>
+        </p:spPr>
+      </p:pic>
+      <p:sp>
+        <p:nvSpPr>
+          <p:cNvPr id="5" name="TextBox 4"/>
           <p:cNvSpPr txBox="1"/>
           <p:nvPr/>
         </p:nvSpPr>
         <p:spPr>
           <a:xfrm>
-            <a:off x="731520" y="1874519"/>
-            <a:ext cx="10698480" cy="4297680"/>
+            <a:off x="8229600" y="1828800"/>
+            <a:ext cx="3383280" cy="4297680"/>
           </a:xfrm>
           <a:prstGeom prst="rect">
             <a:avLst/>
@@ -8523,24 +11266,24 @@
               </a:spcAft>
             </a:pPr>
             <a:r>
-              <a:rPr sz="2400" b="0">
-                <a:solidFill>
-                  <a:srgbClr val="213444"/>
-                </a:solidFill>
-                <a:latin typeface="Microsoft YaHei"/>
-                <a:ea typeface="Microsoft YaHei"/>
-              </a:rPr>
-              <a:t>核心变量：长度、自律/目标词、社交称呼/互助词、积极表达词、问号。</a:t>
-            </a:r>
-          </a:p>
-          <a:p>
-            <a:pPr>
-              <a:spcAft>
-                <a:spcPts val="900"/>
-              </a:spcAft>
-            </a:pPr>
-            <a:r>
-              <a:rPr sz="2400" b="0">
+              <a:rPr sz="1900" b="0">
+                <a:solidFill>
+                  <a:srgbClr val="213444"/>
+                </a:solidFill>
+                <a:latin typeface="Microsoft YaHei"/>
+                <a:ea typeface="Microsoft YaHei"/>
+              </a:rPr>
+              <a:t>均值37.05，中位数25，最大5,126；零点赞占3.8%。</a:t>
+            </a:r>
+          </a:p>
+          <a:p>
+            <a:pPr>
+              <a:spcAft>
+                <a:spcPts val="900"/>
+              </a:spcAft>
+            </a:pPr>
+            <a:r>
+              <a:rPr sz="1900" b="0">
                 <a:solidFill>
                   <a:srgbClr val="213444"/>
                 </a:solidFill>
@@ -8557,24 +11300,24 @@
               </a:spcAft>
             </a:pPr>
             <a:r>
-              <a:rPr sz="2400" b="0">
-                <a:solidFill>
-                  <a:srgbClr val="213444"/>
-                </a:solidFill>
-                <a:latin typeface="Microsoft YaHei"/>
-                <a:ea typeface="Microsoft YaHei"/>
-              </a:rPr>
-              <a:t>清理URL、课程后缀、表情标记；话题标签单独编码。</a:t>
-            </a:r>
-          </a:p>
-          <a:p>
-            <a:pPr>
-              <a:spcAft>
-                <a:spcPts val="900"/>
-              </a:spcAft>
-            </a:pPr>
-            <a:r>
-              <a:rPr sz="2400" b="0">
+              <a:rPr sz="1900" b="0">
+                <a:solidFill>
+                  <a:srgbClr val="213444"/>
+                </a:solidFill>
+                <a:latin typeface="Microsoft YaHei"/>
+                <a:ea typeface="Microsoft YaHei"/>
+              </a:rPr>
+              <a:t>用ln(1+点赞数)；按作者聚类；另检查计数模型。</a:t>
+            </a:r>
+          </a:p>
+          <a:p>
+            <a:pPr>
+              <a:spcAft>
+                <a:spcPts val="900"/>
+              </a:spcAft>
+            </a:pPr>
+            <a:r>
+              <a:rPr sz="1900" b="0">
                 <a:solidFill>
                   <a:srgbClr val="213444"/>
                 </a:solidFill>
@@ -8591,21 +11334,21 @@
               </a:spcAft>
             </a:pPr>
             <a:r>
-              <a:rPr sz="2400" b="0">
-                <a:solidFill>
-                  <a:srgbClr val="213444"/>
-                </a:solidFill>
-                <a:latin typeface="Microsoft YaHei"/>
-                <a:ea typeface="Microsoft YaHei"/>
-              </a:rPr>
-              <a:t>词典命中可重叠；只表示字面表达，不是心理或情感量表。</a:t>
-            </a:r>
-          </a:p>
-        </p:txBody>
-      </p:sp>
-      <p:sp>
-        <p:nvSpPr>
-          <p:cNvPr id="5" name="TextBox 4"/>
+              <a:rPr sz="1900" b="0">
+                <a:solidFill>
+                  <a:srgbClr val="213444"/>
+                </a:solidFill>
+                <a:latin typeface="Microsoft YaHei"/>
+                <a:ea typeface="Microsoft YaHei"/>
+              </a:rPr>
+              <a:t>首末本地日期不完整，不解释末尾下降为活跃度骤降。</a:t>
+            </a:r>
+          </a:p>
+        </p:txBody>
+      </p:sp>
+      <p:sp>
+        <p:nvSpPr>
+          <p:cNvPr id="6" name="TextBox 5"/>
           <p:cNvSpPr txBox="1"/>
           <p:nvPr/>
         </p:nvSpPr>
@@ -8645,7 +11388,7 @@
       </p:sp>
       <p:sp>
         <p:nvSpPr>
-          <p:cNvPr id="6" name="TextBox 5"/>
+          <p:cNvPr id="7" name="TextBox 6"/>
           <p:cNvSpPr txBox="1"/>
           <p:nvPr/>
         </p:nvSpPr>
@@ -8784,35 +11527,119 @@
                 <a:latin typeface="Microsoft YaHei"/>
                 <a:ea typeface="Microsoft YaHei"/>
               </a:rPr>
-              <a:t>文本规模：注意分母和低频特征</a:t>
-            </a:r>
-          </a:p>
-        </p:txBody>
-      </p:sp>
-      <p:pic>
-        <p:nvPicPr>
-          <p:cNvPr id="4" name="Picture 3" descr="03_text_features.png"/>
-          <p:cNvPicPr>
-            <a:picLocks noChangeAspect="1"/>
-          </p:cNvPicPr>
+              <a:t>如何把正文变成回归变量</a:t>
+            </a:r>
+          </a:p>
+        </p:txBody>
+      </p:sp>
+      <p:sp>
+        <p:nvSpPr>
+          <p:cNvPr id="4" name="TextBox 3"/>
+          <p:cNvSpPr txBox="1"/>
           <p:nvPr/>
-        </p:nvPicPr>
-        <p:blipFill>
-          <a:blip r:embed="rId2"/>
-          <a:stretch>
-            <a:fillRect/>
-          </a:stretch>
-        </p:blipFill>
-        <p:spPr>
-          <a:xfrm>
-            <a:off x="480060" y="2580225"/>
-            <a:ext cx="7452360" cy="2566229"/>
-          </a:xfrm>
-          <a:prstGeom prst="rect">
-            <a:avLst/>
-          </a:prstGeom>
-        </p:spPr>
-      </p:pic>
+        </p:nvSpPr>
+        <p:spPr>
+          <a:xfrm>
+            <a:off x="731520" y="1874519"/>
+            <a:ext cx="10698480" cy="4297680"/>
+          </a:xfrm>
+          <a:prstGeom prst="rect">
+            <a:avLst/>
+          </a:prstGeom>
+          <a:noFill/>
+        </p:spPr>
+        <p:txBody>
+          <a:bodyPr wrap="square" lIns="0" rIns="0" tIns="0" bIns="0">
+            <a:spAutoFit/>
+          </a:bodyPr>
+          <a:lstStyle/>
+          <a:p>
+            <a:pPr>
+              <a:spcAft>
+                <a:spcPts val="900"/>
+              </a:spcAft>
+            </a:pPr>
+            <a:r>
+              <a:rPr sz="2400" b="0">
+                <a:solidFill>
+                  <a:srgbClr val="213444"/>
+                </a:solidFill>
+                <a:latin typeface="Microsoft YaHei"/>
+                <a:ea typeface="Microsoft YaHei"/>
+              </a:rPr>
+              <a:t>核心变量：长度、自律/目标词、社交称呼/互助词、积极表达词、问号。</a:t>
+            </a:r>
+          </a:p>
+          <a:p>
+            <a:pPr>
+              <a:spcAft>
+                <a:spcPts val="900"/>
+              </a:spcAft>
+            </a:pPr>
+            <a:r>
+              <a:rPr sz="2400" b="0">
+                <a:solidFill>
+                  <a:srgbClr val="213444"/>
+                </a:solidFill>
+                <a:latin typeface="Microsoft YaHei"/>
+                <a:ea typeface="Microsoft YaHei"/>
+              </a:rPr>
+              <a:t/>
+            </a:r>
+          </a:p>
+          <a:p>
+            <a:pPr>
+              <a:spcAft>
+                <a:spcPts val="900"/>
+              </a:spcAft>
+            </a:pPr>
+            <a:r>
+              <a:rPr sz="2400" b="0">
+                <a:solidFill>
+                  <a:srgbClr val="213444"/>
+                </a:solidFill>
+                <a:latin typeface="Microsoft YaHei"/>
+                <a:ea typeface="Microsoft YaHei"/>
+              </a:rPr>
+              <a:t>清理URL、课程后缀、表情标记；话题标签单独编码。</a:t>
+            </a:r>
+          </a:p>
+          <a:p>
+            <a:pPr>
+              <a:spcAft>
+                <a:spcPts val="900"/>
+              </a:spcAft>
+            </a:pPr>
+            <a:r>
+              <a:rPr sz="2400" b="0">
+                <a:solidFill>
+                  <a:srgbClr val="213444"/>
+                </a:solidFill>
+                <a:latin typeface="Microsoft YaHei"/>
+                <a:ea typeface="Microsoft YaHei"/>
+              </a:rPr>
+              <a:t/>
+            </a:r>
+          </a:p>
+          <a:p>
+            <a:pPr>
+              <a:spcAft>
+                <a:spcPts val="900"/>
+              </a:spcAft>
+            </a:pPr>
+            <a:r>
+              <a:rPr sz="2400" b="0">
+                <a:solidFill>
+                  <a:srgbClr val="213444"/>
+                </a:solidFill>
+                <a:latin typeface="Microsoft YaHei"/>
+                <a:ea typeface="Microsoft YaHei"/>
+              </a:rPr>
+              <a:t>词典命中可重叠；只表示字面表达，不是心理或情感量表。</a:t>
+            </a:r>
+          </a:p>
+        </p:txBody>
+      </p:sp>
       <p:sp>
         <p:nvSpPr>
           <p:cNvPr id="5" name="TextBox 4"/>
@@ -8821,8 +11648,8 @@
         </p:nvSpPr>
         <p:spPr>
           <a:xfrm>
-            <a:off x="8229600" y="1828800"/>
-            <a:ext cx="3383280" cy="4297680"/>
+            <a:off x="502920" y="6419088"/>
+            <a:ext cx="10789920" cy="228600"/>
           </a:xfrm>
           <a:prstGeom prst="rect">
             <a:avLst/>
@@ -8841,82 +11668,14 @@
               </a:spcAft>
             </a:pPr>
             <a:r>
-              <a:rPr sz="1900" b="0">
-                <a:solidFill>
-                  <a:srgbClr val="213444"/>
-                </a:solidFill>
-                <a:latin typeface="Microsoft YaHei"/>
-                <a:ea typeface="Microsoft YaHei"/>
-              </a:rPr>
-              <a:t>自律/目标词877帖：全部帖9.2%；可见正文15.8%。</a:t>
-            </a:r>
-          </a:p>
-          <a:p>
-            <a:pPr>
-              <a:spcAft>
-                <a:spcPts val="900"/>
-              </a:spcAft>
-            </a:pPr>
-            <a:r>
-              <a:rPr sz="1900" b="0">
-                <a:solidFill>
-                  <a:srgbClr val="213444"/>
-                </a:solidFill>
-                <a:latin typeface="Microsoft YaHei"/>
-                <a:ea typeface="Microsoft YaHei"/>
-              </a:rPr>
-              <a:t/>
-            </a:r>
-          </a:p>
-          <a:p>
-            <a:pPr>
-              <a:spcAft>
-                <a:spcPts val="900"/>
-              </a:spcAft>
-            </a:pPr>
-            <a:r>
-              <a:rPr sz="1900" b="0">
-                <a:solidFill>
-                  <a:srgbClr val="213444"/>
-                </a:solidFill>
-                <a:latin typeface="Microsoft YaHei"/>
-                <a:ea typeface="Microsoft YaHei"/>
-              </a:rPr>
-              <a:t>社交词159帖；问号125帖，提供作者内变化的人数较少。</a:t>
-            </a:r>
-          </a:p>
-          <a:p>
-            <a:pPr>
-              <a:spcAft>
-                <a:spcPts val="900"/>
-              </a:spcAft>
-            </a:pPr>
-            <a:r>
-              <a:rPr sz="1900" b="0">
-                <a:solidFill>
-                  <a:srgbClr val="213444"/>
-                </a:solidFill>
-                <a:latin typeface="Microsoft YaHei"/>
-                <a:ea typeface="Microsoft YaHei"/>
-              </a:rPr>
-              <a:t/>
-            </a:r>
-          </a:p>
-          <a:p>
-            <a:pPr>
-              <a:spcAft>
-                <a:spcPts val="900"/>
-              </a:spcAft>
-            </a:pPr>
-            <a:r>
-              <a:rPr sz="1900" b="0">
-                <a:solidFill>
-                  <a:srgbClr val="213444"/>
-                </a:solidFill>
-                <a:latin typeface="Microsoft YaHei"/>
-                <a:ea typeface="Microsoft YaHei"/>
-              </a:rPr>
-              <a:t>高频词是逐帖去重后的文档频数，不能当作效果证据。</a:t>
+              <a:rPr sz="1000" b="0">
+                <a:solidFill>
+                  <a:srgbClr val="71818B"/>
+                </a:solidFill>
+                <a:latin typeface="Microsoft YaHei"/>
+                <a:ea typeface="Microsoft YaHei"/>
+              </a:rPr>
+              <a:t>Keep课程样本；观察性分析。全部数值与口径见分析报告及附带结果。</a:t>
             </a:r>
           </a:p>
         </p:txBody>
@@ -8924,46 +11683,6 @@
       <p:sp>
         <p:nvSpPr>
           <p:cNvPr id="6" name="TextBox 5"/>
-          <p:cNvSpPr txBox="1"/>
-          <p:nvPr/>
-        </p:nvSpPr>
-        <p:spPr>
-          <a:xfrm>
-            <a:off x="502920" y="6419088"/>
-            <a:ext cx="10789920" cy="228600"/>
-          </a:xfrm>
-          <a:prstGeom prst="rect">
-            <a:avLst/>
-          </a:prstGeom>
-          <a:noFill/>
-        </p:spPr>
-        <p:txBody>
-          <a:bodyPr wrap="square" lIns="0" rIns="0" tIns="0" bIns="0">
-            <a:spAutoFit/>
-          </a:bodyPr>
-          <a:lstStyle/>
-          <a:p>
-            <a:pPr>
-              <a:spcAft>
-                <a:spcPts val="900"/>
-              </a:spcAft>
-            </a:pPr>
-            <a:r>
-              <a:rPr sz="1000" b="0">
-                <a:solidFill>
-                  <a:srgbClr val="71818B"/>
-                </a:solidFill>
-                <a:latin typeface="Microsoft YaHei"/>
-                <a:ea typeface="Microsoft YaHei"/>
-              </a:rPr>
-              <a:t>Keep课程样本；观察性分析。全部数值与口径见分析报告及附带结果。</a:t>
-            </a:r>
-          </a:p>
-        </p:txBody>
-      </p:sp>
-      <p:sp>
-        <p:nvSpPr>
-          <p:cNvPr id="7" name="TextBox 6"/>
           <p:cNvSpPr txBox="1"/>
           <p:nvPr/>
         </p:nvSpPr>
@@ -9102,21 +11821,45 @@
                 <a:latin typeface="Microsoft YaHei"/>
                 <a:ea typeface="Microsoft YaHei"/>
               </a:rPr>
-              <a:t>主模型：控制作者和日期</a:t>
-            </a:r>
-          </a:p>
-        </p:txBody>
-      </p:sp>
-      <p:sp>
-        <p:nvSpPr>
-          <p:cNvPr id="4" name="TextBox 3"/>
+              <a:t>文本规模：注意分母和低频特征</a:t>
+            </a:r>
+          </a:p>
+        </p:txBody>
+      </p:sp>
+      <p:pic>
+        <p:nvPicPr>
+          <p:cNvPr id="4" name="Picture 3" descr="03_text_features.png"/>
+          <p:cNvPicPr>
+            <a:picLocks noChangeAspect="1"/>
+          </p:cNvPicPr>
+          <p:nvPr/>
+        </p:nvPicPr>
+        <p:blipFill>
+          <a:blip r:embed="rId2"/>
+          <a:stretch>
+            <a:fillRect/>
+          </a:stretch>
+        </p:blipFill>
+        <p:spPr>
+          <a:xfrm>
+            <a:off x="480060" y="2580225"/>
+            <a:ext cx="7452360" cy="2566229"/>
+          </a:xfrm>
+          <a:prstGeom prst="rect">
+            <a:avLst/>
+          </a:prstGeom>
+        </p:spPr>
+      </p:pic>
+      <p:sp>
+        <p:nvSpPr>
+          <p:cNvPr id="5" name="TextBox 4"/>
           <p:cNvSpPr txBox="1"/>
           <p:nvPr/>
         </p:nvSpPr>
         <p:spPr>
           <a:xfrm>
-            <a:off x="731520" y="1874519"/>
-            <a:ext cx="10698480" cy="4297680"/>
+            <a:off x="8229600" y="1828800"/>
+            <a:ext cx="3383280" cy="4297680"/>
           </a:xfrm>
           <a:prstGeom prst="rect">
             <a:avLst/>
@@ -9135,24 +11878,24 @@
               </a:spcAft>
             </a:pPr>
             <a:r>
-              <a:rPr sz="2100" b="0">
-                <a:solidFill>
-                  <a:srgbClr val="213444"/>
-                </a:solidFill>
-                <a:latin typeface="Microsoft YaHei"/>
-                <a:ea typeface="Microsoft YaHei"/>
-              </a:rPr>
-              <a:t>因变量 ln(1+likes)；全部9,532帖，100位作者。</a:t>
-            </a:r>
-          </a:p>
-          <a:p>
-            <a:pPr>
-              <a:spcAft>
-                <a:spcPts val="900"/>
-              </a:spcAft>
-            </a:pPr>
-            <a:r>
-              <a:rPr sz="2100" b="0">
+              <a:rPr sz="1900" b="0">
+                <a:solidFill>
+                  <a:srgbClr val="213444"/>
+                </a:solidFill>
+                <a:latin typeface="Microsoft YaHei"/>
+                <a:ea typeface="Microsoft YaHei"/>
+              </a:rPr>
+              <a:t>自律/目标词877帖：全部帖9.2%；可见正文15.8%。</a:t>
+            </a:r>
+          </a:p>
+          <a:p>
+            <a:pPr>
+              <a:spcAft>
+                <a:spcPts val="900"/>
+              </a:spcAft>
+            </a:pPr>
+            <a:r>
+              <a:rPr sz="1900" b="0">
                 <a:solidFill>
                   <a:srgbClr val="213444"/>
                 </a:solidFill>
@@ -9169,24 +11912,24 @@
               </a:spcAft>
             </a:pPr>
             <a:r>
-              <a:rPr sz="2100" b="0">
-                <a:solidFill>
-                  <a:srgbClr val="213444"/>
-                </a:solidFill>
-                <a:latin typeface="Microsoft YaHei"/>
-                <a:ea typeface="Microsoft YaHei"/>
-              </a:rPr>
-              <a:t>作者固定效应 + 日期固定效应 + 内容形式/类型/时段及文本标记。</a:t>
-            </a:r>
-          </a:p>
-          <a:p>
-            <a:pPr>
-              <a:spcAft>
-                <a:spcPts val="900"/>
-              </a:spcAft>
-            </a:pPr>
-            <a:r>
-              <a:rPr sz="2100" b="0">
+              <a:rPr sz="1900" b="0">
+                <a:solidFill>
+                  <a:srgbClr val="213444"/>
+                </a:solidFill>
+                <a:latin typeface="Microsoft YaHei"/>
+                <a:ea typeface="Microsoft YaHei"/>
+              </a:rPr>
+              <a:t>社交词159帖；问号125帖，提供作者内变化的人数较少。</a:t>
+            </a:r>
+          </a:p>
+          <a:p>
+            <a:pPr>
+              <a:spcAft>
+                <a:spcPts val="900"/>
+              </a:spcAft>
+            </a:pPr>
+            <a:r>
+              <a:rPr sz="1900" b="0">
                 <a:solidFill>
                   <a:srgbClr val="213444"/>
                 </a:solidFill>
@@ -9203,55 +11946,21 @@
               </a:spcAft>
             </a:pPr>
             <a:r>
-              <a:rPr sz="2100" b="0">
-                <a:solidFill>
-                  <a:srgbClr val="213444"/>
-                </a:solidFill>
-                <a:latin typeface="Microsoft YaHei"/>
-                <a:ea typeface="Microsoft YaHei"/>
-              </a:rPr>
-              <a:t>作者聚类CR1标准误；t分布df=99；五项核心检验BH校正。</a:t>
-            </a:r>
-          </a:p>
-          <a:p>
-            <a:pPr>
-              <a:spcAft>
-                <a:spcPts val="900"/>
-              </a:spcAft>
-            </a:pPr>
-            <a:r>
-              <a:rPr sz="2100" b="0">
-                <a:solidFill>
-                  <a:srgbClr val="213444"/>
-                </a:solidFill>
-                <a:latin typeface="Microsoft YaHei"/>
-                <a:ea typeface="Microsoft YaHei"/>
-              </a:rPr>
-              <a:t/>
-            </a:r>
-          </a:p>
-          <a:p>
-            <a:pPr>
-              <a:spcAft>
-                <a:spcPts val="900"/>
-              </a:spcAft>
-            </a:pPr>
-            <a:r>
-              <a:rPr sz="2100" b="0">
-                <a:solidFill>
-                  <a:srgbClr val="213444"/>
-                </a:solidFill>
-                <a:latin typeface="Microsoft YaHei"/>
-                <a:ea typeface="Microsoft YaHei"/>
-              </a:rPr>
-              <a:t>作者内不变的性别、会员、等级等由作者固定效应吸收。</a:t>
-            </a:r>
-          </a:p>
-        </p:txBody>
-      </p:sp>
-      <p:sp>
-        <p:nvSpPr>
-          <p:cNvPr id="5" name="TextBox 4"/>
+              <a:rPr sz="1900" b="0">
+                <a:solidFill>
+                  <a:srgbClr val="213444"/>
+                </a:solidFill>
+                <a:latin typeface="Microsoft YaHei"/>
+                <a:ea typeface="Microsoft YaHei"/>
+              </a:rPr>
+              <a:t>高频词是逐帖去重后的文档频数，不能当作效果证据。</a:t>
+            </a:r>
+          </a:p>
+        </p:txBody>
+      </p:sp>
+      <p:sp>
+        <p:nvSpPr>
+          <p:cNvPr id="6" name="TextBox 5"/>
           <p:cNvSpPr txBox="1"/>
           <p:nvPr/>
         </p:nvSpPr>
@@ -9291,7 +12000,7 @@
       </p:sp>
       <p:sp>
         <p:nvSpPr>
-          <p:cNvPr id="6" name="TextBox 5"/>
+          <p:cNvPr id="7" name="TextBox 6"/>
           <p:cNvSpPr txBox="1"/>
           <p:nvPr/>
         </p:nvSpPr>
@@ -9430,14 +12139,14 @@
                 <a:latin typeface="Microsoft YaHei"/>
                 <a:ea typeface="Microsoft YaHei"/>
               </a:rPr>
-              <a:t>主结果：没有明确的高赞用词公式</a:t>
+              <a:t>NMF补充识别内容表达模式</a:t>
             </a:r>
           </a:p>
         </p:txBody>
       </p:sp>
       <p:pic>
         <p:nvPicPr>
-          <p:cNvPr id="4" name="Picture 3" descr="04_main_coefficients.png"/>
+          <p:cNvPr id="4" name="Picture 3" descr="09_topics.png"/>
           <p:cNvPicPr>
             <a:picLocks noChangeAspect="1"/>
           </p:cNvPicPr>
@@ -9451,8 +12160,8 @@
         </p:blipFill>
         <p:spPr>
           <a:xfrm>
-            <a:off x="480060" y="2397089"/>
-            <a:ext cx="7452360" cy="2932501"/>
+            <a:off x="480060" y="2519060"/>
+            <a:ext cx="7452360" cy="2688558"/>
           </a:xfrm>
           <a:prstGeom prst="rect">
             <a:avLst/>
@@ -9494,7 +12203,7 @@
                 <a:latin typeface="Microsoft YaHei"/>
                 <a:ea typeface="Microsoft YaHei"/>
               </a:rPr>
-              <a:t>五项核心特征联合检验p=0.130；新增R²仅0.065个百分点。</a:t>
+              <a:t>2,470帖、86位作者，1,046词项；主题数固定为5。</a:t>
             </a:r>
           </a:p>
           <a:p>
@@ -9528,7 +12237,7 @@
                 <a:latin typeface="Microsoft YaHei"/>
                 <a:ea typeface="Microsoft YaHei"/>
               </a:rPr>
-              <a:t>积极表达词β=-0.086；原始p=0.016，BH q=0.079。</a:t>
+              <a:t>运动与训练交流52.7%，生活感悟与问候35.8%。</a:t>
             </a:r>
           </a:p>
           <a:p>
@@ -9562,7 +12271,7 @@
                 <a:latin typeface="Microsoft YaHei"/>
                 <a:ea typeface="Microsoft YaHei"/>
               </a:rPr>
-              <a:t>不显著不是证明无作用；现有测量下证据不足。</a:t>
+              <a:t>静蹲、骑行主题集中于少数作者，反映重复记录习惯。</a:t>
             </a:r>
           </a:p>
         </p:txBody>

</xml_diff>

<commit_message>
Remove prediction branch from formal report and presentation
</commit_message>
<xml_diff>
--- a/演示文稿.pptx
+++ b/演示文稿.pptx
@@ -26,8 +26,6 @@
     <p:sldId id="274" r:id="rId26"/>
     <p:sldId id="275" r:id="rId27"/>
     <p:sldId id="276" r:id="rId28"/>
-    <p:sldId id="277" r:id="rId29"/>
-    <p:sldId id="278" r:id="rId30"/>
   </p:sldIdLst>
   <p:sldSz cx="12191969" cy="6858000" type="screen4x3"/>
   <p:notesSz cx="6858000" cy="9144000"/>
@@ -944,7 +942,7 @@
           <a:lstStyle/>
           <a:p>
             <a:r>
-              <a:t>岭回归alpha固定10，未在测试集调参。字符TF-IDF是2至4元组。因标签观察窗与作者属性历史时戳缺失，这不是实际部署评估。</a:t>
+              <a:t>这是方法上的边界检查。规则本身能复现不代表语义测量有效，未命中也不等于没有表达。没有使用结果来反复修改词典以获取显著系数。</a:t>
             </a:r>
           </a:p>
         </p:txBody>
@@ -1014,7 +1012,7 @@
           <a:lstStyle/>
           <a:p>
             <a:r>
-              <a:t>误差尺度为ln(1+点赞数)。区间以2000次作者聚类重采样固定预测结果得到，未重新训练模型。指标表及全部模型对照见报告。</a:t>
+              <a:t>不要把所有回复都连向帖主。评论最晚到2021年8月，所以网络指标不作为发帖前影响力加入回归。金色表示样本作者，蓝色表示其他参与者；节点大小按加权入度对数缩放。</a:t>
             </a:r>
           </a:p>
         </p:txBody>
@@ -1084,7 +1082,7 @@
           <a:lstStyle/>
           <a:p>
             <a:r>
-              <a:t>这是方法上的边界检查。规则本身能复现不代表语义测量有效，未命中也不等于没有表达。没有使用结果来反复修改词典以获取显著系数。</a:t>
+              <a:t>样本从100位作者帖子出发，根评论天然指向帖主，会形成中心。互惠率按有反向边的有向边占比，不按权重；两个网络节点集合不同，不能解释为行为下降。</a:t>
             </a:r>
           </a:p>
         </p:txBody>
@@ -1154,7 +1152,7 @@
           <a:lstStyle/>
           <a:p>
             <a:r>
-              <a:t>不要把所有回复都连向帖主。评论最晚到2021年8月，所以网络指标不作为发帖前影响力加入回归。金色表示样本作者，蓝色表示其他参与者；节点大小按加权入度对数缩放。</a:t>
+              <a:t>比例都以已采集记录为条件。首次帖主回应的中位时延2.05小时仅在观测到回应的线程中计算，未见回应不等于没有回应。</a:t>
             </a:r>
           </a:p>
         </p:txBody>
@@ -1224,7 +1222,7 @@
           <a:lstStyle/>
           <a:p>
             <a:r>
-              <a:t>样本从100位作者帖子出发，根评论天然指向帖主，会形成中心。互惠率按有反向边的有向边占比，不按权重；两个网络节点集合不同，不能解释为行为下降。</a:t>
+              <a:t>提出用户层面随机分组，避免同作者跨组污染；三组可为过程记录提示、面向伙伴问题提示和常规发布，固定7天，样本量先做试点再计算。不宣称已发现提升方案。</a:t>
             </a:r>
           </a:p>
         </p:txBody>
@@ -1294,7 +1292,7 @@
           <a:lstStyle/>
           <a:p>
             <a:r>
-              <a:t>用四个问题串联描述、解释与建议。强调研究观察统计关联，不能回答改写文案是否会因果提高点赞。</a:t>
+              <a:t>用三个问题串联描述、解释与建议。强调研究观察统计关联，不能回答改写文案是否会因果提高点赞。</a:t>
             </a:r>
           </a:p>
         </p:txBody>
@@ -1364,7 +1362,7 @@
           <a:lstStyle/>
           <a:p>
             <a:r>
-              <a:t>比例都以已采集记录为条件。首次帖主回应的中位时延2.05小时仅在观测到回应的线程中计算，未见回应不等于没有回应。</a:t>
+              <a:t>回到三个研究问题，概括内容分布、条件关联和互动结构的结果。主题、作者剔除及评论时序属于探索性补充，完整参数及输出见附带Notebook与代码。</a:t>
             </a:r>
           </a:p>
         </p:txBody>
@@ -1390,146 +1388,6 @@
 </file>
 
 <file path=ppt/notesSlides/notesSlide21.xml><?xml version="1.0" encoding="utf-8"?>
-<p:notes xmlns:a="http://schemas.openxmlformats.org/drawingml/2006/main" xmlns:p="http://schemas.openxmlformats.org/presentationml/2006/main" xmlns:r="http://schemas.openxmlformats.org/officeDocument/2006/relationships">
-  <p:cSld>
-    <p:spTree>
-      <p:nvGrpSpPr>
-        <p:cNvPr id="1" name=""/>
-        <p:cNvGrpSpPr/>
-        <p:nvPr/>
-      </p:nvGrpSpPr>
-      <p:grpSpPr>
-        <a:xfrm>
-          <a:off x="0" y="0"/>
-          <a:ext cx="0" cy="0"/>
-          <a:chOff x="0" y="0"/>
-          <a:chExt cx="0" cy="0"/>
-        </a:xfrm>
-      </p:grpSpPr>
-      <p:sp>
-        <p:nvSpPr>
-          <p:cNvPr id="2" name="Slide Image Placeholder 1"/>
-          <p:cNvSpPr>
-            <a:spLocks noGrp="1"/>
-          </p:cNvSpPr>
-          <p:nvPr>
-            <p:ph type="sldImg" idx="2"/>
-          </p:nvPr>
-        </p:nvSpPr>
-        <p:spPr/>
-      </p:sp>
-      <p:sp>
-        <p:nvSpPr>
-          <p:cNvPr id="3" name="Notes Placeholder 2"/>
-          <p:cNvSpPr>
-            <a:spLocks noGrp="1"/>
-          </p:cNvSpPr>
-          <p:nvPr>
-            <p:ph type="body" idx="3" sz="quarter"/>
-          </p:nvPr>
-        </p:nvSpPr>
-        <p:spPr/>
-        <p:txBody>
-          <a:bodyPr/>
-          <a:lstStyle/>
-          <a:p>
-            <a:r>
-              <a:t>提出用户层面随机分组，避免同作者跨组污染；三组可为过程记录提示、面向伙伴问题提示和常规发布，固定7天，样本量先做试点再计算。不宣称已发现提升方案。</a:t>
-            </a:r>
-          </a:p>
-        </p:txBody>
-      </p:sp>
-      <p:sp>
-        <p:nvSpPr>
-          <p:cNvPr id="4" name="Slide Number Placeholder 3"/>
-          <p:cNvSpPr>
-            <a:spLocks noGrp="1"/>
-          </p:cNvSpPr>
-          <p:nvPr>
-            <p:ph type="sldNum" idx="5" sz="quarter"/>
-          </p:nvPr>
-        </p:nvSpPr>
-        <p:spPr/>
-      </p:sp>
-    </p:spTree>
-  </p:cSld>
-  <p:clrMapOvr>
-    <a:masterClrMapping/>
-  </p:clrMapOvr>
-</p:notes>
-</file>
-
-<file path=ppt/notesSlides/notesSlide22.xml><?xml version="1.0" encoding="utf-8"?>
-<p:notes xmlns:a="http://schemas.openxmlformats.org/drawingml/2006/main" xmlns:p="http://schemas.openxmlformats.org/presentationml/2006/main" xmlns:r="http://schemas.openxmlformats.org/officeDocument/2006/relationships">
-  <p:cSld>
-    <p:spTree>
-      <p:nvGrpSpPr>
-        <p:cNvPr id="1" name=""/>
-        <p:cNvGrpSpPr/>
-        <p:nvPr/>
-      </p:nvGrpSpPr>
-      <p:grpSpPr>
-        <a:xfrm>
-          <a:off x="0" y="0"/>
-          <a:ext cx="0" cy="0"/>
-          <a:chOff x="0" y="0"/>
-          <a:chExt cx="0" cy="0"/>
-        </a:xfrm>
-      </p:grpSpPr>
-      <p:sp>
-        <p:nvSpPr>
-          <p:cNvPr id="2" name="Slide Image Placeholder 1"/>
-          <p:cNvSpPr>
-            <a:spLocks noGrp="1"/>
-          </p:cNvSpPr>
-          <p:nvPr>
-            <p:ph type="sldImg" idx="2"/>
-          </p:nvPr>
-        </p:nvSpPr>
-        <p:spPr/>
-      </p:sp>
-      <p:sp>
-        <p:nvSpPr>
-          <p:cNvPr id="3" name="Notes Placeholder 2"/>
-          <p:cNvSpPr>
-            <a:spLocks noGrp="1"/>
-          </p:cNvSpPr>
-          <p:nvPr>
-            <p:ph type="body" idx="3" sz="quarter"/>
-          </p:nvPr>
-        </p:nvSpPr>
-        <p:spPr/>
-        <p:txBody>
-          <a:bodyPr/>
-          <a:lstStyle/>
-          <a:p>
-            <a:r>
-              <a:t>回到四个研究问题，概括内容分布、条件关联、预测增量和互动结构的结果。扩展分析为探索性工作，完整参数及输出见附带Notebook与代码。</a:t>
-            </a:r>
-          </a:p>
-        </p:txBody>
-      </p:sp>
-      <p:sp>
-        <p:nvSpPr>
-          <p:cNvPr id="4" name="Slide Number Placeholder 3"/>
-          <p:cNvSpPr>
-            <a:spLocks noGrp="1"/>
-          </p:cNvSpPr>
-          <p:nvPr>
-            <p:ph type="sldNum" idx="5" sz="quarter"/>
-          </p:nvPr>
-        </p:nvSpPr>
-        <p:spPr/>
-      </p:sp>
-    </p:spTree>
-  </p:cSld>
-  <p:clrMapOvr>
-    <a:masterClrMapping/>
-  </p:clrMapOvr>
-</p:notes>
-</file>
-
-<file path=ppt/notesSlides/notesSlide23.xml><?xml version="1.0" encoding="utf-8"?>
 <p:notes xmlns:a="http://schemas.openxmlformats.org/drawingml/2006/main" xmlns:p="http://schemas.openxmlformats.org/presentationml/2006/main" xmlns:r="http://schemas.openxmlformats.org/officeDocument/2006/relationships">
   <p:cSld>
     <p:spTree>
@@ -7023,7 +6881,7 @@
                 <a:latin typeface="Microsoft YaHei"/>
                 <a:ea typeface="Microsoft YaHei"/>
               </a:rPr>
-              <a:t>预测对照：文本是否帮助样本外泛化？</a:t>
+              <a:t>词典测量也需要接受检查</a:t>
             </a:r>
           </a:p>
         </p:txBody>
@@ -7063,7 +6921,7 @@
                 <a:latin typeface="Microsoft YaHei"/>
                 <a:ea typeface="Microsoft YaHei"/>
               </a:rPr>
-              <a:t>时间留出：7,098帖训练、2,434帖测试。</a:t>
+              <a:t>40个帖子—特征检查单元：按规则命中分层抽样，无点赞展示。</a:t>
             </a:r>
           </a:p>
           <a:p>
@@ -7097,7 +6955,7 @@
                 <a:latin typeface="Microsoft YaHei"/>
                 <a:ea typeface="Microsoft YaHei"/>
               </a:rPr>
-              <a:t>作者分组五折：同一作者只在一个测试折出现。</a:t>
+              <a:t>“完成”可能指绘画；“一起”可能描述线下朋友；问号可能是反问。</a:t>
             </a:r>
           </a:p>
           <a:p>
@@ -7131,7 +6989,7 @@
                 <a:latin typeface="Microsoft YaHei"/>
                 <a:ea typeface="Microsoft YaHei"/>
               </a:rPr>
-              <a:t>同一划分比较均值、结构化、加词典、加字符文本；编码仅拟合训练集。</a:t>
+              <a:t>Codex辅助抽查，未做独立人工双编码；不宣称准确率。</a:t>
             </a:r>
           </a:p>
         </p:txBody>
@@ -7317,14 +7175,14 @@
                 <a:latin typeface="Microsoft YaHei"/>
                 <a:ea typeface="Microsoft YaHei"/>
               </a:rPr>
-              <a:t>两种留出评估均未显示稳定的文本增益</a:t>
+              <a:t>评论网络：明确每条边的指向</a:t>
             </a:r>
           </a:p>
         </p:txBody>
       </p:sp>
       <p:pic>
         <p:nvPicPr>
-          <p:cNvPr id="4" name="Picture 3" descr="10_prediction_comparison.png"/>
+          <p:cNvPr id="4" name="Picture 3" descr="06_comment_network.png"/>
           <p:cNvPicPr>
             <a:picLocks noChangeAspect="1"/>
           </p:cNvPicPr>
@@ -7338,8 +7196,8 @@
         </p:blipFill>
         <p:spPr>
           <a:xfrm>
-            <a:off x="480060" y="2616990"/>
-            <a:ext cx="7452360" cy="2492698"/>
+            <a:off x="578279" y="1851660"/>
+            <a:ext cx="7255921" cy="4023360"/>
           </a:xfrm>
           <a:prstGeom prst="rect">
             <a:avLst/>
@@ -7381,7 +7239,7 @@
                 <a:latin typeface="Microsoft YaHei"/>
                 <a:ea typeface="Microsoft YaHei"/>
               </a:rPr>
-              <a:t>时间留出MAE：结构化0.5641，加字符文本0.5656。</a:t>
+              <a:t>根评论：评论者→帖主；明确回复：回复者→replyUserId。</a:t>
             </a:r>
           </a:p>
           <a:p>
@@ -7415,7 +7273,7 @@
                 <a:latin typeface="Microsoft YaHei"/>
                 <a:ea typeface="Microsoft YaHei"/>
               </a:rPr>
-              <a:t>作者分组MAE：结构化0.7180，加字符文本0.7164。</a:t>
+              <a:t>去重后移除84次自我互动；11,511事件合并为4,069条边。</a:t>
             </a:r>
           </a:p>
           <a:p>
@@ -7449,7 +7307,7 @@
                 <a:latin typeface="Microsoft YaHei"/>
                 <a:ea typeface="Microsoft YaHei"/>
               </a:rPr>
-              <a:t>配对作者聚类区间均跨0；未见正文子集也未改变判断。</a:t>
+              <a:t>2,932个有边节点；箭头在图中省略，原数据保持有向。</a:t>
             </a:r>
           </a:p>
         </p:txBody>
@@ -7635,21 +7493,45 @@
                 <a:latin typeface="Microsoft YaHei"/>
                 <a:ea typeface="Microsoft YaHei"/>
               </a:rPr>
-              <a:t>词典测量也需要接受检查</a:t>
-            </a:r>
-          </a:p>
-        </p:txBody>
-      </p:sp>
-      <p:sp>
-        <p:nvSpPr>
-          <p:cNvPr id="4" name="TextBox 3"/>
+              <a:t>互动集中，但样本边界影响很大</a:t>
+            </a:r>
+          </a:p>
+        </p:txBody>
+      </p:sp>
+      <p:pic>
+        <p:nvPicPr>
+          <p:cNvPr id="4" name="Picture 3" descr="07_network_concentration.png"/>
+          <p:cNvPicPr>
+            <a:picLocks noChangeAspect="1"/>
+          </p:cNvPicPr>
+          <p:nvPr/>
+        </p:nvPicPr>
+        <p:blipFill>
+          <a:blip r:embed="rId2"/>
+          <a:stretch>
+            <a:fillRect/>
+          </a:stretch>
+        </p:blipFill>
+        <p:spPr>
+          <a:xfrm>
+            <a:off x="480060" y="2614975"/>
+            <a:ext cx="7452360" cy="2496729"/>
+          </a:xfrm>
+          <a:prstGeom prst="rect">
+            <a:avLst/>
+          </a:prstGeom>
+        </p:spPr>
+      </p:pic>
+      <p:sp>
+        <p:nvSpPr>
+          <p:cNvPr id="5" name="TextBox 4"/>
           <p:cNvSpPr txBox="1"/>
           <p:nvPr/>
         </p:nvSpPr>
         <p:spPr>
           <a:xfrm>
-            <a:off x="731520" y="1874519"/>
-            <a:ext cx="10698480" cy="4297680"/>
+            <a:off x="8229600" y="1828800"/>
+            <a:ext cx="3383280" cy="4297680"/>
           </a:xfrm>
           <a:prstGeom prst="rect">
             <a:avLst/>
@@ -7668,24 +7550,24 @@
               </a:spcAft>
             </a:pPr>
             <a:r>
-              <a:rPr sz="2400" b="0">
-                <a:solidFill>
-                  <a:srgbClr val="213444"/>
-                </a:solidFill>
-                <a:latin typeface="Microsoft YaHei"/>
-                <a:ea typeface="Microsoft YaHei"/>
-              </a:rPr>
-              <a:t>40个帖子—特征检查单元：按规则命中分层抽样，无点赞展示。</a:t>
-            </a:r>
-          </a:p>
-          <a:p>
-            <a:pPr>
-              <a:spcAft>
-                <a:spcPts val="900"/>
-              </a:spcAft>
-            </a:pPr>
-            <a:r>
-              <a:rPr sz="2400" b="0">
+              <a:rPr sz="1900" b="0">
+                <a:solidFill>
+                  <a:srgbClr val="213444"/>
+                </a:solidFill>
+                <a:latin typeface="Microsoft YaHei"/>
+                <a:ea typeface="Microsoft YaHei"/>
+              </a:rPr>
+              <a:t>前10位接收者获得54.0%互动；第一位12.0%。</a:t>
+            </a:r>
+          </a:p>
+          <a:p>
+            <a:pPr>
+              <a:spcAft>
+                <a:spcPts val="900"/>
+              </a:spcAft>
+            </a:pPr>
+            <a:r>
+              <a:rPr sz="1900" b="0">
                 <a:solidFill>
                   <a:srgbClr val="213444"/>
                 </a:solidFill>
@@ -7702,24 +7584,24 @@
               </a:spcAft>
             </a:pPr>
             <a:r>
-              <a:rPr sz="2400" b="0">
-                <a:solidFill>
-                  <a:srgbClr val="213444"/>
-                </a:solidFill>
-                <a:latin typeface="Microsoft YaHei"/>
-                <a:ea typeface="Microsoft YaHei"/>
-              </a:rPr>
-              <a:t>“完成”可能指绘画；“一起”可能描述线下朋友；问号可能是反问。</a:t>
-            </a:r>
-          </a:p>
-          <a:p>
-            <a:pPr>
-              <a:spcAft>
-                <a:spcPts val="900"/>
-              </a:spcAft>
-            </a:pPr>
-            <a:r>
-              <a:rPr sz="2400" b="0">
+              <a:rPr sz="1900" b="0">
+                <a:solidFill>
+                  <a:srgbClr val="213444"/>
+                </a:solidFill>
+                <a:latin typeface="Microsoft YaHei"/>
+                <a:ea typeface="Microsoft YaHei"/>
+              </a:rPr>
+              <a:t>整体互惠率49.6%；仅明确回复子网络29.9%。</a:t>
+            </a:r>
+          </a:p>
+          <a:p>
+            <a:pPr>
+              <a:spcAft>
+                <a:spcPts val="900"/>
+              </a:spcAft>
+            </a:pPr>
+            <a:r>
+              <a:rPr sz="1900" b="0">
                 <a:solidFill>
                   <a:srgbClr val="213444"/>
                 </a:solidFill>
@@ -7736,21 +7618,21 @@
               </a:spcAft>
             </a:pPr>
             <a:r>
-              <a:rPr sz="2400" b="0">
-                <a:solidFill>
-                  <a:srgbClr val="213444"/>
-                </a:solidFill>
-                <a:latin typeface="Microsoft YaHei"/>
-                <a:ea typeface="Microsoft YaHei"/>
-              </a:rPr>
-              <a:t>Codex辅助抽查，未做独立人工双编码；不宣称准确率。</a:t>
-            </a:r>
-          </a:p>
-        </p:txBody>
-      </p:sp>
-      <p:sp>
-        <p:nvSpPr>
-          <p:cNvPr id="5" name="TextBox 4"/>
+              <a:rPr sz="1900" b="0">
+                <a:solidFill>
+                  <a:srgbClr val="213444"/>
+                </a:solidFill>
+                <a:latin typeface="Microsoft YaHei"/>
+                <a:ea typeface="Microsoft YaHei"/>
+              </a:rPr>
+              <a:t>这是采集网络的接收事件数，不是平台影响力或独立粉丝数。</a:t>
+            </a:r>
+          </a:p>
+        </p:txBody>
+      </p:sp>
+      <p:sp>
+        <p:nvSpPr>
+          <p:cNvPr id="6" name="TextBox 5"/>
           <p:cNvSpPr txBox="1"/>
           <p:nvPr/>
         </p:nvSpPr>
@@ -7790,7 +7672,7 @@
       </p:sp>
       <p:sp>
         <p:nvSpPr>
-          <p:cNvPr id="6" name="TextBox 5"/>
+          <p:cNvPr id="7" name="TextBox 6"/>
           <p:cNvSpPr txBox="1"/>
           <p:nvPr/>
         </p:nvSpPr>
@@ -7929,14 +7811,14 @@
                 <a:latin typeface="Microsoft YaHei"/>
                 <a:ea typeface="Microsoft YaHei"/>
               </a:rPr>
-              <a:t>评论网络：明确每条边的指向</a:t>
+              <a:t>网络互惠主要体现围绕帖主的回应</a:t>
             </a:r>
           </a:p>
         </p:txBody>
       </p:sp>
       <p:pic>
         <p:nvPicPr>
-          <p:cNvPr id="4" name="Picture 3" descr="06_comment_network.png"/>
+          <p:cNvPr id="4" name="Picture 3" descr="13_comment_timing_roles.png"/>
           <p:cNvPicPr>
             <a:picLocks noChangeAspect="1"/>
           </p:cNvPicPr>
@@ -7950,8 +7832,8 @@
         </p:blipFill>
         <p:spPr>
           <a:xfrm>
-            <a:off x="578279" y="1851660"/>
-            <a:ext cx="7255921" cy="4023360"/>
+            <a:off x="480060" y="2649480"/>
+            <a:ext cx="7452360" cy="2427718"/>
           </a:xfrm>
           <a:prstGeom prst="rect">
             <a:avLst/>
@@ -7993,7 +7875,7 @@
                 <a:latin typeface="Microsoft YaHei"/>
                 <a:ea typeface="Microsoft YaHei"/>
               </a:rPr>
-              <a:t>根评论：评论者→帖主；明确回复：回复者→replyUserId。</a:t>
+              <a:t>已采集评论中64.5%在24小时内，82.2%在7天内。</a:t>
             </a:r>
           </a:p>
           <a:p>
@@ -8027,7 +7909,7 @@
                 <a:latin typeface="Microsoft YaHei"/>
                 <a:ea typeface="Microsoft YaHei"/>
               </a:rPr>
-              <a:t>去重后移除84次自我互动；11,511事件合并为4,069条边。</a:t>
+              <a:t>4,902次明确回复中，89.0%由帖主发出；用户彼此回复仅2.0%。</a:t>
             </a:r>
           </a:p>
           <a:p>
@@ -8061,7 +7943,7 @@
                 <a:latin typeface="Microsoft YaHei"/>
                 <a:ea typeface="Microsoft YaHei"/>
               </a:rPr>
-              <a:t>2,932个有边节点；箭头在图中省略，原数据保持有向。</a:t>
+              <a:t>首周互惠率74.1%，全部记录49.6%；窗口和采集边界影响结构。</a:t>
             </a:r>
           </a:p>
         </p:txBody>
@@ -8247,35 +8129,153 @@
                 <a:latin typeface="Microsoft YaHei"/>
                 <a:ea typeface="Microsoft YaHei"/>
               </a:rPr>
-              <a:t>互动集中，但样本边界影响很大</a:t>
-            </a:r>
-          </a:p>
-        </p:txBody>
-      </p:sp>
-      <p:pic>
-        <p:nvPicPr>
-          <p:cNvPr id="4" name="Picture 3" descr="07_network_concentration.png"/>
-          <p:cNvPicPr>
-            <a:picLocks noChangeAspect="1"/>
-          </p:cNvPicPr>
+              <a:t>建议：把表达方案交给对照实验</a:t>
+            </a:r>
+          </a:p>
+        </p:txBody>
+      </p:sp>
+      <p:sp>
+        <p:nvSpPr>
+          <p:cNvPr id="4" name="TextBox 3"/>
+          <p:cNvSpPr txBox="1"/>
           <p:nvPr/>
-        </p:nvPicPr>
-        <p:blipFill>
-          <a:blip r:embed="rId2"/>
-          <a:stretch>
-            <a:fillRect/>
-          </a:stretch>
-        </p:blipFill>
-        <p:spPr>
-          <a:xfrm>
-            <a:off x="480060" y="2614975"/>
-            <a:ext cx="7452360" cy="2496729"/>
-          </a:xfrm>
-          <a:prstGeom prst="rect">
-            <a:avLst/>
-          </a:prstGeom>
-        </p:spPr>
-      </p:pic>
+        </p:nvSpPr>
+        <p:spPr>
+          <a:xfrm>
+            <a:off x="731520" y="1874519"/>
+            <a:ext cx="10698480" cy="4297680"/>
+          </a:xfrm>
+          <a:prstGeom prst="rect">
+            <a:avLst/>
+          </a:prstGeom>
+          <a:noFill/>
+        </p:spPr>
+        <p:txBody>
+          <a:bodyPr wrap="square" lIns="0" rIns="0" tIns="0" bIns="0">
+            <a:spAutoFit/>
+          </a:bodyPr>
+          <a:lstStyle/>
+          <a:p>
+            <a:pPr>
+              <a:spcAft>
+                <a:spcPts val="900"/>
+              </a:spcAft>
+            </a:pPr>
+            <a:r>
+              <a:rPr sz="2100" b="0">
+                <a:solidFill>
+                  <a:srgbClr val="213444"/>
+                </a:solidFill>
+                <a:latin typeface="Microsoft YaHei"/>
+                <a:ea typeface="Microsoft YaHei"/>
+              </a:rPr>
+              <a:t>不承诺“加某个词就会涨赞”；先保证真实、完整且易交流的内容。</a:t>
+            </a:r>
+          </a:p>
+          <a:p>
+            <a:pPr>
+              <a:spcAft>
+                <a:spcPts val="900"/>
+              </a:spcAft>
+            </a:pPr>
+            <a:r>
+              <a:rPr sz="2100" b="0">
+                <a:solidFill>
+                  <a:srgbClr val="213444"/>
+                </a:solidFill>
+                <a:latin typeface="Microsoft YaHei"/>
+                <a:ea typeface="Microsoft YaHei"/>
+              </a:rPr>
+              <a:t/>
+            </a:r>
+          </a:p>
+          <a:p>
+            <a:pPr>
+              <a:spcAft>
+                <a:spcPts val="900"/>
+              </a:spcAft>
+            </a:pPr>
+            <a:r>
+              <a:rPr sz="2100" b="0">
+                <a:solidFill>
+                  <a:srgbClr val="213444"/>
+                </a:solidFill>
+                <a:latin typeface="Microsoft YaHei"/>
+                <a:ea typeface="Microsoft YaHei"/>
+              </a:rPr>
+              <a:t>固定观察窗口、记录真实曝光；按作者随机分组评估提示文案。</a:t>
+            </a:r>
+          </a:p>
+          <a:p>
+            <a:pPr>
+              <a:spcAft>
+                <a:spcPts val="900"/>
+              </a:spcAft>
+            </a:pPr>
+            <a:r>
+              <a:rPr sz="2100" b="0">
+                <a:solidFill>
+                  <a:srgbClr val="213444"/>
+                </a:solidFill>
+                <a:latin typeface="Microsoft YaHei"/>
+                <a:ea typeface="Microsoft YaHei"/>
+              </a:rPr>
+              <a:t/>
+            </a:r>
+          </a:p>
+          <a:p>
+            <a:pPr>
+              <a:spcAft>
+                <a:spcPts val="900"/>
+              </a:spcAft>
+            </a:pPr>
+            <a:r>
+              <a:rPr sz="2100" b="0">
+                <a:solidFill>
+                  <a:srgbClr val="213444"/>
+                </a:solidFill>
+                <a:latin typeface="Microsoft YaHei"/>
+                <a:ea typeface="Microsoft YaHei"/>
+              </a:rPr>
+              <a:t>关注低反馈用户与回复质量，同时验证抽样是否造成集中。</a:t>
+            </a:r>
+          </a:p>
+          <a:p>
+            <a:pPr>
+              <a:spcAft>
+                <a:spcPts val="900"/>
+              </a:spcAft>
+            </a:pPr>
+            <a:r>
+              <a:rPr sz="2100" b="0">
+                <a:solidFill>
+                  <a:srgbClr val="213444"/>
+                </a:solidFill>
+                <a:latin typeface="Microsoft YaHei"/>
+                <a:ea typeface="Microsoft YaHei"/>
+              </a:rPr>
+              <a:t/>
+            </a:r>
+          </a:p>
+          <a:p>
+            <a:pPr>
+              <a:spcAft>
+                <a:spcPts val="900"/>
+              </a:spcAft>
+            </a:pPr>
+            <a:r>
+              <a:rPr sz="2100" b="0">
+                <a:solidFill>
+                  <a:srgbClr val="213444"/>
+                </a:solidFill>
+                <a:latin typeface="Microsoft YaHei"/>
+                <a:ea typeface="Microsoft YaHei"/>
+              </a:rPr>
+              <a:t>未执行的实验是后续设计，不是已证实的增长方案。</a:t>
+            </a:r>
+          </a:p>
+        </p:txBody>
+      </p:sp>
       <p:sp>
         <p:nvSpPr>
           <p:cNvPr id="5" name="TextBox 4"/>
@@ -8284,8 +8284,8 @@
         </p:nvSpPr>
         <p:spPr>
           <a:xfrm>
-            <a:off x="8229600" y="1828800"/>
-            <a:ext cx="3383280" cy="4297680"/>
+            <a:off x="502920" y="6419088"/>
+            <a:ext cx="10789920" cy="228600"/>
           </a:xfrm>
           <a:prstGeom prst="rect">
             <a:avLst/>
@@ -8304,82 +8304,14 @@
               </a:spcAft>
             </a:pPr>
             <a:r>
-              <a:rPr sz="1900" b="0">
-                <a:solidFill>
-                  <a:srgbClr val="213444"/>
-                </a:solidFill>
-                <a:latin typeface="Microsoft YaHei"/>
-                <a:ea typeface="Microsoft YaHei"/>
-              </a:rPr>
-              <a:t>前10位接收者获得54.0%互动；第一位12.0%。</a:t>
-            </a:r>
-          </a:p>
-          <a:p>
-            <a:pPr>
-              <a:spcAft>
-                <a:spcPts val="900"/>
-              </a:spcAft>
-            </a:pPr>
-            <a:r>
-              <a:rPr sz="1900" b="0">
-                <a:solidFill>
-                  <a:srgbClr val="213444"/>
-                </a:solidFill>
-                <a:latin typeface="Microsoft YaHei"/>
-                <a:ea typeface="Microsoft YaHei"/>
-              </a:rPr>
-              <a:t/>
-            </a:r>
-          </a:p>
-          <a:p>
-            <a:pPr>
-              <a:spcAft>
-                <a:spcPts val="900"/>
-              </a:spcAft>
-            </a:pPr>
-            <a:r>
-              <a:rPr sz="1900" b="0">
-                <a:solidFill>
-                  <a:srgbClr val="213444"/>
-                </a:solidFill>
-                <a:latin typeface="Microsoft YaHei"/>
-                <a:ea typeface="Microsoft YaHei"/>
-              </a:rPr>
-              <a:t>整体互惠率49.6%；仅明确回复子网络29.9%。</a:t>
-            </a:r>
-          </a:p>
-          <a:p>
-            <a:pPr>
-              <a:spcAft>
-                <a:spcPts val="900"/>
-              </a:spcAft>
-            </a:pPr>
-            <a:r>
-              <a:rPr sz="1900" b="0">
-                <a:solidFill>
-                  <a:srgbClr val="213444"/>
-                </a:solidFill>
-                <a:latin typeface="Microsoft YaHei"/>
-                <a:ea typeface="Microsoft YaHei"/>
-              </a:rPr>
-              <a:t/>
-            </a:r>
-          </a:p>
-          <a:p>
-            <a:pPr>
-              <a:spcAft>
-                <a:spcPts val="900"/>
-              </a:spcAft>
-            </a:pPr>
-            <a:r>
-              <a:rPr sz="1900" b="0">
-                <a:solidFill>
-                  <a:srgbClr val="213444"/>
-                </a:solidFill>
-                <a:latin typeface="Microsoft YaHei"/>
-                <a:ea typeface="Microsoft YaHei"/>
-              </a:rPr>
-              <a:t>这是采集网络的接收事件数，不是平台影响力或独立粉丝数。</a:t>
+              <a:rPr sz="1000" b="0">
+                <a:solidFill>
+                  <a:srgbClr val="71818B"/>
+                </a:solidFill>
+                <a:latin typeface="Microsoft YaHei"/>
+                <a:ea typeface="Microsoft YaHei"/>
+              </a:rPr>
+              <a:t>Keep课程样本；观察性分析。全部数值与口径见分析报告及附带结果。</a:t>
             </a:r>
           </a:p>
         </p:txBody>
@@ -8387,46 +8319,6 @@
       <p:sp>
         <p:nvSpPr>
           <p:cNvPr id="6" name="TextBox 5"/>
-          <p:cNvSpPr txBox="1"/>
-          <p:nvPr/>
-        </p:nvSpPr>
-        <p:spPr>
-          <a:xfrm>
-            <a:off x="502920" y="6419088"/>
-            <a:ext cx="10789920" cy="228600"/>
-          </a:xfrm>
-          <a:prstGeom prst="rect">
-            <a:avLst/>
-          </a:prstGeom>
-          <a:noFill/>
-        </p:spPr>
-        <p:txBody>
-          <a:bodyPr wrap="square" lIns="0" rIns="0" tIns="0" bIns="0">
-            <a:spAutoFit/>
-          </a:bodyPr>
-          <a:lstStyle/>
-          <a:p>
-            <a:pPr>
-              <a:spcAft>
-                <a:spcPts val="900"/>
-              </a:spcAft>
-            </a:pPr>
-            <a:r>
-              <a:rPr sz="1000" b="0">
-                <a:solidFill>
-                  <a:srgbClr val="71818B"/>
-                </a:solidFill>
-                <a:latin typeface="Microsoft YaHei"/>
-                <a:ea typeface="Microsoft YaHei"/>
-              </a:rPr>
-              <a:t>Keep课程样本；观察性分析。全部数值与口径见分析报告及附带结果。</a:t>
-            </a:r>
-          </a:p>
-        </p:txBody>
-      </p:sp>
-      <p:sp>
-        <p:nvSpPr>
-          <p:cNvPr id="7" name="TextBox 6"/>
           <p:cNvSpPr txBox="1"/>
           <p:nvPr/>
         </p:nvSpPr>
@@ -8598,7 +8490,7 @@
               </a:spcAft>
             </a:pPr>
             <a:r>
-              <a:rPr sz="2100" b="0">
+              <a:rPr sz="2400" b="0">
                 <a:solidFill>
                   <a:srgbClr val="213444"/>
                 </a:solidFill>
@@ -8615,7 +8507,7 @@
               </a:spcAft>
             </a:pPr>
             <a:r>
-              <a:rPr sz="2100" b="0">
+              <a:rPr sz="2400" b="0">
                 <a:solidFill>
                   <a:srgbClr val="213444"/>
                 </a:solidFill>
@@ -8632,7 +8524,7 @@
               </a:spcAft>
             </a:pPr>
             <a:r>
-              <a:rPr sz="2100" b="0">
+              <a:rPr sz="2400" b="0">
                 <a:solidFill>
                   <a:srgbClr val="213444"/>
                 </a:solidFill>
@@ -8649,7 +8541,7 @@
               </a:spcAft>
             </a:pPr>
             <a:r>
-              <a:rPr sz="2100" b="0">
+              <a:rPr sz="2400" b="0">
                 <a:solidFill>
                   <a:srgbClr val="213444"/>
                 </a:solidFill>
@@ -8666,7 +8558,7 @@
               </a:spcAft>
             </a:pPr>
             <a:r>
-              <a:rPr sz="2100" b="0">
+              <a:rPr sz="2400" b="0">
                 <a:solidFill>
                   <a:srgbClr val="213444"/>
                 </a:solidFill>
@@ -8674,40 +8566,6 @@
                 <a:ea typeface="Microsoft YaHei"/>
               </a:rPr>
               <a:t>RQ3：评论连接了谁，互动是否集中？</a:t>
-            </a:r>
-          </a:p>
-          <a:p>
-            <a:pPr>
-              <a:spcAft>
-                <a:spcPts val="900"/>
-              </a:spcAft>
-            </a:pPr>
-            <a:r>
-              <a:rPr sz="2100" b="0">
-                <a:solidFill>
-                  <a:srgbClr val="213444"/>
-                </a:solidFill>
-                <a:latin typeface="Microsoft YaHei"/>
-                <a:ea typeface="Microsoft YaHei"/>
-              </a:rPr>
-              <a:t/>
-            </a:r>
-          </a:p>
-          <a:p>
-            <a:pPr>
-              <a:spcAft>
-                <a:spcPts val="900"/>
-              </a:spcAft>
-            </a:pPr>
-            <a:r>
-              <a:rPr sz="2100" b="0">
-                <a:solidFill>
-                  <a:srgbClr val="213444"/>
-                </a:solidFill>
-                <a:latin typeface="Microsoft YaHei"/>
-                <a:ea typeface="Microsoft YaHei"/>
-              </a:rPr>
-              <a:t>RQ4：文本能否改善样本外点赞预测？</a:t>
             </a:r>
           </a:p>
         </p:txBody>
@@ -8893,35 +8751,153 @@
                 <a:latin typeface="Microsoft YaHei"/>
                 <a:ea typeface="Microsoft YaHei"/>
               </a:rPr>
-              <a:t>网络互惠主要体现围绕帖主的回应</a:t>
-            </a:r>
-          </a:p>
-        </p:txBody>
-      </p:sp>
-      <p:pic>
-        <p:nvPicPr>
-          <p:cNvPr id="4" name="Picture 3" descr="13_comment_timing_roles.png"/>
-          <p:cNvPicPr>
-            <a:picLocks noChangeAspect="1"/>
-          </p:cNvPicPr>
+              <a:t>结论、局限与可复现性</a:t>
+            </a:r>
+          </a:p>
+        </p:txBody>
+      </p:sp>
+      <p:sp>
+        <p:nvSpPr>
+          <p:cNvPr id="4" name="TextBox 3"/>
+          <p:cNvSpPr txBox="1"/>
           <p:nvPr/>
-        </p:nvPicPr>
-        <p:blipFill>
-          <a:blip r:embed="rId2"/>
-          <a:stretch>
-            <a:fillRect/>
-          </a:stretch>
-        </p:blipFill>
-        <p:spPr>
-          <a:xfrm>
-            <a:off x="480060" y="2649480"/>
-            <a:ext cx="7452360" cy="2427718"/>
-          </a:xfrm>
-          <a:prstGeom prst="rect">
-            <a:avLst/>
-          </a:prstGeom>
-        </p:spPr>
-      </p:pic>
+        </p:nvSpPr>
+        <p:spPr>
+          <a:xfrm>
+            <a:off x="731520" y="1874519"/>
+            <a:ext cx="10698480" cy="4297680"/>
+          </a:xfrm>
+          <a:prstGeom prst="rect">
+            <a:avLst/>
+          </a:prstGeom>
+          <a:noFill/>
+        </p:spPr>
+        <p:txBody>
+          <a:bodyPr wrap="square" lIns="0" rIns="0" tIns="0" bIns="0">
+            <a:spAutoFit/>
+          </a:bodyPr>
+          <a:lstStyle/>
+          <a:p>
+            <a:pPr>
+              <a:spcAft>
+                <a:spcPts val="900"/>
+              </a:spcAft>
+            </a:pPr>
+            <a:r>
+              <a:rPr sz="2100" b="0">
+                <a:solidFill>
+                  <a:srgbClr val="213444"/>
+                </a:solidFill>
+                <a:latin typeface="Microsoft YaHei"/>
+                <a:ea typeface="Microsoft YaHei"/>
+              </a:rPr>
+              <a:t>词典特征与主题权重的回归均未提供明确、稳定的点赞关联证据。</a:t>
+            </a:r>
+          </a:p>
+          <a:p>
+            <a:pPr>
+              <a:spcAft>
+                <a:spcPts val="900"/>
+              </a:spcAft>
+            </a:pPr>
+            <a:r>
+              <a:rPr sz="2100" b="0">
+                <a:solidFill>
+                  <a:srgbClr val="213444"/>
+                </a:solidFill>
+                <a:latin typeface="Microsoft YaHei"/>
+                <a:ea typeface="Microsoft YaHei"/>
+              </a:rPr>
+              <a:t/>
+            </a:r>
+          </a:p>
+          <a:p>
+            <a:pPr>
+              <a:spcAft>
+                <a:spcPts val="900"/>
+              </a:spcAft>
+            </a:pPr>
+            <a:r>
+              <a:rPr sz="2100" b="0">
+                <a:solidFill>
+                  <a:srgbClr val="213444"/>
+                </a:solidFill>
+                <a:latin typeface="Microsoft YaHei"/>
+                <a:ea typeface="Microsoft YaHei"/>
+              </a:rPr>
+              <a:t>100位作者课程样本，抽样机制不明；正文/视觉缺失；曝光和统一采集时点未知。</a:t>
+            </a:r>
+          </a:p>
+          <a:p>
+            <a:pPr>
+              <a:spcAft>
+                <a:spcPts val="900"/>
+              </a:spcAft>
+            </a:pPr>
+            <a:r>
+              <a:rPr sz="2100" b="0">
+                <a:solidFill>
+                  <a:srgbClr val="213444"/>
+                </a:solidFill>
+                <a:latin typeface="Microsoft YaHei"/>
+                <a:ea typeface="Microsoft YaHei"/>
+              </a:rPr>
+              <a:t/>
+            </a:r>
+          </a:p>
+          <a:p>
+            <a:pPr>
+              <a:spcAft>
+                <a:spcPts val="900"/>
+              </a:spcAft>
+            </a:pPr>
+            <a:r>
+              <a:rPr sz="2100" b="0">
+                <a:solidFill>
+                  <a:srgbClr val="213444"/>
+                </a:solidFill>
+                <a:latin typeface="Microsoft YaHei"/>
+                <a:ea typeface="Microsoft YaHei"/>
+              </a:rPr>
+              <a:t>代码、原始Keep数据、特征表、回归结果与已执行Notebook全部随附。</a:t>
+            </a:r>
+          </a:p>
+          <a:p>
+            <a:pPr>
+              <a:spcAft>
+                <a:spcPts val="900"/>
+              </a:spcAft>
+            </a:pPr>
+            <a:r>
+              <a:rPr sz="2100" b="0">
+                <a:solidFill>
+                  <a:srgbClr val="213444"/>
+                </a:solidFill>
+                <a:latin typeface="Microsoft YaHei"/>
+                <a:ea typeface="Microsoft YaHei"/>
+              </a:rPr>
+              <a:t/>
+            </a:r>
+          </a:p>
+          <a:p>
+            <a:pPr>
+              <a:spcAft>
+                <a:spcPts val="900"/>
+              </a:spcAft>
+            </a:pPr>
+            <a:r>
+              <a:rPr sz="2100" b="0">
+                <a:solidFill>
+                  <a:srgbClr val="213444"/>
+                </a:solidFill>
+                <a:latin typeface="Microsoft YaHei"/>
+                <a:ea typeface="Microsoft YaHei"/>
+              </a:rPr>
+              <a:t>数值独立复核；填好组号、成员后按课程要求打包提交。</a:t>
+            </a:r>
+          </a:p>
+        </p:txBody>
+      </p:sp>
       <p:sp>
         <p:nvSpPr>
           <p:cNvPr id="5" name="TextBox 4"/>
@@ -8930,8 +8906,8 @@
         </p:nvSpPr>
         <p:spPr>
           <a:xfrm>
-            <a:off x="8229600" y="1828800"/>
-            <a:ext cx="3383280" cy="4297680"/>
+            <a:off x="502920" y="6419088"/>
+            <a:ext cx="10789920" cy="228600"/>
           </a:xfrm>
           <a:prstGeom prst="rect">
             <a:avLst/>
@@ -8950,82 +8926,14 @@
               </a:spcAft>
             </a:pPr>
             <a:r>
-              <a:rPr sz="1900" b="0">
-                <a:solidFill>
-                  <a:srgbClr val="213444"/>
-                </a:solidFill>
-                <a:latin typeface="Microsoft YaHei"/>
-                <a:ea typeface="Microsoft YaHei"/>
-              </a:rPr>
-              <a:t>已采集评论中64.5%在24小时内，82.2%在7天内。</a:t>
-            </a:r>
-          </a:p>
-          <a:p>
-            <a:pPr>
-              <a:spcAft>
-                <a:spcPts val="900"/>
-              </a:spcAft>
-            </a:pPr>
-            <a:r>
-              <a:rPr sz="1900" b="0">
-                <a:solidFill>
-                  <a:srgbClr val="213444"/>
-                </a:solidFill>
-                <a:latin typeface="Microsoft YaHei"/>
-                <a:ea typeface="Microsoft YaHei"/>
-              </a:rPr>
-              <a:t/>
-            </a:r>
-          </a:p>
-          <a:p>
-            <a:pPr>
-              <a:spcAft>
-                <a:spcPts val="900"/>
-              </a:spcAft>
-            </a:pPr>
-            <a:r>
-              <a:rPr sz="1900" b="0">
-                <a:solidFill>
-                  <a:srgbClr val="213444"/>
-                </a:solidFill>
-                <a:latin typeface="Microsoft YaHei"/>
-                <a:ea typeface="Microsoft YaHei"/>
-              </a:rPr>
-              <a:t>4,902次明确回复中，89.0%由帖主发出；用户彼此回复仅2.0%。</a:t>
-            </a:r>
-          </a:p>
-          <a:p>
-            <a:pPr>
-              <a:spcAft>
-                <a:spcPts val="900"/>
-              </a:spcAft>
-            </a:pPr>
-            <a:r>
-              <a:rPr sz="1900" b="0">
-                <a:solidFill>
-                  <a:srgbClr val="213444"/>
-                </a:solidFill>
-                <a:latin typeface="Microsoft YaHei"/>
-                <a:ea typeface="Microsoft YaHei"/>
-              </a:rPr>
-              <a:t/>
-            </a:r>
-          </a:p>
-          <a:p>
-            <a:pPr>
-              <a:spcAft>
-                <a:spcPts val="900"/>
-              </a:spcAft>
-            </a:pPr>
-            <a:r>
-              <a:rPr sz="1900" b="0">
-                <a:solidFill>
-                  <a:srgbClr val="213444"/>
-                </a:solidFill>
-                <a:latin typeface="Microsoft YaHei"/>
-                <a:ea typeface="Microsoft YaHei"/>
-              </a:rPr>
-              <a:t>首周互惠率74.1%，全部记录49.6%；窗口和采集边界影响结构。</a:t>
+              <a:rPr sz="1000" b="0">
+                <a:solidFill>
+                  <a:srgbClr val="71818B"/>
+                </a:solidFill>
+                <a:latin typeface="Microsoft YaHei"/>
+                <a:ea typeface="Microsoft YaHei"/>
+              </a:rPr>
+              <a:t>Keep课程样本；观察性分析。全部数值与口径见分析报告及附带结果。</a:t>
             </a:r>
           </a:p>
         </p:txBody>
@@ -9033,46 +8941,6 @@
       <p:sp>
         <p:nvSpPr>
           <p:cNvPr id="6" name="TextBox 5"/>
-          <p:cNvSpPr txBox="1"/>
-          <p:nvPr/>
-        </p:nvSpPr>
-        <p:spPr>
-          <a:xfrm>
-            <a:off x="502920" y="6419088"/>
-            <a:ext cx="10789920" cy="228600"/>
-          </a:xfrm>
-          <a:prstGeom prst="rect">
-            <a:avLst/>
-          </a:prstGeom>
-          <a:noFill/>
-        </p:spPr>
-        <p:txBody>
-          <a:bodyPr wrap="square" lIns="0" rIns="0" tIns="0" bIns="0">
-            <a:spAutoFit/>
-          </a:bodyPr>
-          <a:lstStyle/>
-          <a:p>
-            <a:pPr>
-              <a:spcAft>
-                <a:spcPts val="900"/>
-              </a:spcAft>
-            </a:pPr>
-            <a:r>
-              <a:rPr sz="1000" b="0">
-                <a:solidFill>
-                  <a:srgbClr val="71818B"/>
-                </a:solidFill>
-                <a:latin typeface="Microsoft YaHei"/>
-                <a:ea typeface="Microsoft YaHei"/>
-              </a:rPr>
-              <a:t>Keep课程样本；观察性分析。全部数值与口径见分析报告及附带结果。</a:t>
-            </a:r>
-          </a:p>
-        </p:txBody>
-      </p:sp>
-      <p:sp>
-        <p:nvSpPr>
-          <p:cNvPr id="7" name="TextBox 6"/>
           <p:cNvSpPr txBox="1"/>
           <p:nvPr/>
         </p:nvSpPr>
@@ -9211,7 +9079,7 @@
                 <a:latin typeface="Microsoft YaHei"/>
                 <a:ea typeface="Microsoft YaHei"/>
               </a:rPr>
-              <a:t>建议：把表达方案交给对照实验</a:t>
+              <a:t>小组分工与讨论</a:t>
             </a:r>
           </a:p>
         </p:txBody>
@@ -9251,7 +9119,7 @@
                 <a:latin typeface="Microsoft YaHei"/>
                 <a:ea typeface="Microsoft YaHei"/>
               </a:rPr>
-              <a:t>不承诺“加某个词就会涨赞”；先保证真实、完整且易交流的内容。</a:t>
+              <a:t>成员A【待填写】：研究问题与背景（1—3页）</a:t>
             </a:r>
           </a:p>
           <a:p>
@@ -9285,7 +9153,7 @@
                 <a:latin typeface="Microsoft YaHei"/>
                 <a:ea typeface="Microsoft YaHei"/>
               </a:rPr>
-              <a:t>固定观察窗口、记录真实曝光；按作者随机分组评估提示文案。</a:t>
+              <a:t>成员B【待填写】：数据、文本与主题（4—10页）</a:t>
             </a:r>
           </a:p>
           <a:p>
@@ -9319,7 +9187,7 @@
                 <a:latin typeface="Microsoft YaHei"/>
                 <a:ea typeface="Microsoft YaHei"/>
               </a:rPr>
-              <a:t>关注低反馈用户与回复质量，同时验证抽样是否造成集中。</a:t>
+              <a:t>成员C【待填写】：回归、检验与测量核查（11—15页）</a:t>
             </a:r>
           </a:p>
           <a:p>
@@ -9353,7 +9221,41 @@
                 <a:latin typeface="Microsoft YaHei"/>
                 <a:ea typeface="Microsoft YaHei"/>
               </a:rPr>
-              <a:t>未执行的实验是后续设计，不是已证实的增长方案。</a:t>
+              <a:t>成员D【待填写】：网络、建议与总结（16—21页）</a:t>
+            </a:r>
+          </a:p>
+          <a:p>
+            <a:pPr>
+              <a:spcAft>
+                <a:spcPts val="900"/>
+              </a:spcAft>
+            </a:pPr>
+            <a:r>
+              <a:rPr sz="2100" b="0">
+                <a:solidFill>
+                  <a:srgbClr val="213444"/>
+                </a:solidFill>
+                <a:latin typeface="Microsoft YaHei"/>
+                <a:ea typeface="Microsoft YaHei"/>
+              </a:rPr>
+              <a:t/>
+            </a:r>
+          </a:p>
+          <a:p>
+            <a:pPr>
+              <a:spcAft>
+                <a:spcPts val="900"/>
+              </a:spcAft>
+            </a:pPr>
+            <a:r>
+              <a:rPr sz="2100" b="0">
+                <a:solidFill>
+                  <a:srgbClr val="213444"/>
+                </a:solidFill>
+                <a:latin typeface="Microsoft YaHei"/>
+                <a:ea typeface="Microsoft YaHei"/>
+              </a:rPr>
+              <a:t>建议分工须按真实人数和贡献修订。</a:t>
             </a:r>
           </a:p>
         </p:txBody>
@@ -9434,696 +9336,6 @@
                 <a:ea typeface="Microsoft YaHei"/>
               </a:rPr>
               <a:t>21</a:t>
-            </a:r>
-          </a:p>
-        </p:txBody>
-      </p:sp>
-    </p:spTree>
-  </p:cSld>
-  <p:clrMapOvr>
-    <a:masterClrMapping/>
-  </p:clrMapOvr>
-</p:sld>
-</file>
-
-<file path=ppt/slides/slide22.xml><?xml version="1.0" encoding="utf-8"?>
-<p:sld xmlns:a="http://schemas.openxmlformats.org/drawingml/2006/main" xmlns:p="http://schemas.openxmlformats.org/presentationml/2006/main" xmlns:r="http://schemas.openxmlformats.org/officeDocument/2006/relationships">
-  <p:cSld>
-    <p:bg>
-      <p:bgPr>
-        <a:solidFill>
-          <a:srgbClr val="FFFFFF"/>
-        </a:solidFill>
-        <a:effectLst/>
-      </p:bgPr>
-    </p:bg>
-    <p:spTree>
-      <p:nvGrpSpPr>
-        <p:cNvPr id="1" name=""/>
-        <p:cNvGrpSpPr/>
-        <p:nvPr/>
-      </p:nvGrpSpPr>
-      <p:grpSpPr/>
-      <p:sp>
-        <p:nvSpPr>
-          <p:cNvPr id="2" name="TextBox 1"/>
-          <p:cNvSpPr txBox="1"/>
-          <p:nvPr/>
-        </p:nvSpPr>
-        <p:spPr>
-          <a:xfrm>
-            <a:off x="502920" y="256032"/>
-            <a:ext cx="10972800" cy="274320"/>
-          </a:xfrm>
-          <a:prstGeom prst="rect">
-            <a:avLst/>
-          </a:prstGeom>
-          <a:noFill/>
-        </p:spPr>
-        <p:txBody>
-          <a:bodyPr wrap="square" lIns="0" rIns="0" tIns="0" bIns="0">
-            <a:spAutoFit/>
-          </a:bodyPr>
-          <a:lstStyle/>
-          <a:p>
-            <a:pPr>
-              <a:spcAft>
-                <a:spcPts val="900"/>
-              </a:spcAft>
-            </a:pPr>
-            <a:r>
-              <a:rPr sz="1100" b="0">
-                <a:solidFill>
-                  <a:srgbClr val="356D9A"/>
-                </a:solidFill>
-                <a:latin typeface="Microsoft YaHei"/>
-                <a:ea typeface="Microsoft YaHei"/>
-              </a:rPr>
-              <a:t>KEEP COMMUNITY  /  小组项目  /  22</a:t>
-            </a:r>
-          </a:p>
-        </p:txBody>
-      </p:sp>
-      <p:sp>
-        <p:nvSpPr>
-          <p:cNvPr id="3" name="TextBox 2"/>
-          <p:cNvSpPr txBox="1"/>
-          <p:nvPr/>
-        </p:nvSpPr>
-        <p:spPr>
-          <a:xfrm>
-            <a:off x="502920" y="749808"/>
-            <a:ext cx="11155680" cy="822960"/>
-          </a:xfrm>
-          <a:prstGeom prst="rect">
-            <a:avLst/>
-          </a:prstGeom>
-          <a:noFill/>
-        </p:spPr>
-        <p:txBody>
-          <a:bodyPr wrap="square" lIns="0" rIns="0" tIns="0" bIns="0">
-            <a:spAutoFit/>
-          </a:bodyPr>
-          <a:lstStyle/>
-          <a:p>
-            <a:pPr>
-              <a:spcAft>
-                <a:spcPts val="900"/>
-              </a:spcAft>
-            </a:pPr>
-            <a:r>
-              <a:rPr sz="3000" b="1">
-                <a:solidFill>
-                  <a:srgbClr val="213444"/>
-                </a:solidFill>
-                <a:latin typeface="Microsoft YaHei"/>
-                <a:ea typeface="Microsoft YaHei"/>
-              </a:rPr>
-              <a:t>结论、局限与可复现性</a:t>
-            </a:r>
-          </a:p>
-        </p:txBody>
-      </p:sp>
-      <p:sp>
-        <p:nvSpPr>
-          <p:cNvPr id="4" name="TextBox 3"/>
-          <p:cNvSpPr txBox="1"/>
-          <p:nvPr/>
-        </p:nvSpPr>
-        <p:spPr>
-          <a:xfrm>
-            <a:off x="731520" y="1874519"/>
-            <a:ext cx="10698480" cy="4297680"/>
-          </a:xfrm>
-          <a:prstGeom prst="rect">
-            <a:avLst/>
-          </a:prstGeom>
-          <a:noFill/>
-        </p:spPr>
-        <p:txBody>
-          <a:bodyPr wrap="square" lIns="0" rIns="0" tIns="0" bIns="0">
-            <a:spAutoFit/>
-          </a:bodyPr>
-          <a:lstStyle/>
-          <a:p>
-            <a:pPr>
-              <a:spcAft>
-                <a:spcPts val="900"/>
-              </a:spcAft>
-            </a:pPr>
-            <a:r>
-              <a:rPr sz="2100" b="0">
-                <a:solidFill>
-                  <a:srgbClr val="213444"/>
-                </a:solidFill>
-                <a:latin typeface="Microsoft YaHei"/>
-                <a:ea typeface="Microsoft YaHei"/>
-              </a:rPr>
-              <a:t>词典、主题与留出评估均未提供稳定的文本增益证据。</a:t>
-            </a:r>
-          </a:p>
-          <a:p>
-            <a:pPr>
-              <a:spcAft>
-                <a:spcPts val="900"/>
-              </a:spcAft>
-            </a:pPr>
-            <a:r>
-              <a:rPr sz="2100" b="0">
-                <a:solidFill>
-                  <a:srgbClr val="213444"/>
-                </a:solidFill>
-                <a:latin typeface="Microsoft YaHei"/>
-                <a:ea typeface="Microsoft YaHei"/>
-              </a:rPr>
-              <a:t/>
-            </a:r>
-          </a:p>
-          <a:p>
-            <a:pPr>
-              <a:spcAft>
-                <a:spcPts val="900"/>
-              </a:spcAft>
-            </a:pPr>
-            <a:r>
-              <a:rPr sz="2100" b="0">
-                <a:solidFill>
-                  <a:srgbClr val="213444"/>
-                </a:solidFill>
-                <a:latin typeface="Microsoft YaHei"/>
-                <a:ea typeface="Microsoft YaHei"/>
-              </a:rPr>
-              <a:t>100位作者课程样本，抽样机制不明；正文/视觉缺失；曝光和统一采集时点未知。</a:t>
-            </a:r>
-          </a:p>
-          <a:p>
-            <a:pPr>
-              <a:spcAft>
-                <a:spcPts val="900"/>
-              </a:spcAft>
-            </a:pPr>
-            <a:r>
-              <a:rPr sz="2100" b="0">
-                <a:solidFill>
-                  <a:srgbClr val="213444"/>
-                </a:solidFill>
-                <a:latin typeface="Microsoft YaHei"/>
-                <a:ea typeface="Microsoft YaHei"/>
-              </a:rPr>
-              <a:t/>
-            </a:r>
-          </a:p>
-          <a:p>
-            <a:pPr>
-              <a:spcAft>
-                <a:spcPts val="900"/>
-              </a:spcAft>
-            </a:pPr>
-            <a:r>
-              <a:rPr sz="2100" b="0">
-                <a:solidFill>
-                  <a:srgbClr val="213444"/>
-                </a:solidFill>
-                <a:latin typeface="Microsoft YaHei"/>
-                <a:ea typeface="Microsoft YaHei"/>
-              </a:rPr>
-              <a:t>代码、原始Keep数据、特征表、回归结果与已执行Notebook全部随附。</a:t>
-            </a:r>
-          </a:p>
-          <a:p>
-            <a:pPr>
-              <a:spcAft>
-                <a:spcPts val="900"/>
-              </a:spcAft>
-            </a:pPr>
-            <a:r>
-              <a:rPr sz="2100" b="0">
-                <a:solidFill>
-                  <a:srgbClr val="213444"/>
-                </a:solidFill>
-                <a:latin typeface="Microsoft YaHei"/>
-                <a:ea typeface="Microsoft YaHei"/>
-              </a:rPr>
-              <a:t/>
-            </a:r>
-          </a:p>
-          <a:p>
-            <a:pPr>
-              <a:spcAft>
-                <a:spcPts val="900"/>
-              </a:spcAft>
-            </a:pPr>
-            <a:r>
-              <a:rPr sz="2100" b="0">
-                <a:solidFill>
-                  <a:srgbClr val="213444"/>
-                </a:solidFill>
-                <a:latin typeface="Microsoft YaHei"/>
-                <a:ea typeface="Microsoft YaHei"/>
-              </a:rPr>
-              <a:t>数值独立复核；填好组号、成员后按课程要求打包提交。</a:t>
-            </a:r>
-          </a:p>
-        </p:txBody>
-      </p:sp>
-      <p:sp>
-        <p:nvSpPr>
-          <p:cNvPr id="5" name="TextBox 4"/>
-          <p:cNvSpPr txBox="1"/>
-          <p:nvPr/>
-        </p:nvSpPr>
-        <p:spPr>
-          <a:xfrm>
-            <a:off x="502920" y="6419088"/>
-            <a:ext cx="10789920" cy="228600"/>
-          </a:xfrm>
-          <a:prstGeom prst="rect">
-            <a:avLst/>
-          </a:prstGeom>
-          <a:noFill/>
-        </p:spPr>
-        <p:txBody>
-          <a:bodyPr wrap="square" lIns="0" rIns="0" tIns="0" bIns="0">
-            <a:spAutoFit/>
-          </a:bodyPr>
-          <a:lstStyle/>
-          <a:p>
-            <a:pPr>
-              <a:spcAft>
-                <a:spcPts val="900"/>
-              </a:spcAft>
-            </a:pPr>
-            <a:r>
-              <a:rPr sz="1000" b="0">
-                <a:solidFill>
-                  <a:srgbClr val="71818B"/>
-                </a:solidFill>
-                <a:latin typeface="Microsoft YaHei"/>
-                <a:ea typeface="Microsoft YaHei"/>
-              </a:rPr>
-              <a:t>Keep课程样本；观察性分析。全部数值与口径见分析报告及附带结果。</a:t>
-            </a:r>
-          </a:p>
-        </p:txBody>
-      </p:sp>
-      <p:sp>
-        <p:nvSpPr>
-          <p:cNvPr id="6" name="TextBox 5"/>
-          <p:cNvSpPr txBox="1"/>
-          <p:nvPr/>
-        </p:nvSpPr>
-        <p:spPr>
-          <a:xfrm>
-            <a:off x="11201400" y="6419088"/>
-            <a:ext cx="548640" cy="228600"/>
-          </a:xfrm>
-          <a:prstGeom prst="rect">
-            <a:avLst/>
-          </a:prstGeom>
-          <a:noFill/>
-        </p:spPr>
-        <p:txBody>
-          <a:bodyPr wrap="square" lIns="0" rIns="0" tIns="0" bIns="0">
-            <a:spAutoFit/>
-          </a:bodyPr>
-          <a:lstStyle/>
-          <a:p>
-            <a:pPr>
-              <a:spcAft>
-                <a:spcPts val="900"/>
-              </a:spcAft>
-            </a:pPr>
-            <a:r>
-              <a:rPr sz="1000" b="0">
-                <a:solidFill>
-                  <a:srgbClr val="356D9A"/>
-                </a:solidFill>
-                <a:latin typeface="Microsoft YaHei"/>
-                <a:ea typeface="Microsoft YaHei"/>
-              </a:rPr>
-              <a:t>22</a:t>
-            </a:r>
-          </a:p>
-        </p:txBody>
-      </p:sp>
-    </p:spTree>
-  </p:cSld>
-  <p:clrMapOvr>
-    <a:masterClrMapping/>
-  </p:clrMapOvr>
-</p:sld>
-</file>
-
-<file path=ppt/slides/slide23.xml><?xml version="1.0" encoding="utf-8"?>
-<p:sld xmlns:a="http://schemas.openxmlformats.org/drawingml/2006/main" xmlns:p="http://schemas.openxmlformats.org/presentationml/2006/main" xmlns:r="http://schemas.openxmlformats.org/officeDocument/2006/relationships">
-  <p:cSld>
-    <p:bg>
-      <p:bgPr>
-        <a:solidFill>
-          <a:srgbClr val="FFFFFF"/>
-        </a:solidFill>
-        <a:effectLst/>
-      </p:bgPr>
-    </p:bg>
-    <p:spTree>
-      <p:nvGrpSpPr>
-        <p:cNvPr id="1" name=""/>
-        <p:cNvGrpSpPr/>
-        <p:nvPr/>
-      </p:nvGrpSpPr>
-      <p:grpSpPr/>
-      <p:sp>
-        <p:nvSpPr>
-          <p:cNvPr id="2" name="TextBox 1"/>
-          <p:cNvSpPr txBox="1"/>
-          <p:nvPr/>
-        </p:nvSpPr>
-        <p:spPr>
-          <a:xfrm>
-            <a:off x="502920" y="256032"/>
-            <a:ext cx="10972800" cy="274320"/>
-          </a:xfrm>
-          <a:prstGeom prst="rect">
-            <a:avLst/>
-          </a:prstGeom>
-          <a:noFill/>
-        </p:spPr>
-        <p:txBody>
-          <a:bodyPr wrap="square" lIns="0" rIns="0" tIns="0" bIns="0">
-            <a:spAutoFit/>
-          </a:bodyPr>
-          <a:lstStyle/>
-          <a:p>
-            <a:pPr>
-              <a:spcAft>
-                <a:spcPts val="900"/>
-              </a:spcAft>
-            </a:pPr>
-            <a:r>
-              <a:rPr sz="1100" b="0">
-                <a:solidFill>
-                  <a:srgbClr val="356D9A"/>
-                </a:solidFill>
-                <a:latin typeface="Microsoft YaHei"/>
-                <a:ea typeface="Microsoft YaHei"/>
-              </a:rPr>
-              <a:t>KEEP COMMUNITY  /  小组项目  /  23</a:t>
-            </a:r>
-          </a:p>
-        </p:txBody>
-      </p:sp>
-      <p:sp>
-        <p:nvSpPr>
-          <p:cNvPr id="3" name="TextBox 2"/>
-          <p:cNvSpPr txBox="1"/>
-          <p:nvPr/>
-        </p:nvSpPr>
-        <p:spPr>
-          <a:xfrm>
-            <a:off x="502920" y="749808"/>
-            <a:ext cx="11155680" cy="822960"/>
-          </a:xfrm>
-          <a:prstGeom prst="rect">
-            <a:avLst/>
-          </a:prstGeom>
-          <a:noFill/>
-        </p:spPr>
-        <p:txBody>
-          <a:bodyPr wrap="square" lIns="0" rIns="0" tIns="0" bIns="0">
-            <a:spAutoFit/>
-          </a:bodyPr>
-          <a:lstStyle/>
-          <a:p>
-            <a:pPr>
-              <a:spcAft>
-                <a:spcPts val="900"/>
-              </a:spcAft>
-            </a:pPr>
-            <a:r>
-              <a:rPr sz="3000" b="1">
-                <a:solidFill>
-                  <a:srgbClr val="213444"/>
-                </a:solidFill>
-                <a:latin typeface="Microsoft YaHei"/>
-                <a:ea typeface="Microsoft YaHei"/>
-              </a:rPr>
-              <a:t>小组分工与讨论</a:t>
-            </a:r>
-          </a:p>
-        </p:txBody>
-      </p:sp>
-      <p:sp>
-        <p:nvSpPr>
-          <p:cNvPr id="4" name="TextBox 3"/>
-          <p:cNvSpPr txBox="1"/>
-          <p:nvPr/>
-        </p:nvSpPr>
-        <p:spPr>
-          <a:xfrm>
-            <a:off x="731520" y="1874519"/>
-            <a:ext cx="10698480" cy="4297680"/>
-          </a:xfrm>
-          <a:prstGeom prst="rect">
-            <a:avLst/>
-          </a:prstGeom>
-          <a:noFill/>
-        </p:spPr>
-        <p:txBody>
-          <a:bodyPr wrap="square" lIns="0" rIns="0" tIns="0" bIns="0">
-            <a:spAutoFit/>
-          </a:bodyPr>
-          <a:lstStyle/>
-          <a:p>
-            <a:pPr>
-              <a:spcAft>
-                <a:spcPts val="900"/>
-              </a:spcAft>
-            </a:pPr>
-            <a:r>
-              <a:rPr sz="2100" b="0">
-                <a:solidFill>
-                  <a:srgbClr val="213444"/>
-                </a:solidFill>
-                <a:latin typeface="Microsoft YaHei"/>
-                <a:ea typeface="Microsoft YaHei"/>
-              </a:rPr>
-              <a:t>成员A【待填写】：研究问题与背景（1—3页）</a:t>
-            </a:r>
-          </a:p>
-          <a:p>
-            <a:pPr>
-              <a:spcAft>
-                <a:spcPts val="900"/>
-              </a:spcAft>
-            </a:pPr>
-            <a:r>
-              <a:rPr sz="2100" b="0">
-                <a:solidFill>
-                  <a:srgbClr val="213444"/>
-                </a:solidFill>
-                <a:latin typeface="Microsoft YaHei"/>
-                <a:ea typeface="Microsoft YaHei"/>
-              </a:rPr>
-              <a:t/>
-            </a:r>
-          </a:p>
-          <a:p>
-            <a:pPr>
-              <a:spcAft>
-                <a:spcPts val="900"/>
-              </a:spcAft>
-            </a:pPr>
-            <a:r>
-              <a:rPr sz="2100" b="0">
-                <a:solidFill>
-                  <a:srgbClr val="213444"/>
-                </a:solidFill>
-                <a:latin typeface="Microsoft YaHei"/>
-                <a:ea typeface="Microsoft YaHei"/>
-              </a:rPr>
-              <a:t>成员B【待填写】：数据、文本与主题（4—10页）</a:t>
-            </a:r>
-          </a:p>
-          <a:p>
-            <a:pPr>
-              <a:spcAft>
-                <a:spcPts val="900"/>
-              </a:spcAft>
-            </a:pPr>
-            <a:r>
-              <a:rPr sz="2100" b="0">
-                <a:solidFill>
-                  <a:srgbClr val="213444"/>
-                </a:solidFill>
-                <a:latin typeface="Microsoft YaHei"/>
-                <a:ea typeface="Microsoft YaHei"/>
-              </a:rPr>
-              <a:t/>
-            </a:r>
-          </a:p>
-          <a:p>
-            <a:pPr>
-              <a:spcAft>
-                <a:spcPts val="900"/>
-              </a:spcAft>
-            </a:pPr>
-            <a:r>
-              <a:rPr sz="2100" b="0">
-                <a:solidFill>
-                  <a:srgbClr val="213444"/>
-                </a:solidFill>
-                <a:latin typeface="Microsoft YaHei"/>
-                <a:ea typeface="Microsoft YaHei"/>
-              </a:rPr>
-              <a:t>成员C【待填写】：回归、预测与检验（11—17页）</a:t>
-            </a:r>
-          </a:p>
-          <a:p>
-            <a:pPr>
-              <a:spcAft>
-                <a:spcPts val="900"/>
-              </a:spcAft>
-            </a:pPr>
-            <a:r>
-              <a:rPr sz="2100" b="0">
-                <a:solidFill>
-                  <a:srgbClr val="213444"/>
-                </a:solidFill>
-                <a:latin typeface="Microsoft YaHei"/>
-                <a:ea typeface="Microsoft YaHei"/>
-              </a:rPr>
-              <a:t/>
-            </a:r>
-          </a:p>
-          <a:p>
-            <a:pPr>
-              <a:spcAft>
-                <a:spcPts val="900"/>
-              </a:spcAft>
-            </a:pPr>
-            <a:r>
-              <a:rPr sz="2100" b="0">
-                <a:solidFill>
-                  <a:srgbClr val="213444"/>
-                </a:solidFill>
-                <a:latin typeface="Microsoft YaHei"/>
-                <a:ea typeface="Microsoft YaHei"/>
-              </a:rPr>
-              <a:t>成员D【待填写】：网络、建议与总结（18—23页）</a:t>
-            </a:r>
-          </a:p>
-          <a:p>
-            <a:pPr>
-              <a:spcAft>
-                <a:spcPts val="900"/>
-              </a:spcAft>
-            </a:pPr>
-            <a:r>
-              <a:rPr sz="2100" b="0">
-                <a:solidFill>
-                  <a:srgbClr val="213444"/>
-                </a:solidFill>
-                <a:latin typeface="Microsoft YaHei"/>
-                <a:ea typeface="Microsoft YaHei"/>
-              </a:rPr>
-              <a:t/>
-            </a:r>
-          </a:p>
-          <a:p>
-            <a:pPr>
-              <a:spcAft>
-                <a:spcPts val="900"/>
-              </a:spcAft>
-            </a:pPr>
-            <a:r>
-              <a:rPr sz="2100" b="0">
-                <a:solidFill>
-                  <a:srgbClr val="213444"/>
-                </a:solidFill>
-                <a:latin typeface="Microsoft YaHei"/>
-                <a:ea typeface="Microsoft YaHei"/>
-              </a:rPr>
-              <a:t>建议分工须按真实人数和贡献修订。</a:t>
-            </a:r>
-          </a:p>
-        </p:txBody>
-      </p:sp>
-      <p:sp>
-        <p:nvSpPr>
-          <p:cNvPr id="5" name="TextBox 4"/>
-          <p:cNvSpPr txBox="1"/>
-          <p:nvPr/>
-        </p:nvSpPr>
-        <p:spPr>
-          <a:xfrm>
-            <a:off x="502920" y="6419088"/>
-            <a:ext cx="10789920" cy="228600"/>
-          </a:xfrm>
-          <a:prstGeom prst="rect">
-            <a:avLst/>
-          </a:prstGeom>
-          <a:noFill/>
-        </p:spPr>
-        <p:txBody>
-          <a:bodyPr wrap="square" lIns="0" rIns="0" tIns="0" bIns="0">
-            <a:spAutoFit/>
-          </a:bodyPr>
-          <a:lstStyle/>
-          <a:p>
-            <a:pPr>
-              <a:spcAft>
-                <a:spcPts val="900"/>
-              </a:spcAft>
-            </a:pPr>
-            <a:r>
-              <a:rPr sz="1000" b="0">
-                <a:solidFill>
-                  <a:srgbClr val="71818B"/>
-                </a:solidFill>
-                <a:latin typeface="Microsoft YaHei"/>
-                <a:ea typeface="Microsoft YaHei"/>
-              </a:rPr>
-              <a:t>Keep课程样本；观察性分析。全部数值与口径见分析报告及附带结果。</a:t>
-            </a:r>
-          </a:p>
-        </p:txBody>
-      </p:sp>
-      <p:sp>
-        <p:nvSpPr>
-          <p:cNvPr id="6" name="TextBox 5"/>
-          <p:cNvSpPr txBox="1"/>
-          <p:nvPr/>
-        </p:nvSpPr>
-        <p:spPr>
-          <a:xfrm>
-            <a:off x="11201400" y="6419088"/>
-            <a:ext cx="548640" cy="228600"/>
-          </a:xfrm>
-          <a:prstGeom prst="rect">
-            <a:avLst/>
-          </a:prstGeom>
-          <a:noFill/>
-        </p:spPr>
-        <p:txBody>
-          <a:bodyPr wrap="square" lIns="0" rIns="0" tIns="0" bIns="0">
-            <a:spAutoFit/>
-          </a:bodyPr>
-          <a:lstStyle/>
-          <a:p>
-            <a:pPr>
-              <a:spcAft>
-                <a:spcPts val="900"/>
-              </a:spcAft>
-            </a:pPr>
-            <a:r>
-              <a:rPr sz="1000" b="0">
-                <a:solidFill>
-                  <a:srgbClr val="356D9A"/>
-                </a:solidFill>
-                <a:latin typeface="Microsoft YaHei"/>
-                <a:ea typeface="Microsoft YaHei"/>
-              </a:rPr>
-              <a:t>23</a:t>
             </a:r>
           </a:p>
         </p:txBody>

</xml_diff>

<commit_message>
Unify research narrative and add reproducible comment content analysis
</commit_message>
<xml_diff>
--- a/演示文稿.pptx
+++ b/演示文稿.pptx
@@ -26,6 +26,9 @@
     <p:sldId id="274" r:id="rId26"/>
     <p:sldId id="275" r:id="rId27"/>
     <p:sldId id="276" r:id="rId28"/>
+    <p:sldId id="277" r:id="rId29"/>
+    <p:sldId id="278" r:id="rId30"/>
+    <p:sldId id="279" r:id="rId31"/>
   </p:sldIdLst>
   <p:sldSz cx="12191969" cy="6858000" type="screen4x3"/>
   <p:notesSz cx="6858000" cy="9144000"/>
@@ -592,7 +595,7 @@
           <a:lstStyle/>
           <a:p>
             <a:r>
-              <a:t>主题模型纳入至少3个有效词的正文，并排除8条成分贡献近零的记录，占全部帖25.9%。回归控制原词典及作者、日期等因素，区间未包含主题估计误差。</a:t>
+              <a:t>解释同一作者发帖比较。没有曝光、粉丝与统一采集时间，固定效应没有消除全部混杂。若被问到公式，请对应报告中的模型设定部分。</a:t>
             </a:r>
           </a:p>
         </p:txBody>
@@ -662,7 +665,7 @@
           <a:lstStyle/>
           <a:p>
             <a:r>
-              <a:t>解释同一作者发帖比较。没有曝光、粉丝与统一采集时间，固定效应没有消除全部混杂。若被问到公式，请对应报告中的模型设定部分。</a:t>
+              <a:t>图中误差线是原始95%聚类置信区间，未做多重检验调整。积极表达虽然区间未跨0，经过五项检验校正后证据不足。不要把模型总R²约0.688都归因于文本。</a:t>
             </a:r>
           </a:p>
         </p:txBody>
@@ -732,7 +735,7 @@
           <a:lstStyle/>
           <a:p>
             <a:r>
-              <a:t>图中误差线是原始95%聚类置信区间，未做多重检验调整。积极表达虽然区间未跨0，经过五项检验校正后证据不足。不要把模型总R²约0.688都归因于文本。</a:t>
+              <a:t>解释为什么不因长尾强行删除极端值：主模型保留，敏感性规格另行比较。PPML以原始点赞数的条件算术均值为目标，OLS刻画对数结果。</a:t>
             </a:r>
           </a:p>
         </p:txBody>
@@ -802,7 +805,7 @@
           <a:lstStyle/>
           <a:p>
             <a:r>
-              <a:t>解释为什么不因长尾强行删除极端值：主模型保留，敏感性规格另行比较。PPML以原始点赞数的条件算术均值为目标，OLS刻画对数结果。</a:t>
+              <a:t>这一检查考察是否某一个作者决定结果，不新增100轮显著性判断。原始主检验和探索性检验保持分开。</a:t>
             </a:r>
           </a:p>
         </p:txBody>
@@ -872,7 +875,7 @@
           <a:lstStyle/>
           <a:p>
             <a:r>
-              <a:t>这一检查考察是否某一个作者决定结果，不新增100轮显著性判断。原始主检验和探索性检验保持分开。</a:t>
+              <a:t>主题根据不含点赞数的词项和例文命名。主导类别互斥，软权重可以混合。静蹲主题最大作者占91.8%，骑行主题68.2%。</a:t>
             </a:r>
           </a:p>
         </p:txBody>
@@ -942,7 +945,7 @@
           <a:lstStyle/>
           <a:p>
             <a:r>
-              <a:t>这是方法上的边界检查。规则本身能复现不代表语义测量有效，未命中也不等于没有表达。没有使用结果来反复修改词典以获取显著系数。</a:t>
+              <a:t>主题模型纳入至少3个有效词的正文，并排除8条成分贡献近零的记录，占全部帖25.9%。回归控制原词典及作者、日期等因素，区间未包含主题估计误差。</a:t>
             </a:r>
           </a:p>
         </p:txBody>
@@ -1012,7 +1015,7 @@
           <a:lstStyle/>
           <a:p>
             <a:r>
-              <a:t>不要把所有回复都连向帖主。评论最晚到2021年8月，所以网络指标不作为发帖前影响力加入回归。金色表示样本作者，蓝色表示其他参与者；节点大小按加权入度对数缩放。</a:t>
+              <a:t>RQ3先考察评论内容，再讨论关系。每条评论内词项去重，分母为11595条，包括84次自我互动；不同评论ID下的重复短句保留。频数与用户覆盖含义不同，不把常见词直接解释为完整情感或社会支持。</a:t>
             </a:r>
           </a:p>
         </p:txBody>
@@ -1082,7 +1085,7 @@
           <a:lstStyle/>
           <a:p>
             <a:r>
-              <a:t>样本从100位作者帖子出发，根评论天然指向帖主，会形成中心。互惠率按有反向边的有向边占比，不按权重；两个网络节点集合不同，不能解释为行为下降。</a:t>
+              <a:t>角色按每条评论的发言者是否为所属帖主界定。同一用户在不同帖子中可能切换角色，用户数不能相加；组间差异未解释为因果，也未检验逐线程的鼓励—感谢链条。完整规则及19项独立核查见评论文本Notebook。</a:t>
             </a:r>
           </a:p>
         </p:txBody>
@@ -1152,7 +1155,7 @@
           <a:lstStyle/>
           <a:p>
             <a:r>
-              <a:t>比例都以已采集记录为条件。首次帖主回应的中位时延2.05小时仅在观测到回应的线程中计算，未见回应不等于没有回应。</a:t>
+              <a:t>不要把所有回复都连向帖主。评论最晚到2021年8月，所以网络指标不作为发帖前影响力加入回归。金色表示样本作者，蓝色表示其他参与者；节点大小按加权入度对数缩放。</a:t>
             </a:r>
           </a:p>
         </p:txBody>
@@ -1222,7 +1225,7 @@
           <a:lstStyle/>
           <a:p>
             <a:r>
-              <a:t>提出用户层面随机分组，避免同作者跨组污染；三组可为过程记录提示、面向伙伴问题提示和常规发布，固定7天，样本量先做试点再计算。不宣称已发现提升方案。</a:t>
+              <a:t>样本从100位作者帖子出发，根评论天然指向帖主，会形成中心。互惠率按有反向边的有向边占比，不按权重；两个网络节点集合不同，不能解释为行为下降。</a:t>
             </a:r>
           </a:p>
         </p:txBody>
@@ -1292,7 +1295,7 @@
           <a:lstStyle/>
           <a:p>
             <a:r>
-              <a:t>用三个问题串联描述、解释与建议。强调研究观察统计关联，不能回答改写文案是否会因果提高点赞。</a:t>
+              <a:t>RQ1由描述统计回答；RQ2由词典主回归、主题分析与主题回归回答；RQ3同时采用评论内容描述和网络分析。研究围绕帖子内容关联与评论互动两条线展开。</a:t>
             </a:r>
           </a:p>
         </p:txBody>
@@ -1362,7 +1365,7 @@
           <a:lstStyle/>
           <a:p>
             <a:r>
-              <a:t>回到三个研究问题，概括内容分布、条件关联和互动结构的结果。主题、作者剔除及评论时序属于探索性补充，完整参数及输出见附带Notebook与代码。</a:t>
+              <a:t>比例都以已采集记录为条件。首次帖主回应的中位时延2.05小时仅在观测到回应的线程中计算，未见回应不等于没有回应。</a:t>
             </a:r>
           </a:p>
         </p:txBody>
@@ -1432,6 +1435,216 @@
           <a:lstStyle/>
           <a:p>
             <a:r>
+              <a:t>分别回答三个问题，不比较内容和关系对点赞的影响大小。主题回归仅覆盖2470条有效正文，不作为9532帖主回归的重复验证。</a:t>
+            </a:r>
+          </a:p>
+        </p:txBody>
+      </p:sp>
+      <p:sp>
+        <p:nvSpPr>
+          <p:cNvPr id="4" name="Slide Number Placeholder 3"/>
+          <p:cNvSpPr>
+            <a:spLocks noGrp="1"/>
+          </p:cNvSpPr>
+          <p:nvPr>
+            <p:ph type="sldNum" idx="5" sz="quarter"/>
+          </p:nvPr>
+        </p:nvSpPr>
+        <p:spPr/>
+      </p:sp>
+    </p:spTree>
+  </p:cSld>
+  <p:clrMapOvr>
+    <a:masterClrMapping/>
+  </p:clrMapOvr>
+</p:notes>
+</file>
+
+<file path=ppt/notesSlides/notesSlide22.xml><?xml version="1.0" encoding="utf-8"?>
+<p:notes xmlns:a="http://schemas.openxmlformats.org/drawingml/2006/main" xmlns:p="http://schemas.openxmlformats.org/presentationml/2006/main" xmlns:r="http://schemas.openxmlformats.org/officeDocument/2006/relationships">
+  <p:cSld>
+    <p:spTree>
+      <p:nvGrpSpPr>
+        <p:cNvPr id="1" name=""/>
+        <p:cNvGrpSpPr/>
+        <p:nvPr/>
+      </p:nvGrpSpPr>
+      <p:grpSpPr>
+        <a:xfrm>
+          <a:off x="0" y="0"/>
+          <a:ext cx="0" cy="0"/>
+          <a:chOff x="0" y="0"/>
+          <a:chExt cx="0" cy="0"/>
+        </a:xfrm>
+      </p:grpSpPr>
+      <p:sp>
+        <p:nvSpPr>
+          <p:cNvPr id="2" name="Slide Image Placeholder 1"/>
+          <p:cNvSpPr>
+            <a:spLocks noGrp="1"/>
+          </p:cNvSpPr>
+          <p:nvPr>
+            <p:ph type="sldImg" idx="2"/>
+          </p:nvPr>
+        </p:nvSpPr>
+        <p:spPr/>
+      </p:sp>
+      <p:sp>
+        <p:nvSpPr>
+          <p:cNvPr id="3" name="Notes Placeholder 2"/>
+          <p:cNvSpPr>
+            <a:spLocks noGrp="1"/>
+          </p:cNvSpPr>
+          <p:nvPr>
+            <p:ph type="body" idx="3" sz="quarter"/>
+          </p:nvPr>
+        </p:nvSpPr>
+        <p:spPr/>
+        <p:txBody>
+          <a:bodyPr/>
+          <a:lstStyle/>
+          <a:p>
+            <a:r>
+              <a:t>建议从观察到的问题出发：文本关联有限、评论次数与用户覆盖不同、网络指标受采集边界影响。先改进测量和统计，再预先设置对照检验具体干预。</a:t>
+            </a:r>
+          </a:p>
+        </p:txBody>
+      </p:sp>
+      <p:sp>
+        <p:nvSpPr>
+          <p:cNvPr id="4" name="Slide Number Placeholder 3"/>
+          <p:cNvSpPr>
+            <a:spLocks noGrp="1"/>
+          </p:cNvSpPr>
+          <p:nvPr>
+            <p:ph type="sldNum" idx="5" sz="quarter"/>
+          </p:nvPr>
+        </p:nvSpPr>
+        <p:spPr/>
+      </p:sp>
+    </p:spTree>
+  </p:cSld>
+  <p:clrMapOvr>
+    <a:masterClrMapping/>
+  </p:clrMapOvr>
+</p:notes>
+</file>
+
+<file path=ppt/notesSlides/notesSlide23.xml><?xml version="1.0" encoding="utf-8"?>
+<p:notes xmlns:a="http://schemas.openxmlformats.org/drawingml/2006/main" xmlns:p="http://schemas.openxmlformats.org/presentationml/2006/main" xmlns:r="http://schemas.openxmlformats.org/officeDocument/2006/relationships">
+  <p:cSld>
+    <p:spTree>
+      <p:nvGrpSpPr>
+        <p:cNvPr id="1" name=""/>
+        <p:cNvGrpSpPr/>
+        <p:nvPr/>
+      </p:nvGrpSpPr>
+      <p:grpSpPr>
+        <a:xfrm>
+          <a:off x="0" y="0"/>
+          <a:ext cx="0" cy="0"/>
+          <a:chOff x="0" y="0"/>
+          <a:chExt cx="0" cy="0"/>
+        </a:xfrm>
+      </p:grpSpPr>
+      <p:sp>
+        <p:nvSpPr>
+          <p:cNvPr id="2" name="Slide Image Placeholder 1"/>
+          <p:cNvSpPr>
+            <a:spLocks noGrp="1"/>
+          </p:cNvSpPr>
+          <p:nvPr>
+            <p:ph type="sldImg" idx="2"/>
+          </p:nvPr>
+        </p:nvSpPr>
+        <p:spPr/>
+      </p:sp>
+      <p:sp>
+        <p:nvSpPr>
+          <p:cNvPr id="3" name="Notes Placeholder 2"/>
+          <p:cNvSpPr>
+            <a:spLocks noGrp="1"/>
+          </p:cNvSpPr>
+          <p:nvPr>
+            <p:ph type="body" idx="3" sz="quarter"/>
+          </p:nvPr>
+        </p:nvSpPr>
+        <p:spPr/>
+        <p:txBody>
+          <a:bodyPr/>
+          <a:lstStyle/>
+          <a:p>
+            <a:r>
+              <a:t>说明两条分析线各自的适用范围。评论文本采用描述性规则，不把命中率当作情感或社会支持量表；也不将评论的关系结构用于解释点赞回归的系数。</a:t>
+            </a:r>
+          </a:p>
+        </p:txBody>
+      </p:sp>
+      <p:sp>
+        <p:nvSpPr>
+          <p:cNvPr id="4" name="Slide Number Placeholder 3"/>
+          <p:cNvSpPr>
+            <a:spLocks noGrp="1"/>
+          </p:cNvSpPr>
+          <p:nvPr>
+            <p:ph type="sldNum" idx="5" sz="quarter"/>
+          </p:nvPr>
+        </p:nvSpPr>
+        <p:spPr/>
+      </p:sp>
+    </p:spTree>
+  </p:cSld>
+  <p:clrMapOvr>
+    <a:masterClrMapping/>
+  </p:clrMapOvr>
+</p:notes>
+</file>
+
+<file path=ppt/notesSlides/notesSlide24.xml><?xml version="1.0" encoding="utf-8"?>
+<p:notes xmlns:a="http://schemas.openxmlformats.org/drawingml/2006/main" xmlns:p="http://schemas.openxmlformats.org/presentationml/2006/main" xmlns:r="http://schemas.openxmlformats.org/officeDocument/2006/relationships">
+  <p:cSld>
+    <p:spTree>
+      <p:nvGrpSpPr>
+        <p:cNvPr id="1" name=""/>
+        <p:cNvGrpSpPr/>
+        <p:nvPr/>
+      </p:nvGrpSpPr>
+      <p:grpSpPr>
+        <a:xfrm>
+          <a:off x="0" y="0"/>
+          <a:ext cx="0" cy="0"/>
+          <a:chOff x="0" y="0"/>
+          <a:chExt cx="0" cy="0"/>
+        </a:xfrm>
+      </p:grpSpPr>
+      <p:sp>
+        <p:nvSpPr>
+          <p:cNvPr id="2" name="Slide Image Placeholder 1"/>
+          <p:cNvSpPr>
+            <a:spLocks noGrp="1"/>
+          </p:cNvSpPr>
+          <p:nvPr>
+            <p:ph type="sldImg" idx="2"/>
+          </p:nvPr>
+        </p:nvSpPr>
+        <p:spPr/>
+      </p:sp>
+      <p:sp>
+        <p:nvSpPr>
+          <p:cNvPr id="3" name="Notes Placeholder 2"/>
+          <p:cNvSpPr>
+            <a:spLocks noGrp="1"/>
+          </p:cNvSpPr>
+          <p:nvPr>
+            <p:ph type="body" idx="3" sz="quarter"/>
+          </p:nvPr>
+        </p:nvSpPr>
+        <p:spPr/>
+        <p:txBody>
+          <a:bodyPr/>
+          <a:lstStyle/>
+          <a:p>
+            <a:r>
               <a:t>感谢听众并进入讨论。每名组员应汇报自己实际负责的内容。请在提交前替换姓名、组号与学号，并修改为真实贡献。互评需每人独立据实完成，模板不代表完成记录。</a:t>
             </a:r>
           </a:p>
@@ -1502,7 +1715,7 @@
           <a:lstStyle/>
           <a:p>
             <a:r>
-              <a:t>引用Richardson等2010年的随机试验：社区功能降低流失，未发现组间步数增幅显著差异。我们不把该结果套用Keep，而是据此区分参与和行为结果。课程第七周汇报允许初步结果，本稿已有完整分析，可直接用于汇报。</a:t>
+              <a:t>在线社区参与和运动行为结果需要区分。[1]本研究限定平台反馈，不推断健康变化。两条线共同描绘反馈的内容与关系侧面，评论网络未作为发帖前特征加入点赞回归。</a:t>
             </a:r>
           </a:p>
         </p:txBody>
@@ -1922,7 +2135,7 @@
           <a:lstStyle/>
           <a:p>
             <a:r>
-              <a:t>主题根据不含点赞数的词项和例文命名。主导类别互斥，软权重可以混合。静蹲主题最大作者占91.8%，骑行主题68.2%。</a:t>
+              <a:t>这是方法上的边界检查。规则本身能复现不代表语义测量有效，未命中也不等于没有表达。没有使用结果来反复修改词典以获取显著系数。</a:t>
             </a:r>
           </a:p>
         </p:txBody>
@@ -5011,7 +5224,7 @@
                 <a:latin typeface="Microsoft YaHei"/>
                 <a:ea typeface="Microsoft YaHei"/>
               </a:rPr>
-              <a:t>什么样的健身分享更容易获得点赞？</a:t>
+              <a:t>Keep社区中的内容表达与互动反馈</a:t>
             </a:r>
           </a:p>
         </p:txBody>
@@ -5051,7 +5264,7 @@
                 <a:latin typeface="Microsoft YaHei"/>
                 <a:ea typeface="Microsoft YaHei"/>
               </a:rPr>
-              <a:t>Keep 社区帖子文本、点赞表现与评论互动网络分析</a:t>
+              <a:t>基于帖子文本、点赞与评论网络的分析</a:t>
             </a:r>
           </a:p>
           <a:p>
@@ -5305,7 +5518,7 @@
                 <a:latin typeface="Microsoft YaHei"/>
                 <a:ea typeface="Microsoft YaHei"/>
               </a:rPr>
-              <a:t>主题回归仍未提供明确的增量证据</a:t>
+              <a:t>主模型：控制作者和日期</a:t>
             </a:r>
           </a:p>
         </p:txBody>
@@ -5338,24 +5551,24 @@
               </a:spcAft>
             </a:pPr>
             <a:r>
-              <a:rPr sz="2400" b="0">
-                <a:solidFill>
-                  <a:srgbClr val="213444"/>
-                </a:solidFill>
-                <a:latin typeface="Microsoft YaHei"/>
-                <a:ea typeface="Microsoft YaHei"/>
-              </a:rPr>
-              <a:t>以“运动与训练交流”为基准，加入4个主题权重。</a:t>
-            </a:r>
-          </a:p>
-          <a:p>
-            <a:pPr>
-              <a:spcAft>
-                <a:spcPts val="900"/>
-              </a:spcAft>
-            </a:pPr>
-            <a:r>
-              <a:rPr sz="2400" b="0">
+              <a:rPr sz="2100" b="0">
+                <a:solidFill>
+                  <a:srgbClr val="213444"/>
+                </a:solidFill>
+                <a:latin typeface="Microsoft YaHei"/>
+                <a:ea typeface="Microsoft YaHei"/>
+              </a:rPr>
+              <a:t>因变量 ln(1+likes)；全部9,532帖，100位作者。</a:t>
+            </a:r>
+          </a:p>
+          <a:p>
+            <a:pPr>
+              <a:spcAft>
+                <a:spcPts val="900"/>
+              </a:spcAft>
+            </a:pPr>
+            <a:r>
+              <a:rPr sz="2100" b="0">
                 <a:solidFill>
                   <a:srgbClr val="213444"/>
                 </a:solidFill>
@@ -5372,24 +5585,24 @@
               </a:spcAft>
             </a:pPr>
             <a:r>
-              <a:rPr sz="2400" b="0">
-                <a:solidFill>
-                  <a:srgbClr val="213444"/>
-                </a:solidFill>
-                <a:latin typeface="Microsoft YaHei"/>
-                <a:ea typeface="Microsoft YaHei"/>
-              </a:rPr>
-              <a:t>联合检验p=0.166；4项BH校正后均未达到5%显著性水平。</a:t>
-            </a:r>
-          </a:p>
-          <a:p>
-            <a:pPr>
-              <a:spcAft>
-                <a:spcPts val="900"/>
-              </a:spcAft>
-            </a:pPr>
-            <a:r>
-              <a:rPr sz="2400" b="0">
+              <a:rPr sz="2100" b="0">
+                <a:solidFill>
+                  <a:srgbClr val="213444"/>
+                </a:solidFill>
+                <a:latin typeface="Microsoft YaHei"/>
+                <a:ea typeface="Microsoft YaHei"/>
+              </a:rPr>
+              <a:t>作者固定效应 + 日期固定效应 + 内容形式/类型/时段及文本标记。</a:t>
+            </a:r>
+          </a:p>
+          <a:p>
+            <a:pPr>
+              <a:spcAft>
+                <a:spcPts val="900"/>
+              </a:spcAft>
+            </a:pPr>
+            <a:r>
+              <a:rPr sz="2100" b="0">
                 <a:solidFill>
                   <a:srgbClr val="213444"/>
                 </a:solidFill>
@@ -5406,14 +5619,48 @@
               </a:spcAft>
             </a:pPr>
             <a:r>
-              <a:rPr sz="2400" b="0">
-                <a:solidFill>
-                  <a:srgbClr val="213444"/>
-                </a:solidFill>
-                <a:latin typeface="Microsoft YaHei"/>
-                <a:ea typeface="Microsoft YaHei"/>
-              </a:rPr>
-              <a:t>初始化关键词稳定，但不能代替抽样稳定性和测量效度。</a:t>
+              <a:rPr sz="2100" b="0">
+                <a:solidFill>
+                  <a:srgbClr val="213444"/>
+                </a:solidFill>
+                <a:latin typeface="Microsoft YaHei"/>
+                <a:ea typeface="Microsoft YaHei"/>
+              </a:rPr>
+              <a:t>作者聚类CR1标准误；t分布df=99；五项核心检验BH校正。</a:t>
+            </a:r>
+          </a:p>
+          <a:p>
+            <a:pPr>
+              <a:spcAft>
+                <a:spcPts val="900"/>
+              </a:spcAft>
+            </a:pPr>
+            <a:r>
+              <a:rPr sz="2100" b="0">
+                <a:solidFill>
+                  <a:srgbClr val="213444"/>
+                </a:solidFill>
+                <a:latin typeface="Microsoft YaHei"/>
+                <a:ea typeface="Microsoft YaHei"/>
+              </a:rPr>
+              <a:t/>
+            </a:r>
+          </a:p>
+          <a:p>
+            <a:pPr>
+              <a:spcAft>
+                <a:spcPts val="900"/>
+              </a:spcAft>
+            </a:pPr>
+            <a:r>
+              <a:rPr sz="2100" b="0">
+                <a:solidFill>
+                  <a:srgbClr val="213444"/>
+                </a:solidFill>
+                <a:latin typeface="Microsoft YaHei"/>
+                <a:ea typeface="Microsoft YaHei"/>
+              </a:rPr>
+              <a:t>作者内不变的性别、会员、等级等由作者固定效应吸收。</a:t>
             </a:r>
           </a:p>
         </p:txBody>
@@ -5599,21 +5846,45 @@
                 <a:latin typeface="Microsoft YaHei"/>
                 <a:ea typeface="Microsoft YaHei"/>
               </a:rPr>
-              <a:t>主模型：控制作者和日期</a:t>
-            </a:r>
-          </a:p>
-        </p:txBody>
-      </p:sp>
-      <p:sp>
-        <p:nvSpPr>
-          <p:cNvPr id="4" name="TextBox 3"/>
+              <a:t>主结果：核心文本特征的关联证据有限</a:t>
+            </a:r>
+          </a:p>
+        </p:txBody>
+      </p:sp>
+      <p:pic>
+        <p:nvPicPr>
+          <p:cNvPr id="4" name="Picture 3" descr="04_main_coefficients.png"/>
+          <p:cNvPicPr>
+            <a:picLocks noChangeAspect="1"/>
+          </p:cNvPicPr>
+          <p:nvPr/>
+        </p:nvPicPr>
+        <p:blipFill>
+          <a:blip r:embed="rId2"/>
+          <a:stretch>
+            <a:fillRect/>
+          </a:stretch>
+        </p:blipFill>
+        <p:spPr>
+          <a:xfrm>
+            <a:off x="480060" y="2397089"/>
+            <a:ext cx="7452360" cy="2932501"/>
+          </a:xfrm>
+          <a:prstGeom prst="rect">
+            <a:avLst/>
+          </a:prstGeom>
+        </p:spPr>
+      </p:pic>
+      <p:sp>
+        <p:nvSpPr>
+          <p:cNvPr id="5" name="TextBox 4"/>
           <p:cNvSpPr txBox="1"/>
           <p:nvPr/>
         </p:nvSpPr>
         <p:spPr>
           <a:xfrm>
-            <a:off x="731520" y="1874519"/>
-            <a:ext cx="10698480" cy="4297680"/>
+            <a:off x="8229600" y="1828800"/>
+            <a:ext cx="3383280" cy="4297680"/>
           </a:xfrm>
           <a:prstGeom prst="rect">
             <a:avLst/>
@@ -5632,24 +5903,24 @@
               </a:spcAft>
             </a:pPr>
             <a:r>
-              <a:rPr sz="2100" b="0">
-                <a:solidFill>
-                  <a:srgbClr val="213444"/>
-                </a:solidFill>
-                <a:latin typeface="Microsoft YaHei"/>
-                <a:ea typeface="Microsoft YaHei"/>
-              </a:rPr>
-              <a:t>因变量 ln(1+likes)；全部9,532帖，100位作者。</a:t>
-            </a:r>
-          </a:p>
-          <a:p>
-            <a:pPr>
-              <a:spcAft>
-                <a:spcPts val="900"/>
-              </a:spcAft>
-            </a:pPr>
-            <a:r>
-              <a:rPr sz="2100" b="0">
+              <a:rPr sz="1900" b="0">
+                <a:solidFill>
+                  <a:srgbClr val="213444"/>
+                </a:solidFill>
+                <a:latin typeface="Microsoft YaHei"/>
+                <a:ea typeface="Microsoft YaHei"/>
+              </a:rPr>
+              <a:t>五项核心特征联合检验p=0.130；新增R²仅0.065个百分点。</a:t>
+            </a:r>
+          </a:p>
+          <a:p>
+            <a:pPr>
+              <a:spcAft>
+                <a:spcPts val="900"/>
+              </a:spcAft>
+            </a:pPr>
+            <a:r>
+              <a:rPr sz="1900" b="0">
                 <a:solidFill>
                   <a:srgbClr val="213444"/>
                 </a:solidFill>
@@ -5666,24 +5937,24 @@
               </a:spcAft>
             </a:pPr>
             <a:r>
-              <a:rPr sz="2100" b="0">
-                <a:solidFill>
-                  <a:srgbClr val="213444"/>
-                </a:solidFill>
-                <a:latin typeface="Microsoft YaHei"/>
-                <a:ea typeface="Microsoft YaHei"/>
-              </a:rPr>
-              <a:t>作者固定效应 + 日期固定效应 + 内容形式/类型/时段及文本标记。</a:t>
-            </a:r>
-          </a:p>
-          <a:p>
-            <a:pPr>
-              <a:spcAft>
-                <a:spcPts val="900"/>
-              </a:spcAft>
-            </a:pPr>
-            <a:r>
-              <a:rPr sz="2100" b="0">
+              <a:rPr sz="1900" b="0">
+                <a:solidFill>
+                  <a:srgbClr val="213444"/>
+                </a:solidFill>
+                <a:latin typeface="Microsoft YaHei"/>
+                <a:ea typeface="Microsoft YaHei"/>
+              </a:rPr>
+              <a:t>积极表达词β=-0.086；原始p=0.016，BH q=0.079。</a:t>
+            </a:r>
+          </a:p>
+          <a:p>
+            <a:pPr>
+              <a:spcAft>
+                <a:spcPts val="900"/>
+              </a:spcAft>
+            </a:pPr>
+            <a:r>
+              <a:rPr sz="1900" b="0">
                 <a:solidFill>
                   <a:srgbClr val="213444"/>
                 </a:solidFill>
@@ -5700,55 +5971,21 @@
               </a:spcAft>
             </a:pPr>
             <a:r>
-              <a:rPr sz="2100" b="0">
-                <a:solidFill>
-                  <a:srgbClr val="213444"/>
-                </a:solidFill>
-                <a:latin typeface="Microsoft YaHei"/>
-                <a:ea typeface="Microsoft YaHei"/>
-              </a:rPr>
-              <a:t>作者聚类CR1标准误；t分布df=99；五项核心检验BH校正。</a:t>
-            </a:r>
-          </a:p>
-          <a:p>
-            <a:pPr>
-              <a:spcAft>
-                <a:spcPts val="900"/>
-              </a:spcAft>
-            </a:pPr>
-            <a:r>
-              <a:rPr sz="2100" b="0">
-                <a:solidFill>
-                  <a:srgbClr val="213444"/>
-                </a:solidFill>
-                <a:latin typeface="Microsoft YaHei"/>
-                <a:ea typeface="Microsoft YaHei"/>
-              </a:rPr>
-              <a:t/>
-            </a:r>
-          </a:p>
-          <a:p>
-            <a:pPr>
-              <a:spcAft>
-                <a:spcPts val="900"/>
-              </a:spcAft>
-            </a:pPr>
-            <a:r>
-              <a:rPr sz="2100" b="0">
-                <a:solidFill>
-                  <a:srgbClr val="213444"/>
-                </a:solidFill>
-                <a:latin typeface="Microsoft YaHei"/>
-                <a:ea typeface="Microsoft YaHei"/>
-              </a:rPr>
-              <a:t>作者内不变的性别、会员、等级等由作者固定效应吸收。</a:t>
-            </a:r>
-          </a:p>
-        </p:txBody>
-      </p:sp>
-      <p:sp>
-        <p:nvSpPr>
-          <p:cNvPr id="5" name="TextBox 4"/>
+              <a:rPr sz="1900" b="0">
+                <a:solidFill>
+                  <a:srgbClr val="213444"/>
+                </a:solidFill>
+                <a:latin typeface="Microsoft YaHei"/>
+                <a:ea typeface="Microsoft YaHei"/>
+              </a:rPr>
+              <a:t>不显著不是证明无作用；现有测量下证据不足。</a:t>
+            </a:r>
+          </a:p>
+        </p:txBody>
+      </p:sp>
+      <p:sp>
+        <p:nvSpPr>
+          <p:cNvPr id="6" name="TextBox 5"/>
           <p:cNvSpPr txBox="1"/>
           <p:nvPr/>
         </p:nvSpPr>
@@ -5788,7 +6025,7 @@
       </p:sp>
       <p:sp>
         <p:nvSpPr>
-          <p:cNvPr id="6" name="TextBox 5"/>
+          <p:cNvPr id="7" name="TextBox 6"/>
           <p:cNvSpPr txBox="1"/>
           <p:nvPr/>
         </p:nvSpPr>
@@ -5927,14 +6164,14 @@
                 <a:latin typeface="Microsoft YaHei"/>
                 <a:ea typeface="Microsoft YaHei"/>
               </a:rPr>
-              <a:t>主结果：核心文本特征的关联证据有限</a:t>
+              <a:t>稳健性：结论依赖尺度与规格</a:t>
             </a:r>
           </a:p>
         </p:txBody>
       </p:sp>
       <p:pic>
         <p:nvPicPr>
-          <p:cNvPr id="4" name="Picture 3" descr="04_main_coefficients.png"/>
+          <p:cNvPr id="4" name="Picture 3" descr="05_robustness.png"/>
           <p:cNvPicPr>
             <a:picLocks noChangeAspect="1"/>
           </p:cNvPicPr>
@@ -5948,8 +6185,8 @@
         </p:blipFill>
         <p:spPr>
           <a:xfrm>
-            <a:off x="480060" y="2397089"/>
-            <a:ext cx="7452360" cy="2932501"/>
+            <a:off x="480060" y="2716421"/>
+            <a:ext cx="7452360" cy="2293837"/>
           </a:xfrm>
           <a:prstGeom prst="rect">
             <a:avLst/>
@@ -5991,7 +6228,7 @@
                 <a:latin typeface="Microsoft YaHei"/>
                 <a:ea typeface="Microsoft YaHei"/>
               </a:rPr>
-              <a:t>五项核心特征联合检验p=0.130；新增R²仅0.065个百分点。</a:t>
+              <a:t>检查仅可见正文、去最高1%点赞、作者等权、PPML计数模型。</a:t>
             </a:r>
           </a:p>
           <a:p>
@@ -6025,7 +6262,7 @@
                 <a:latin typeface="Microsoft YaHei"/>
                 <a:ea typeface="Microsoft YaHei"/>
               </a:rPr>
-              <a:t>积极表达词β=-0.086；原始p=0.016，BH q=0.079。</a:t>
+              <a:t>积极表达词的PPML区间包含0，原始p=0.103。</a:t>
             </a:r>
           </a:p>
           <a:p>
@@ -6059,7 +6296,7 @@
                 <a:latin typeface="Microsoft YaHei"/>
                 <a:ea typeface="Microsoft YaHei"/>
               </a:rPr>
-              <a:t>不显著不是证明无作用；现有测量下证据不足。</a:t>
+              <a:t>OLS与PPML的估计量不同；不能以某个规格显著就宣称稳健。</a:t>
             </a:r>
           </a:p>
         </p:txBody>
@@ -6245,14 +6482,14 @@
                 <a:latin typeface="Microsoft YaHei"/>
                 <a:ea typeface="Microsoft YaHei"/>
               </a:rPr>
-              <a:t>稳健性：结论依赖尺度与规格</a:t>
+              <a:t>逐作者剔除：点估计与统计证据分开判断</a:t>
             </a:r>
           </a:p>
         </p:txBody>
       </p:sp>
       <p:pic>
         <p:nvPicPr>
-          <p:cNvPr id="4" name="Picture 3" descr="05_robustness.png"/>
+          <p:cNvPr id="4" name="Picture 3" descr="12_author_influence.png"/>
           <p:cNvPicPr>
             <a:picLocks noChangeAspect="1"/>
           </p:cNvPicPr>
@@ -6266,8 +6503,8 @@
         </p:blipFill>
         <p:spPr>
           <a:xfrm>
-            <a:off x="480060" y="2716421"/>
-            <a:ext cx="7452360" cy="2293837"/>
+            <a:off x="480060" y="2456960"/>
+            <a:ext cx="7452360" cy="2812758"/>
           </a:xfrm>
           <a:prstGeom prst="rect">
             <a:avLst/>
@@ -6309,7 +6546,7 @@
                 <a:latin typeface="Microsoft YaHei"/>
                 <a:ea typeface="Microsoft YaHei"/>
               </a:rPr>
-              <a:t>检查仅可见正文、去最高1%点赞、作者等权、PPML计数模型。</a:t>
+              <a:t>逐次剔除1位作者，重复100次主模型估计。</a:t>
             </a:r>
           </a:p>
           <a:p>
@@ -6343,7 +6580,7 @@
                 <a:latin typeface="Microsoft YaHei"/>
                 <a:ea typeface="Microsoft YaHei"/>
               </a:rPr>
-              <a:t>积极表达词的PPML区间包含0，原始p=0.103。</a:t>
+              <a:t>积极表达词始终为负，范围[-0.100,-0.074]。</a:t>
             </a:r>
           </a:p>
           <a:p>
@@ -6377,7 +6614,7 @@
                 <a:latin typeface="Microsoft YaHei"/>
                 <a:ea typeface="Microsoft YaHei"/>
               </a:rPr>
-              <a:t>OLS与PPML的估计量不同；不能以某个规格显著就宣称稳健。</a:t>
+              <a:t>符号稳定不能替代BH校正和PPML结果；社交词在11次剔除后转正。</a:t>
             </a:r>
           </a:p>
         </p:txBody>
@@ -6563,14 +6800,14 @@
                 <a:latin typeface="Microsoft YaHei"/>
                 <a:ea typeface="Microsoft YaHei"/>
               </a:rPr>
-              <a:t>逐作者剔除：点估计与统计证据分开判断</a:t>
+              <a:t>NMF补充识别内容表达模式</a:t>
             </a:r>
           </a:p>
         </p:txBody>
       </p:sp>
       <p:pic>
         <p:nvPicPr>
-          <p:cNvPr id="4" name="Picture 3" descr="12_author_influence.png"/>
+          <p:cNvPr id="4" name="Picture 3" descr="09_topics.png"/>
           <p:cNvPicPr>
             <a:picLocks noChangeAspect="1"/>
           </p:cNvPicPr>
@@ -6584,8 +6821,8 @@
         </p:blipFill>
         <p:spPr>
           <a:xfrm>
-            <a:off x="480060" y="2456960"/>
-            <a:ext cx="7452360" cy="2812758"/>
+            <a:off x="480060" y="2519060"/>
+            <a:ext cx="7452360" cy="2688558"/>
           </a:xfrm>
           <a:prstGeom prst="rect">
             <a:avLst/>
@@ -6627,7 +6864,7 @@
                 <a:latin typeface="Microsoft YaHei"/>
                 <a:ea typeface="Microsoft YaHei"/>
               </a:rPr>
-              <a:t>逐次剔除1位作者，重复100次主模型估计。</a:t>
+              <a:t>2,470帖、86位作者，1,046词项；主题数固定为5。</a:t>
             </a:r>
           </a:p>
           <a:p>
@@ -6661,7 +6898,7 @@
                 <a:latin typeface="Microsoft YaHei"/>
                 <a:ea typeface="Microsoft YaHei"/>
               </a:rPr>
-              <a:t>积极表达词始终为负，范围[-0.100,-0.074]。</a:t>
+              <a:t>运动与训练交流52.7%，生活感悟与问候35.8%。</a:t>
             </a:r>
           </a:p>
           <a:p>
@@ -6695,7 +6932,7 @@
                 <a:latin typeface="Microsoft YaHei"/>
                 <a:ea typeface="Microsoft YaHei"/>
               </a:rPr>
-              <a:t>符号稳定不能替代BH校正和PPML结果；社交词在11次剔除后转正。</a:t>
+              <a:t>静蹲、骑行主题集中于少数作者，反映重复记录习惯。</a:t>
             </a:r>
           </a:p>
         </p:txBody>
@@ -6881,7 +7118,7 @@
                 <a:latin typeface="Microsoft YaHei"/>
                 <a:ea typeface="Microsoft YaHei"/>
               </a:rPr>
-              <a:t>词典测量也需要接受检查</a:t>
+              <a:t>主题回归仍未提供明确的增量证据</a:t>
             </a:r>
           </a:p>
         </p:txBody>
@@ -6921,7 +7158,7 @@
                 <a:latin typeface="Microsoft YaHei"/>
                 <a:ea typeface="Microsoft YaHei"/>
               </a:rPr>
-              <a:t>40个帖子—特征检查单元：按规则命中分层抽样，无点赞展示。</a:t>
+              <a:t>以“运动与训练交流”为基准，加入4个主题权重。</a:t>
             </a:r>
           </a:p>
           <a:p>
@@ -6955,7 +7192,7 @@
                 <a:latin typeface="Microsoft YaHei"/>
                 <a:ea typeface="Microsoft YaHei"/>
               </a:rPr>
-              <a:t>“完成”可能指绘画；“一起”可能描述线下朋友；问号可能是反问。</a:t>
+              <a:t>联合检验p=0.166；4项BH校正后均未达到5%显著性水平。</a:t>
             </a:r>
           </a:p>
           <a:p>
@@ -6989,7 +7226,7 @@
                 <a:latin typeface="Microsoft YaHei"/>
                 <a:ea typeface="Microsoft YaHei"/>
               </a:rPr>
-              <a:t>Codex辅助抽查，未做独立人工双编码；不宣称准确率。</a:t>
+              <a:t>初始化关键词稳定，但不能代替抽样稳定性和测量效度。</a:t>
             </a:r>
           </a:p>
         </p:txBody>
@@ -7175,14 +7412,14 @@
                 <a:latin typeface="Microsoft YaHei"/>
                 <a:ea typeface="Microsoft YaHei"/>
               </a:rPr>
-              <a:t>评论网络：明确每条边的指向</a:t>
+              <a:t>评论文本：短句频数与参与覆盖</a:t>
             </a:r>
           </a:p>
         </p:txBody>
       </p:sp>
       <p:pic>
         <p:nvPicPr>
-          <p:cNvPr id="4" name="Picture 3" descr="06_comment_network.png"/>
+          <p:cNvPr id="4" name="Picture 3" descr="14_comment_words.png"/>
           <p:cNvPicPr>
             <a:picLocks noChangeAspect="1"/>
           </p:cNvPicPr>
@@ -7196,8 +7433,8 @@
         </p:blipFill>
         <p:spPr>
           <a:xfrm>
-            <a:off x="578279" y="1851660"/>
-            <a:ext cx="7255921" cy="4023360"/>
+            <a:off x="480060" y="2355727"/>
+            <a:ext cx="7452360" cy="3015225"/>
           </a:xfrm>
           <a:prstGeom prst="rect">
             <a:avLst/>
@@ -7239,7 +7476,7 @@
                 <a:latin typeface="Microsoft YaHei"/>
                 <a:ea typeface="Microsoft YaHei"/>
               </a:rPr>
-              <a:t>根评论：评论者→帖主；明确回复：回复者→replyUserId。</a:t>
+              <a:t>11,595条评论、2,910位发言者；清理后字符数中位数为6。</a:t>
             </a:r>
           </a:p>
           <a:p>
@@ -7273,7 +7510,7 @@
                 <a:latin typeface="Microsoft YaHei"/>
                 <a:ea typeface="Microsoft YaHei"/>
               </a:rPr>
-              <a:t>去重后移除84次自我互动；11,511事件合并为4,069条边。</a:t>
+              <a:t>1,373条（11.8%）仅有标记或符号。</a:t>
             </a:r>
           </a:p>
           <a:p>
@@ -7307,7 +7544,7 @@
                 <a:latin typeface="Microsoft YaHei"/>
                 <a:ea typeface="Microsoft YaHei"/>
               </a:rPr>
-              <a:t>2,932个有边节点；箭头在图中省略，原数据保持有向。</a:t>
+              <a:t>“加油”612条、431位用户；“谢谢”359条、53位用户。</a:t>
             </a:r>
           </a:p>
         </p:txBody>
@@ -7493,14 +7730,14 @@
                 <a:latin typeface="Microsoft YaHei"/>
                 <a:ea typeface="Microsoft YaHei"/>
               </a:rPr>
-              <a:t>互动集中，但样本边界影响很大</a:t>
+              <a:t>评论内容：发言角色的字面表达差异</a:t>
             </a:r>
           </a:p>
         </p:txBody>
       </p:sp>
       <p:pic>
         <p:nvPicPr>
-          <p:cNvPr id="4" name="Picture 3" descr="07_network_concentration.png"/>
+          <p:cNvPr id="4" name="Picture 3" descr="15_comment_expressions.png"/>
           <p:cNvPicPr>
             <a:picLocks noChangeAspect="1"/>
           </p:cNvPicPr>
@@ -7514,8 +7751,8 @@
         </p:blipFill>
         <p:spPr>
           <a:xfrm>
-            <a:off x="480060" y="2614975"/>
-            <a:ext cx="7452360" cy="2496729"/>
+            <a:off x="480060" y="2614787"/>
+            <a:ext cx="7452360" cy="2497105"/>
           </a:xfrm>
           <a:prstGeom prst="rect">
             <a:avLst/>
@@ -7557,7 +7794,7 @@
                 <a:latin typeface="Microsoft YaHei"/>
                 <a:ea typeface="Microsoft YaHei"/>
               </a:rPr>
-              <a:t>前10位接收者获得54.0%互动；第一位12.0%。</a:t>
+              <a:t>鼓励或赞许词：其他用户16.9%，帖主4.5%。</a:t>
             </a:r>
           </a:p>
           <a:p>
@@ -7591,7 +7828,7 @@
                 <a:latin typeface="Microsoft YaHei"/>
                 <a:ea typeface="Microsoft YaHei"/>
               </a:rPr>
-              <a:t>整体互惠率49.6%；仅明确回复子网络29.9%。</a:t>
+              <a:t>感谢词：帖主7.9%，其他用户0.6%。</a:t>
             </a:r>
           </a:p>
           <a:p>
@@ -7625,7 +7862,7 @@
                 <a:latin typeface="Microsoft YaHei"/>
                 <a:ea typeface="Microsoft YaHei"/>
               </a:rPr>
-              <a:t>这是采集网络的接收事件数，不是平台影响力或独立粉丝数。</a:t>
+              <a:t>规则可重叠；只描述字面表达，未作语义效度验证。</a:t>
             </a:r>
           </a:p>
         </p:txBody>
@@ -7811,14 +8048,14 @@
                 <a:latin typeface="Microsoft YaHei"/>
                 <a:ea typeface="Microsoft YaHei"/>
               </a:rPr>
-              <a:t>网络互惠主要体现围绕帖主的回应</a:t>
+              <a:t>评论网络：明确每条边的指向</a:t>
             </a:r>
           </a:p>
         </p:txBody>
       </p:sp>
       <p:pic>
         <p:nvPicPr>
-          <p:cNvPr id="4" name="Picture 3" descr="13_comment_timing_roles.png"/>
+          <p:cNvPr id="4" name="Picture 3" descr="06_comment_network.png"/>
           <p:cNvPicPr>
             <a:picLocks noChangeAspect="1"/>
           </p:cNvPicPr>
@@ -7832,8 +8069,8 @@
         </p:blipFill>
         <p:spPr>
           <a:xfrm>
-            <a:off x="480060" y="2649480"/>
-            <a:ext cx="7452360" cy="2427718"/>
+            <a:off x="578279" y="1851660"/>
+            <a:ext cx="7255921" cy="4023360"/>
           </a:xfrm>
           <a:prstGeom prst="rect">
             <a:avLst/>
@@ -7875,7 +8112,7 @@
                 <a:latin typeface="Microsoft YaHei"/>
                 <a:ea typeface="Microsoft YaHei"/>
               </a:rPr>
-              <a:t>已采集评论中64.5%在24小时内，82.2%在7天内。</a:t>
+              <a:t>根评论：评论者→帖主；明确回复：回复者→replyUserId。</a:t>
             </a:r>
           </a:p>
           <a:p>
@@ -7909,7 +8146,7 @@
                 <a:latin typeface="Microsoft YaHei"/>
                 <a:ea typeface="Microsoft YaHei"/>
               </a:rPr>
-              <a:t>4,902次明确回复中，89.0%由帖主发出；用户彼此回复仅2.0%。</a:t>
+              <a:t>去重后移除84次自我互动；11,511事件合并为4,069条边。</a:t>
             </a:r>
           </a:p>
           <a:p>
@@ -7943,7 +8180,7 @@
                 <a:latin typeface="Microsoft YaHei"/>
                 <a:ea typeface="Microsoft YaHei"/>
               </a:rPr>
-              <a:t>首周互惠率74.1%，全部记录49.6%；窗口和采集边界影响结构。</a:t>
+              <a:t>2,932个有边节点；箭头在图中省略，原数据保持有向。</a:t>
             </a:r>
           </a:p>
         </p:txBody>
@@ -8129,21 +8366,45 @@
                 <a:latin typeface="Microsoft YaHei"/>
                 <a:ea typeface="Microsoft YaHei"/>
               </a:rPr>
-              <a:t>建议：把表达方案交给对照实验</a:t>
-            </a:r>
-          </a:p>
-        </p:txBody>
-      </p:sp>
-      <p:sp>
-        <p:nvSpPr>
-          <p:cNvPr id="4" name="TextBox 3"/>
+              <a:t>互动集中，但样本边界影响很大</a:t>
+            </a:r>
+          </a:p>
+        </p:txBody>
+      </p:sp>
+      <p:pic>
+        <p:nvPicPr>
+          <p:cNvPr id="4" name="Picture 3" descr="07_network_concentration.png"/>
+          <p:cNvPicPr>
+            <a:picLocks noChangeAspect="1"/>
+          </p:cNvPicPr>
+          <p:nvPr/>
+        </p:nvPicPr>
+        <p:blipFill>
+          <a:blip r:embed="rId2"/>
+          <a:stretch>
+            <a:fillRect/>
+          </a:stretch>
+        </p:blipFill>
+        <p:spPr>
+          <a:xfrm>
+            <a:off x="480060" y="2614975"/>
+            <a:ext cx="7452360" cy="2496729"/>
+          </a:xfrm>
+          <a:prstGeom prst="rect">
+            <a:avLst/>
+          </a:prstGeom>
+        </p:spPr>
+      </p:pic>
+      <p:sp>
+        <p:nvSpPr>
+          <p:cNvPr id="5" name="TextBox 4"/>
           <p:cNvSpPr txBox="1"/>
           <p:nvPr/>
         </p:nvSpPr>
         <p:spPr>
           <a:xfrm>
-            <a:off x="731520" y="1874519"/>
-            <a:ext cx="10698480" cy="4297680"/>
+            <a:off x="8229600" y="1828800"/>
+            <a:ext cx="3383280" cy="4297680"/>
           </a:xfrm>
           <a:prstGeom prst="rect">
             <a:avLst/>
@@ -8162,24 +8423,24 @@
               </a:spcAft>
             </a:pPr>
             <a:r>
-              <a:rPr sz="2100" b="0">
-                <a:solidFill>
-                  <a:srgbClr val="213444"/>
-                </a:solidFill>
-                <a:latin typeface="Microsoft YaHei"/>
-                <a:ea typeface="Microsoft YaHei"/>
-              </a:rPr>
-              <a:t>不承诺“加某个词就会涨赞”；先保证真实、完整且易交流的内容。</a:t>
-            </a:r>
-          </a:p>
-          <a:p>
-            <a:pPr>
-              <a:spcAft>
-                <a:spcPts val="900"/>
-              </a:spcAft>
-            </a:pPr>
-            <a:r>
-              <a:rPr sz="2100" b="0">
+              <a:rPr sz="1900" b="0">
+                <a:solidFill>
+                  <a:srgbClr val="213444"/>
+                </a:solidFill>
+                <a:latin typeface="Microsoft YaHei"/>
+                <a:ea typeface="Microsoft YaHei"/>
+              </a:rPr>
+              <a:t>前10位接收者获得54.0%互动；第一位12.0%。</a:t>
+            </a:r>
+          </a:p>
+          <a:p>
+            <a:pPr>
+              <a:spcAft>
+                <a:spcPts val="900"/>
+              </a:spcAft>
+            </a:pPr>
+            <a:r>
+              <a:rPr sz="1900" b="0">
                 <a:solidFill>
                   <a:srgbClr val="213444"/>
                 </a:solidFill>
@@ -8196,24 +8457,24 @@
               </a:spcAft>
             </a:pPr>
             <a:r>
-              <a:rPr sz="2100" b="0">
-                <a:solidFill>
-                  <a:srgbClr val="213444"/>
-                </a:solidFill>
-                <a:latin typeface="Microsoft YaHei"/>
-                <a:ea typeface="Microsoft YaHei"/>
-              </a:rPr>
-              <a:t>固定观察窗口、记录真实曝光；按作者随机分组评估提示文案。</a:t>
-            </a:r>
-          </a:p>
-          <a:p>
-            <a:pPr>
-              <a:spcAft>
-                <a:spcPts val="900"/>
-              </a:spcAft>
-            </a:pPr>
-            <a:r>
-              <a:rPr sz="2100" b="0">
+              <a:rPr sz="1900" b="0">
+                <a:solidFill>
+                  <a:srgbClr val="213444"/>
+                </a:solidFill>
+                <a:latin typeface="Microsoft YaHei"/>
+                <a:ea typeface="Microsoft YaHei"/>
+              </a:rPr>
+              <a:t>整体互惠率49.6%；仅明确回复子网络29.9%。</a:t>
+            </a:r>
+          </a:p>
+          <a:p>
+            <a:pPr>
+              <a:spcAft>
+                <a:spcPts val="900"/>
+              </a:spcAft>
+            </a:pPr>
+            <a:r>
+              <a:rPr sz="1900" b="0">
                 <a:solidFill>
                   <a:srgbClr val="213444"/>
                 </a:solidFill>
@@ -8230,55 +8491,21 @@
               </a:spcAft>
             </a:pPr>
             <a:r>
-              <a:rPr sz="2100" b="0">
-                <a:solidFill>
-                  <a:srgbClr val="213444"/>
-                </a:solidFill>
-                <a:latin typeface="Microsoft YaHei"/>
-                <a:ea typeface="Microsoft YaHei"/>
-              </a:rPr>
-              <a:t>关注低反馈用户与回复质量，同时验证抽样是否造成集中。</a:t>
-            </a:r>
-          </a:p>
-          <a:p>
-            <a:pPr>
-              <a:spcAft>
-                <a:spcPts val="900"/>
-              </a:spcAft>
-            </a:pPr>
-            <a:r>
-              <a:rPr sz="2100" b="0">
-                <a:solidFill>
-                  <a:srgbClr val="213444"/>
-                </a:solidFill>
-                <a:latin typeface="Microsoft YaHei"/>
-                <a:ea typeface="Microsoft YaHei"/>
-              </a:rPr>
-              <a:t/>
-            </a:r>
-          </a:p>
-          <a:p>
-            <a:pPr>
-              <a:spcAft>
-                <a:spcPts val="900"/>
-              </a:spcAft>
-            </a:pPr>
-            <a:r>
-              <a:rPr sz="2100" b="0">
-                <a:solidFill>
-                  <a:srgbClr val="213444"/>
-                </a:solidFill>
-                <a:latin typeface="Microsoft YaHei"/>
-                <a:ea typeface="Microsoft YaHei"/>
-              </a:rPr>
-              <a:t>未执行的实验是后续设计，不是已证实的增长方案。</a:t>
-            </a:r>
-          </a:p>
-        </p:txBody>
-      </p:sp>
-      <p:sp>
-        <p:nvSpPr>
-          <p:cNvPr id="5" name="TextBox 4"/>
+              <a:rPr sz="1900" b="0">
+                <a:solidFill>
+                  <a:srgbClr val="213444"/>
+                </a:solidFill>
+                <a:latin typeface="Microsoft YaHei"/>
+                <a:ea typeface="Microsoft YaHei"/>
+              </a:rPr>
+              <a:t>这是采集网络的接收事件数，不是平台影响力或独立粉丝数。</a:t>
+            </a:r>
+          </a:p>
+        </p:txBody>
+      </p:sp>
+      <p:sp>
+        <p:nvSpPr>
+          <p:cNvPr id="6" name="TextBox 5"/>
           <p:cNvSpPr txBox="1"/>
           <p:nvPr/>
         </p:nvSpPr>
@@ -8318,7 +8545,7 @@
       </p:sp>
       <p:sp>
         <p:nvSpPr>
-          <p:cNvPr id="6" name="TextBox 5"/>
+          <p:cNvPr id="7" name="TextBox 6"/>
           <p:cNvSpPr txBox="1"/>
           <p:nvPr/>
         </p:nvSpPr>
@@ -8457,7 +8684,7 @@
                 <a:latin typeface="Microsoft YaHei"/>
                 <a:ea typeface="Microsoft YaHei"/>
               </a:rPr>
-              <a:t>研究问题：表达方式与点赞有关吗？</a:t>
+              <a:t>三个研究问题：分布、关联与互动</a:t>
             </a:r>
           </a:p>
         </p:txBody>
@@ -8497,7 +8724,7 @@
                 <a:latin typeface="Microsoft YaHei"/>
                 <a:ea typeface="Microsoft YaHei"/>
               </a:rPr>
-              <a:t>RQ1：帖子、表达方式与点赞如何分布？</a:t>
+              <a:t>RQ1：样本帖子、表达方式及点赞如何分布？</a:t>
             </a:r>
           </a:p>
           <a:p>
@@ -8531,7 +8758,7 @@
                 <a:latin typeface="Microsoft YaHei"/>
                 <a:ea typeface="Microsoft YaHei"/>
               </a:rPr>
-              <a:t>RQ2：同一作者的文本特征与点赞是否相关？</a:t>
+              <a:t>RQ2：不同文本特征与点赞是否相关？</a:t>
             </a:r>
           </a:p>
           <a:p>
@@ -8565,7 +8792,7 @@
                 <a:latin typeface="Microsoft YaHei"/>
                 <a:ea typeface="Microsoft YaHei"/>
               </a:rPr>
-              <a:t>RQ3：评论连接了谁，互动是否集中？</a:t>
+              <a:t>RQ3：评论主要表达什么、如何连接用户？互动集中在哪里？</a:t>
             </a:r>
           </a:p>
         </p:txBody>
@@ -8751,21 +8978,45 @@
                 <a:latin typeface="Microsoft YaHei"/>
                 <a:ea typeface="Microsoft YaHei"/>
               </a:rPr>
-              <a:t>结论、局限与可复现性</a:t>
-            </a:r>
-          </a:p>
-        </p:txBody>
-      </p:sp>
-      <p:sp>
-        <p:nvSpPr>
-          <p:cNvPr id="4" name="TextBox 3"/>
+              <a:t>网络互惠主要体现围绕帖主的回应</a:t>
+            </a:r>
+          </a:p>
+        </p:txBody>
+      </p:sp>
+      <p:pic>
+        <p:nvPicPr>
+          <p:cNvPr id="4" name="Picture 3" descr="13_comment_timing_roles.png"/>
+          <p:cNvPicPr>
+            <a:picLocks noChangeAspect="1"/>
+          </p:cNvPicPr>
+          <p:nvPr/>
+        </p:nvPicPr>
+        <p:blipFill>
+          <a:blip r:embed="rId2"/>
+          <a:stretch>
+            <a:fillRect/>
+          </a:stretch>
+        </p:blipFill>
+        <p:spPr>
+          <a:xfrm>
+            <a:off x="480060" y="2649480"/>
+            <a:ext cx="7452360" cy="2427718"/>
+          </a:xfrm>
+          <a:prstGeom prst="rect">
+            <a:avLst/>
+          </a:prstGeom>
+        </p:spPr>
+      </p:pic>
+      <p:sp>
+        <p:nvSpPr>
+          <p:cNvPr id="5" name="TextBox 4"/>
           <p:cNvSpPr txBox="1"/>
           <p:nvPr/>
         </p:nvSpPr>
         <p:spPr>
           <a:xfrm>
-            <a:off x="731520" y="1874519"/>
-            <a:ext cx="10698480" cy="4297680"/>
+            <a:off x="8229600" y="1828800"/>
+            <a:ext cx="3383280" cy="4297680"/>
           </a:xfrm>
           <a:prstGeom prst="rect">
             <a:avLst/>
@@ -8784,24 +9035,24 @@
               </a:spcAft>
             </a:pPr>
             <a:r>
-              <a:rPr sz="2100" b="0">
-                <a:solidFill>
-                  <a:srgbClr val="213444"/>
-                </a:solidFill>
-                <a:latin typeface="Microsoft YaHei"/>
-                <a:ea typeface="Microsoft YaHei"/>
-              </a:rPr>
-              <a:t>词典特征与主题权重的回归均未提供明确、稳定的点赞关联证据。</a:t>
-            </a:r>
-          </a:p>
-          <a:p>
-            <a:pPr>
-              <a:spcAft>
-                <a:spcPts val="900"/>
-              </a:spcAft>
-            </a:pPr>
-            <a:r>
-              <a:rPr sz="2100" b="0">
+              <a:rPr sz="1900" b="0">
+                <a:solidFill>
+                  <a:srgbClr val="213444"/>
+                </a:solidFill>
+                <a:latin typeface="Microsoft YaHei"/>
+                <a:ea typeface="Microsoft YaHei"/>
+              </a:rPr>
+              <a:t>已采集评论中64.5%在24小时内，82.2%在7天内。</a:t>
+            </a:r>
+          </a:p>
+          <a:p>
+            <a:pPr>
+              <a:spcAft>
+                <a:spcPts val="900"/>
+              </a:spcAft>
+            </a:pPr>
+            <a:r>
+              <a:rPr sz="1900" b="0">
                 <a:solidFill>
                   <a:srgbClr val="213444"/>
                 </a:solidFill>
@@ -8818,24 +9069,24 @@
               </a:spcAft>
             </a:pPr>
             <a:r>
-              <a:rPr sz="2100" b="0">
-                <a:solidFill>
-                  <a:srgbClr val="213444"/>
-                </a:solidFill>
-                <a:latin typeface="Microsoft YaHei"/>
-                <a:ea typeface="Microsoft YaHei"/>
-              </a:rPr>
-              <a:t>100位作者课程样本，抽样机制不明；正文/视觉缺失；曝光和统一采集时点未知。</a:t>
-            </a:r>
-          </a:p>
-          <a:p>
-            <a:pPr>
-              <a:spcAft>
-                <a:spcPts val="900"/>
-              </a:spcAft>
-            </a:pPr>
-            <a:r>
-              <a:rPr sz="2100" b="0">
+              <a:rPr sz="1900" b="0">
+                <a:solidFill>
+                  <a:srgbClr val="213444"/>
+                </a:solidFill>
+                <a:latin typeface="Microsoft YaHei"/>
+                <a:ea typeface="Microsoft YaHei"/>
+              </a:rPr>
+              <a:t>4,902次明确回复中，89.0%由帖主发出；用户彼此回复仅2.0%。</a:t>
+            </a:r>
+          </a:p>
+          <a:p>
+            <a:pPr>
+              <a:spcAft>
+                <a:spcPts val="900"/>
+              </a:spcAft>
+            </a:pPr>
+            <a:r>
+              <a:rPr sz="1900" b="0">
                 <a:solidFill>
                   <a:srgbClr val="213444"/>
                 </a:solidFill>
@@ -8852,55 +9103,21 @@
               </a:spcAft>
             </a:pPr>
             <a:r>
-              <a:rPr sz="2100" b="0">
-                <a:solidFill>
-                  <a:srgbClr val="213444"/>
-                </a:solidFill>
-                <a:latin typeface="Microsoft YaHei"/>
-                <a:ea typeface="Microsoft YaHei"/>
-              </a:rPr>
-              <a:t>代码、原始Keep数据、特征表、回归结果与已执行Notebook全部随附。</a:t>
-            </a:r>
-          </a:p>
-          <a:p>
-            <a:pPr>
-              <a:spcAft>
-                <a:spcPts val="900"/>
-              </a:spcAft>
-            </a:pPr>
-            <a:r>
-              <a:rPr sz="2100" b="0">
-                <a:solidFill>
-                  <a:srgbClr val="213444"/>
-                </a:solidFill>
-                <a:latin typeface="Microsoft YaHei"/>
-                <a:ea typeface="Microsoft YaHei"/>
-              </a:rPr>
-              <a:t/>
-            </a:r>
-          </a:p>
-          <a:p>
-            <a:pPr>
-              <a:spcAft>
-                <a:spcPts val="900"/>
-              </a:spcAft>
-            </a:pPr>
-            <a:r>
-              <a:rPr sz="2100" b="0">
-                <a:solidFill>
-                  <a:srgbClr val="213444"/>
-                </a:solidFill>
-                <a:latin typeface="Microsoft YaHei"/>
-                <a:ea typeface="Microsoft YaHei"/>
-              </a:rPr>
-              <a:t>数值独立复核；填好组号、成员后按课程要求打包提交。</a:t>
-            </a:r>
-          </a:p>
-        </p:txBody>
-      </p:sp>
-      <p:sp>
-        <p:nvSpPr>
-          <p:cNvPr id="5" name="TextBox 4"/>
+              <a:rPr sz="1900" b="0">
+                <a:solidFill>
+                  <a:srgbClr val="213444"/>
+                </a:solidFill>
+                <a:latin typeface="Microsoft YaHei"/>
+                <a:ea typeface="Microsoft YaHei"/>
+              </a:rPr>
+              <a:t>首周互惠率74.1%，全部记录49.6%；窗口和采集边界影响结构。</a:t>
+            </a:r>
+          </a:p>
+        </p:txBody>
+      </p:sp>
+      <p:sp>
+        <p:nvSpPr>
+          <p:cNvPr id="6" name="TextBox 5"/>
           <p:cNvSpPr txBox="1"/>
           <p:nvPr/>
         </p:nvSpPr>
@@ -8940,7 +9157,7 @@
       </p:sp>
       <p:sp>
         <p:nvSpPr>
-          <p:cNvPr id="6" name="TextBox 5"/>
+          <p:cNvPr id="7" name="TextBox 6"/>
           <p:cNvSpPr txBox="1"/>
           <p:nvPr/>
         </p:nvSpPr>
@@ -9079,7 +9296,7 @@
                 <a:latin typeface="Microsoft YaHei"/>
                 <a:ea typeface="Microsoft YaHei"/>
               </a:rPr>
-              <a:t>小组分工与讨论</a:t>
+              <a:t>综合解释：内容关联与回应结构</a:t>
             </a:r>
           </a:p>
         </p:txBody>
@@ -9119,7 +9336,7 @@
                 <a:latin typeface="Microsoft YaHei"/>
                 <a:ea typeface="Microsoft YaHei"/>
               </a:rPr>
-              <a:t>成员A【待填写】：研究问题与背景（1—3页）</a:t>
+              <a:t>RQ1：点赞长尾，作者、内容形式和正文覆盖存在差异。</a:t>
             </a:r>
           </a:p>
           <a:p>
@@ -9153,7 +9370,7 @@
                 <a:latin typeface="Microsoft YaHei"/>
                 <a:ea typeface="Microsoft YaHei"/>
               </a:rPr>
-              <a:t>成员B【待填写】：数据、文本与主题（4—10页）</a:t>
+              <a:t>RQ2：词典主回归与主题子样本回归的关联证据均有限。</a:t>
             </a:r>
           </a:p>
           <a:p>
@@ -9187,7 +9404,7 @@
                 <a:latin typeface="Microsoft YaHei"/>
                 <a:ea typeface="Microsoft YaHei"/>
               </a:rPr>
-              <a:t>成员C【待填写】：回归、检验与测量核查（11—15页）</a:t>
+              <a:t>RQ3：可见表达与关系结构共同描绘围绕帖主的交流。</a:t>
             </a:r>
           </a:p>
           <a:p>
@@ -9221,41 +9438,7 @@
                 <a:latin typeface="Microsoft YaHei"/>
                 <a:ea typeface="Microsoft YaHei"/>
               </a:rPr>
-              <a:t>成员D【待填写】：网络、建议与总结（16—21页）</a:t>
-            </a:r>
-          </a:p>
-          <a:p>
-            <a:pPr>
-              <a:spcAft>
-                <a:spcPts val="900"/>
-              </a:spcAft>
-            </a:pPr>
-            <a:r>
-              <a:rPr sz="2100" b="0">
-                <a:solidFill>
-                  <a:srgbClr val="213444"/>
-                </a:solidFill>
-                <a:latin typeface="Microsoft YaHei"/>
-                <a:ea typeface="Microsoft YaHei"/>
-              </a:rPr>
-              <a:t/>
-            </a:r>
-          </a:p>
-          <a:p>
-            <a:pPr>
-              <a:spcAft>
-                <a:spcPts val="900"/>
-              </a:spcAft>
-            </a:pPr>
-            <a:r>
-              <a:rPr sz="2100" b="0">
-                <a:solidFill>
-                  <a:srgbClr val="213444"/>
-                </a:solidFill>
-                <a:latin typeface="Microsoft YaHei"/>
-                <a:ea typeface="Microsoft YaHei"/>
-              </a:rPr>
-              <a:t>建议分工须按真实人数和贡献修订。</a:t>
+              <a:t>两条分析线并列；未识别“文本→评论关系→点赞”的因果路径。</a:t>
             </a:r>
           </a:p>
         </p:txBody>
@@ -9336,6 +9519,1024 @@
                 <a:ea typeface="Microsoft YaHei"/>
               </a:rPr>
               <a:t>21</a:t>
+            </a:r>
+          </a:p>
+        </p:txBody>
+      </p:sp>
+    </p:spTree>
+  </p:cSld>
+  <p:clrMapOvr>
+    <a:masterClrMapping/>
+  </p:clrMapOvr>
+</p:sld>
+</file>
+
+<file path=ppt/slides/slide22.xml><?xml version="1.0" encoding="utf-8"?>
+<p:sld xmlns:a="http://schemas.openxmlformats.org/drawingml/2006/main" xmlns:p="http://schemas.openxmlformats.org/presentationml/2006/main" xmlns:r="http://schemas.openxmlformats.org/officeDocument/2006/relationships">
+  <p:cSld>
+    <p:bg>
+      <p:bgPr>
+        <a:solidFill>
+          <a:srgbClr val="FFFFFF"/>
+        </a:solidFill>
+        <a:effectLst/>
+      </p:bgPr>
+    </p:bg>
+    <p:spTree>
+      <p:nvGrpSpPr>
+        <p:cNvPr id="1" name=""/>
+        <p:cNvGrpSpPr/>
+        <p:nvPr/>
+      </p:nvGrpSpPr>
+      <p:grpSpPr/>
+      <p:sp>
+        <p:nvSpPr>
+          <p:cNvPr id="2" name="TextBox 1"/>
+          <p:cNvSpPr txBox="1"/>
+          <p:nvPr/>
+        </p:nvSpPr>
+        <p:spPr>
+          <a:xfrm>
+            <a:off x="502920" y="256032"/>
+            <a:ext cx="10972800" cy="274320"/>
+          </a:xfrm>
+          <a:prstGeom prst="rect">
+            <a:avLst/>
+          </a:prstGeom>
+          <a:noFill/>
+        </p:spPr>
+        <p:txBody>
+          <a:bodyPr wrap="square" lIns="0" rIns="0" tIns="0" bIns="0">
+            <a:spAutoFit/>
+          </a:bodyPr>
+          <a:lstStyle/>
+          <a:p>
+            <a:pPr>
+              <a:spcAft>
+                <a:spcPts val="900"/>
+              </a:spcAft>
+            </a:pPr>
+            <a:r>
+              <a:rPr sz="1100" b="0">
+                <a:solidFill>
+                  <a:srgbClr val="356D9A"/>
+                </a:solidFill>
+                <a:latin typeface="Microsoft YaHei"/>
+                <a:ea typeface="Microsoft YaHei"/>
+              </a:rPr>
+              <a:t>KEEP COMMUNITY  /  小组项目  /  22</a:t>
+            </a:r>
+          </a:p>
+        </p:txBody>
+      </p:sp>
+      <p:sp>
+        <p:nvSpPr>
+          <p:cNvPr id="3" name="TextBox 2"/>
+          <p:cNvSpPr txBox="1"/>
+          <p:nvPr/>
+        </p:nvSpPr>
+        <p:spPr>
+          <a:xfrm>
+            <a:off x="502920" y="749808"/>
+            <a:ext cx="11155680" cy="822960"/>
+          </a:xfrm>
+          <a:prstGeom prst="rect">
+            <a:avLst/>
+          </a:prstGeom>
+          <a:noFill/>
+        </p:spPr>
+        <p:txBody>
+          <a:bodyPr wrap="square" lIns="0" rIns="0" tIns="0" bIns="0">
+            <a:spAutoFit/>
+          </a:bodyPr>
+          <a:lstStyle/>
+          <a:p>
+            <a:pPr>
+              <a:spcAft>
+                <a:spcPts val="900"/>
+              </a:spcAft>
+            </a:pPr>
+            <a:r>
+              <a:rPr sz="3000" b="1">
+                <a:solidFill>
+                  <a:srgbClr val="213444"/>
+                </a:solidFill>
+                <a:latin typeface="Microsoft YaHei"/>
+                <a:ea typeface="Microsoft YaHei"/>
+              </a:rPr>
+              <a:t>建议：改进评价口径与数据覆盖</a:t>
+            </a:r>
+          </a:p>
+        </p:txBody>
+      </p:sp>
+      <p:sp>
+        <p:nvSpPr>
+          <p:cNvPr id="4" name="TextBox 3"/>
+          <p:cNvSpPr txBox="1"/>
+          <p:nvPr/>
+        </p:nvSpPr>
+        <p:spPr>
+          <a:xfrm>
+            <a:off x="731520" y="1874519"/>
+            <a:ext cx="10698480" cy="4297680"/>
+          </a:xfrm>
+          <a:prstGeom prst="rect">
+            <a:avLst/>
+          </a:prstGeom>
+          <a:noFill/>
+        </p:spPr>
+        <p:txBody>
+          <a:bodyPr wrap="square" lIns="0" rIns="0" tIns="0" bIns="0">
+            <a:spAutoFit/>
+          </a:bodyPr>
+          <a:lstStyle/>
+          <a:p>
+            <a:pPr>
+              <a:spcAft>
+                <a:spcPts val="900"/>
+              </a:spcAft>
+            </a:pPr>
+            <a:r>
+              <a:rPr sz="2100" b="0">
+                <a:solidFill>
+                  <a:srgbClr val="213444"/>
+                </a:solidFill>
+                <a:latin typeface="Microsoft YaHei"/>
+                <a:ea typeface="Microsoft YaHei"/>
+              </a:rPr>
+              <a:t>依据单个词语或原始点赞均值评价内容，证据仍不足。</a:t>
+            </a:r>
+          </a:p>
+          <a:p>
+            <a:pPr>
+              <a:spcAft>
+                <a:spcPts val="900"/>
+              </a:spcAft>
+            </a:pPr>
+            <a:r>
+              <a:rPr sz="2100" b="0">
+                <a:solidFill>
+                  <a:srgbClr val="213444"/>
+                </a:solidFill>
+                <a:latin typeface="Microsoft YaHei"/>
+                <a:ea typeface="Microsoft YaHei"/>
+              </a:rPr>
+              <a:t/>
+            </a:r>
+          </a:p>
+          <a:p>
+            <a:pPr>
+              <a:spcAft>
+                <a:spcPts val="900"/>
+              </a:spcAft>
+            </a:pPr>
+            <a:r>
+              <a:rPr sz="2100" b="0">
+                <a:solidFill>
+                  <a:srgbClr val="213444"/>
+                </a:solidFill>
+                <a:latin typeface="Microsoft YaHei"/>
+                <a:ea typeface="Microsoft YaHei"/>
+              </a:rPr>
+              <a:t>同时记录评论次数、独立参与人数与重复短句。</a:t>
+            </a:r>
+          </a:p>
+          <a:p>
+            <a:pPr>
+              <a:spcAft>
+                <a:spcPts val="900"/>
+              </a:spcAft>
+            </a:pPr>
+            <a:r>
+              <a:rPr sz="2100" b="0">
+                <a:solidFill>
+                  <a:srgbClr val="213444"/>
+                </a:solidFill>
+                <a:latin typeface="Microsoft YaHei"/>
+                <a:ea typeface="Microsoft YaHei"/>
+              </a:rPr>
+              <a:t/>
+            </a:r>
+          </a:p>
+          <a:p>
+            <a:pPr>
+              <a:spcAft>
+                <a:spcPts val="900"/>
+              </a:spcAft>
+            </a:pPr>
+            <a:r>
+              <a:rPr sz="2100" b="0">
+                <a:solidFill>
+                  <a:srgbClr val="213444"/>
+                </a:solidFill>
+                <a:latin typeface="Microsoft YaHei"/>
+                <a:ea typeface="Microsoft YaHei"/>
+              </a:rPr>
+              <a:t>注明网络建边和时间范围，补充曝光与采集覆盖。</a:t>
+            </a:r>
+          </a:p>
+          <a:p>
+            <a:pPr>
+              <a:spcAft>
+                <a:spcPts val="900"/>
+              </a:spcAft>
+            </a:pPr>
+            <a:r>
+              <a:rPr sz="2100" b="0">
+                <a:solidFill>
+                  <a:srgbClr val="213444"/>
+                </a:solidFill>
+                <a:latin typeface="Microsoft YaHei"/>
+                <a:ea typeface="Microsoft YaHei"/>
+              </a:rPr>
+              <a:t/>
+            </a:r>
+          </a:p>
+          <a:p>
+            <a:pPr>
+              <a:spcAft>
+                <a:spcPts val="900"/>
+              </a:spcAft>
+            </a:pPr>
+            <a:r>
+              <a:rPr sz="2100" b="0">
+                <a:solidFill>
+                  <a:srgbClr val="213444"/>
+                </a:solidFill>
+                <a:latin typeface="Microsoft YaHei"/>
+                <a:ea typeface="Microsoft YaHei"/>
+              </a:rPr>
+              <a:t>表达提示或互助方案需另行验证，当前未估计效果。</a:t>
+            </a:r>
+          </a:p>
+        </p:txBody>
+      </p:sp>
+      <p:sp>
+        <p:nvSpPr>
+          <p:cNvPr id="5" name="TextBox 4"/>
+          <p:cNvSpPr txBox="1"/>
+          <p:nvPr/>
+        </p:nvSpPr>
+        <p:spPr>
+          <a:xfrm>
+            <a:off x="502920" y="6419088"/>
+            <a:ext cx="10789920" cy="228600"/>
+          </a:xfrm>
+          <a:prstGeom prst="rect">
+            <a:avLst/>
+          </a:prstGeom>
+          <a:noFill/>
+        </p:spPr>
+        <p:txBody>
+          <a:bodyPr wrap="square" lIns="0" rIns="0" tIns="0" bIns="0">
+            <a:spAutoFit/>
+          </a:bodyPr>
+          <a:lstStyle/>
+          <a:p>
+            <a:pPr>
+              <a:spcAft>
+                <a:spcPts val="900"/>
+              </a:spcAft>
+            </a:pPr>
+            <a:r>
+              <a:rPr sz="1000" b="0">
+                <a:solidFill>
+                  <a:srgbClr val="71818B"/>
+                </a:solidFill>
+                <a:latin typeface="Microsoft YaHei"/>
+                <a:ea typeface="Microsoft YaHei"/>
+              </a:rPr>
+              <a:t>Keep课程样本；观察性分析。全部数值与口径见分析报告及附带结果。</a:t>
+            </a:r>
+          </a:p>
+        </p:txBody>
+      </p:sp>
+      <p:sp>
+        <p:nvSpPr>
+          <p:cNvPr id="6" name="TextBox 5"/>
+          <p:cNvSpPr txBox="1"/>
+          <p:nvPr/>
+        </p:nvSpPr>
+        <p:spPr>
+          <a:xfrm>
+            <a:off x="11201400" y="6419088"/>
+            <a:ext cx="548640" cy="228600"/>
+          </a:xfrm>
+          <a:prstGeom prst="rect">
+            <a:avLst/>
+          </a:prstGeom>
+          <a:noFill/>
+        </p:spPr>
+        <p:txBody>
+          <a:bodyPr wrap="square" lIns="0" rIns="0" tIns="0" bIns="0">
+            <a:spAutoFit/>
+          </a:bodyPr>
+          <a:lstStyle/>
+          <a:p>
+            <a:pPr>
+              <a:spcAft>
+                <a:spcPts val="900"/>
+              </a:spcAft>
+            </a:pPr>
+            <a:r>
+              <a:rPr sz="1000" b="0">
+                <a:solidFill>
+                  <a:srgbClr val="356D9A"/>
+                </a:solidFill>
+                <a:latin typeface="Microsoft YaHei"/>
+                <a:ea typeface="Microsoft YaHei"/>
+              </a:rPr>
+              <a:t>22</a:t>
+            </a:r>
+          </a:p>
+        </p:txBody>
+      </p:sp>
+    </p:spTree>
+  </p:cSld>
+  <p:clrMapOvr>
+    <a:masterClrMapping/>
+  </p:clrMapOvr>
+</p:sld>
+</file>
+
+<file path=ppt/slides/slide23.xml><?xml version="1.0" encoding="utf-8"?>
+<p:sld xmlns:a="http://schemas.openxmlformats.org/drawingml/2006/main" xmlns:p="http://schemas.openxmlformats.org/presentationml/2006/main" xmlns:r="http://schemas.openxmlformats.org/officeDocument/2006/relationships">
+  <p:cSld>
+    <p:bg>
+      <p:bgPr>
+        <a:solidFill>
+          <a:srgbClr val="FFFFFF"/>
+        </a:solidFill>
+        <a:effectLst/>
+      </p:bgPr>
+    </p:bg>
+    <p:spTree>
+      <p:nvGrpSpPr>
+        <p:cNvPr id="1" name=""/>
+        <p:cNvGrpSpPr/>
+        <p:nvPr/>
+      </p:nvGrpSpPr>
+      <p:grpSpPr/>
+      <p:sp>
+        <p:nvSpPr>
+          <p:cNvPr id="2" name="TextBox 1"/>
+          <p:cNvSpPr txBox="1"/>
+          <p:nvPr/>
+        </p:nvSpPr>
+        <p:spPr>
+          <a:xfrm>
+            <a:off x="502920" y="256032"/>
+            <a:ext cx="10972800" cy="274320"/>
+          </a:xfrm>
+          <a:prstGeom prst="rect">
+            <a:avLst/>
+          </a:prstGeom>
+          <a:noFill/>
+        </p:spPr>
+        <p:txBody>
+          <a:bodyPr wrap="square" lIns="0" rIns="0" tIns="0" bIns="0">
+            <a:spAutoFit/>
+          </a:bodyPr>
+          <a:lstStyle/>
+          <a:p>
+            <a:pPr>
+              <a:spcAft>
+                <a:spcPts val="900"/>
+              </a:spcAft>
+            </a:pPr>
+            <a:r>
+              <a:rPr sz="1100" b="0">
+                <a:solidFill>
+                  <a:srgbClr val="356D9A"/>
+                </a:solidFill>
+                <a:latin typeface="Microsoft YaHei"/>
+                <a:ea typeface="Microsoft YaHei"/>
+              </a:rPr>
+              <a:t>KEEP COMMUNITY  /  小组项目  /  23</a:t>
+            </a:r>
+          </a:p>
+        </p:txBody>
+      </p:sp>
+      <p:sp>
+        <p:nvSpPr>
+          <p:cNvPr id="3" name="TextBox 2"/>
+          <p:cNvSpPr txBox="1"/>
+          <p:nvPr/>
+        </p:nvSpPr>
+        <p:spPr>
+          <a:xfrm>
+            <a:off x="502920" y="749808"/>
+            <a:ext cx="11155680" cy="822960"/>
+          </a:xfrm>
+          <a:prstGeom prst="rect">
+            <a:avLst/>
+          </a:prstGeom>
+          <a:noFill/>
+        </p:spPr>
+        <p:txBody>
+          <a:bodyPr wrap="square" lIns="0" rIns="0" tIns="0" bIns="0">
+            <a:spAutoFit/>
+          </a:bodyPr>
+          <a:lstStyle/>
+          <a:p>
+            <a:pPr>
+              <a:spcAft>
+                <a:spcPts val="900"/>
+              </a:spcAft>
+            </a:pPr>
+            <a:r>
+              <a:rPr sz="3000" b="1">
+                <a:solidFill>
+                  <a:srgbClr val="213444"/>
+                </a:solidFill>
+                <a:latin typeface="Microsoft YaHei"/>
+                <a:ea typeface="Microsoft YaHei"/>
+              </a:rPr>
+              <a:t>研究边界与可复现性</a:t>
+            </a:r>
+          </a:p>
+        </p:txBody>
+      </p:sp>
+      <p:sp>
+        <p:nvSpPr>
+          <p:cNvPr id="4" name="TextBox 3"/>
+          <p:cNvSpPr txBox="1"/>
+          <p:nvPr/>
+        </p:nvSpPr>
+        <p:spPr>
+          <a:xfrm>
+            <a:off x="731520" y="1874519"/>
+            <a:ext cx="10698480" cy="4297680"/>
+          </a:xfrm>
+          <a:prstGeom prst="rect">
+            <a:avLst/>
+          </a:prstGeom>
+          <a:noFill/>
+        </p:spPr>
+        <p:txBody>
+          <a:bodyPr wrap="square" lIns="0" rIns="0" tIns="0" bIns="0">
+            <a:spAutoFit/>
+          </a:bodyPr>
+          <a:lstStyle/>
+          <a:p>
+            <a:pPr>
+              <a:spcAft>
+                <a:spcPts val="900"/>
+              </a:spcAft>
+            </a:pPr>
+            <a:r>
+              <a:rPr sz="2100" b="0">
+                <a:solidFill>
+                  <a:srgbClr val="213444"/>
+                </a:solidFill>
+                <a:latin typeface="Microsoft YaHei"/>
+                <a:ea typeface="Microsoft YaHei"/>
+              </a:rPr>
+              <a:t>100位作者的课程样本，抽样机制与统一采集时点未知。</a:t>
+            </a:r>
+          </a:p>
+          <a:p>
+            <a:pPr>
+              <a:spcAft>
+                <a:spcPts val="900"/>
+              </a:spcAft>
+            </a:pPr>
+            <a:r>
+              <a:rPr sz="2100" b="0">
+                <a:solidFill>
+                  <a:srgbClr val="213444"/>
+                </a:solidFill>
+                <a:latin typeface="Microsoft YaHei"/>
+                <a:ea typeface="Microsoft YaHei"/>
+              </a:rPr>
+              <a:t/>
+            </a:r>
+          </a:p>
+          <a:p>
+            <a:pPr>
+              <a:spcAft>
+                <a:spcPts val="900"/>
+              </a:spcAft>
+            </a:pPr>
+            <a:r>
+              <a:rPr sz="2100" b="0">
+                <a:solidFill>
+                  <a:srgbClr val="213444"/>
+                </a:solidFill>
+                <a:latin typeface="Microsoft YaHei"/>
+                <a:ea typeface="Microsoft YaHei"/>
+              </a:rPr>
+              <a:t>全样本帖子、有效正文和已采集评论分别限定结论范围。</a:t>
+            </a:r>
+          </a:p>
+          <a:p>
+            <a:pPr>
+              <a:spcAft>
+                <a:spcPts val="900"/>
+              </a:spcAft>
+            </a:pPr>
+            <a:r>
+              <a:rPr sz="2100" b="0">
+                <a:solidFill>
+                  <a:srgbClr val="213444"/>
+                </a:solidFill>
+                <a:latin typeface="Microsoft YaHei"/>
+                <a:ea typeface="Microsoft YaHei"/>
+              </a:rPr>
+              <a:t/>
+            </a:r>
+          </a:p>
+          <a:p>
+            <a:pPr>
+              <a:spcAft>
+                <a:spcPts val="900"/>
+              </a:spcAft>
+            </a:pPr>
+            <a:r>
+              <a:rPr sz="2100" b="0">
+                <a:solidFill>
+                  <a:srgbClr val="213444"/>
+                </a:solidFill>
+                <a:latin typeface="Microsoft YaHei"/>
+                <a:ea typeface="Microsoft YaHei"/>
+              </a:rPr>
+              <a:t>字面规则未作独立语义效度验证；不显著不等于没有作用。</a:t>
+            </a:r>
+          </a:p>
+          <a:p>
+            <a:pPr>
+              <a:spcAft>
+                <a:spcPts val="900"/>
+              </a:spcAft>
+            </a:pPr>
+            <a:r>
+              <a:rPr sz="2100" b="0">
+                <a:solidFill>
+                  <a:srgbClr val="213444"/>
+                </a:solidFill>
+                <a:latin typeface="Microsoft YaHei"/>
+                <a:ea typeface="Microsoft YaHei"/>
+              </a:rPr>
+              <a:t/>
+            </a:r>
+          </a:p>
+          <a:p>
+            <a:pPr>
+              <a:spcAft>
+                <a:spcPts val="900"/>
+              </a:spcAft>
+            </a:pPr>
+            <a:r>
+              <a:rPr sz="2100" b="0">
+                <a:solidFill>
+                  <a:srgbClr val="213444"/>
+                </a:solidFill>
+                <a:latin typeface="Microsoft YaHei"/>
+                <a:ea typeface="Microsoft YaHei"/>
+              </a:rPr>
+              <a:t>代码、汇总结果与三个已执行Notebook支持复现。</a:t>
+            </a:r>
+          </a:p>
+        </p:txBody>
+      </p:sp>
+      <p:sp>
+        <p:nvSpPr>
+          <p:cNvPr id="5" name="TextBox 4"/>
+          <p:cNvSpPr txBox="1"/>
+          <p:nvPr/>
+        </p:nvSpPr>
+        <p:spPr>
+          <a:xfrm>
+            <a:off x="502920" y="6419088"/>
+            <a:ext cx="10789920" cy="228600"/>
+          </a:xfrm>
+          <a:prstGeom prst="rect">
+            <a:avLst/>
+          </a:prstGeom>
+          <a:noFill/>
+        </p:spPr>
+        <p:txBody>
+          <a:bodyPr wrap="square" lIns="0" rIns="0" tIns="0" bIns="0">
+            <a:spAutoFit/>
+          </a:bodyPr>
+          <a:lstStyle/>
+          <a:p>
+            <a:pPr>
+              <a:spcAft>
+                <a:spcPts val="900"/>
+              </a:spcAft>
+            </a:pPr>
+            <a:r>
+              <a:rPr sz="1000" b="0">
+                <a:solidFill>
+                  <a:srgbClr val="71818B"/>
+                </a:solidFill>
+                <a:latin typeface="Microsoft YaHei"/>
+                <a:ea typeface="Microsoft YaHei"/>
+              </a:rPr>
+              <a:t>Keep课程样本；观察性分析。全部数值与口径见分析报告及附带结果。</a:t>
+            </a:r>
+          </a:p>
+        </p:txBody>
+      </p:sp>
+      <p:sp>
+        <p:nvSpPr>
+          <p:cNvPr id="6" name="TextBox 5"/>
+          <p:cNvSpPr txBox="1"/>
+          <p:nvPr/>
+        </p:nvSpPr>
+        <p:spPr>
+          <a:xfrm>
+            <a:off x="11201400" y="6419088"/>
+            <a:ext cx="548640" cy="228600"/>
+          </a:xfrm>
+          <a:prstGeom prst="rect">
+            <a:avLst/>
+          </a:prstGeom>
+          <a:noFill/>
+        </p:spPr>
+        <p:txBody>
+          <a:bodyPr wrap="square" lIns="0" rIns="0" tIns="0" bIns="0">
+            <a:spAutoFit/>
+          </a:bodyPr>
+          <a:lstStyle/>
+          <a:p>
+            <a:pPr>
+              <a:spcAft>
+                <a:spcPts val="900"/>
+              </a:spcAft>
+            </a:pPr>
+            <a:r>
+              <a:rPr sz="1000" b="0">
+                <a:solidFill>
+                  <a:srgbClr val="356D9A"/>
+                </a:solidFill>
+                <a:latin typeface="Microsoft YaHei"/>
+                <a:ea typeface="Microsoft YaHei"/>
+              </a:rPr>
+              <a:t>23</a:t>
+            </a:r>
+          </a:p>
+        </p:txBody>
+      </p:sp>
+    </p:spTree>
+  </p:cSld>
+  <p:clrMapOvr>
+    <a:masterClrMapping/>
+  </p:clrMapOvr>
+</p:sld>
+</file>
+
+<file path=ppt/slides/slide24.xml><?xml version="1.0" encoding="utf-8"?>
+<p:sld xmlns:a="http://schemas.openxmlformats.org/drawingml/2006/main" xmlns:p="http://schemas.openxmlformats.org/presentationml/2006/main" xmlns:r="http://schemas.openxmlformats.org/officeDocument/2006/relationships">
+  <p:cSld>
+    <p:bg>
+      <p:bgPr>
+        <a:solidFill>
+          <a:srgbClr val="FFFFFF"/>
+        </a:solidFill>
+        <a:effectLst/>
+      </p:bgPr>
+    </p:bg>
+    <p:spTree>
+      <p:nvGrpSpPr>
+        <p:cNvPr id="1" name=""/>
+        <p:cNvGrpSpPr/>
+        <p:nvPr/>
+      </p:nvGrpSpPr>
+      <p:grpSpPr/>
+      <p:sp>
+        <p:nvSpPr>
+          <p:cNvPr id="2" name="TextBox 1"/>
+          <p:cNvSpPr txBox="1"/>
+          <p:nvPr/>
+        </p:nvSpPr>
+        <p:spPr>
+          <a:xfrm>
+            <a:off x="502920" y="256032"/>
+            <a:ext cx="10972800" cy="274320"/>
+          </a:xfrm>
+          <a:prstGeom prst="rect">
+            <a:avLst/>
+          </a:prstGeom>
+          <a:noFill/>
+        </p:spPr>
+        <p:txBody>
+          <a:bodyPr wrap="square" lIns="0" rIns="0" tIns="0" bIns="0">
+            <a:spAutoFit/>
+          </a:bodyPr>
+          <a:lstStyle/>
+          <a:p>
+            <a:pPr>
+              <a:spcAft>
+                <a:spcPts val="900"/>
+              </a:spcAft>
+            </a:pPr>
+            <a:r>
+              <a:rPr sz="1100" b="0">
+                <a:solidFill>
+                  <a:srgbClr val="356D9A"/>
+                </a:solidFill>
+                <a:latin typeface="Microsoft YaHei"/>
+                <a:ea typeface="Microsoft YaHei"/>
+              </a:rPr>
+              <a:t>KEEP COMMUNITY  /  小组项目  /  24</a:t>
+            </a:r>
+          </a:p>
+        </p:txBody>
+      </p:sp>
+      <p:sp>
+        <p:nvSpPr>
+          <p:cNvPr id="3" name="TextBox 2"/>
+          <p:cNvSpPr txBox="1"/>
+          <p:nvPr/>
+        </p:nvSpPr>
+        <p:spPr>
+          <a:xfrm>
+            <a:off x="502920" y="749808"/>
+            <a:ext cx="11155680" cy="822960"/>
+          </a:xfrm>
+          <a:prstGeom prst="rect">
+            <a:avLst/>
+          </a:prstGeom>
+          <a:noFill/>
+        </p:spPr>
+        <p:txBody>
+          <a:bodyPr wrap="square" lIns="0" rIns="0" tIns="0" bIns="0">
+            <a:spAutoFit/>
+          </a:bodyPr>
+          <a:lstStyle/>
+          <a:p>
+            <a:pPr>
+              <a:spcAft>
+                <a:spcPts val="900"/>
+              </a:spcAft>
+            </a:pPr>
+            <a:r>
+              <a:rPr sz="3000" b="1">
+                <a:solidFill>
+                  <a:srgbClr val="213444"/>
+                </a:solidFill>
+                <a:latin typeface="Microsoft YaHei"/>
+                <a:ea typeface="Microsoft YaHei"/>
+              </a:rPr>
+              <a:t>小组分工与讨论</a:t>
+            </a:r>
+          </a:p>
+        </p:txBody>
+      </p:sp>
+      <p:sp>
+        <p:nvSpPr>
+          <p:cNvPr id="4" name="TextBox 3"/>
+          <p:cNvSpPr txBox="1"/>
+          <p:nvPr/>
+        </p:nvSpPr>
+        <p:spPr>
+          <a:xfrm>
+            <a:off x="731520" y="1874519"/>
+            <a:ext cx="10698480" cy="4297680"/>
+          </a:xfrm>
+          <a:prstGeom prst="rect">
+            <a:avLst/>
+          </a:prstGeom>
+          <a:noFill/>
+        </p:spPr>
+        <p:txBody>
+          <a:bodyPr wrap="square" lIns="0" rIns="0" tIns="0" bIns="0">
+            <a:spAutoFit/>
+          </a:bodyPr>
+          <a:lstStyle/>
+          <a:p>
+            <a:pPr>
+              <a:spcAft>
+                <a:spcPts val="900"/>
+              </a:spcAft>
+            </a:pPr>
+            <a:r>
+              <a:rPr sz="2100" b="0">
+                <a:solidFill>
+                  <a:srgbClr val="213444"/>
+                </a:solidFill>
+                <a:latin typeface="Microsoft YaHei"/>
+                <a:ea typeface="Microsoft YaHei"/>
+              </a:rPr>
+              <a:t>成员A【待填写】：研究背景、问题与文献核对（1—3页）</a:t>
+            </a:r>
+          </a:p>
+          <a:p>
+            <a:pPr>
+              <a:spcAft>
+                <a:spcPts val="900"/>
+              </a:spcAft>
+            </a:pPr>
+            <a:r>
+              <a:rPr sz="2100" b="0">
+                <a:solidFill>
+                  <a:srgbClr val="213444"/>
+                </a:solidFill>
+                <a:latin typeface="Microsoft YaHei"/>
+                <a:ea typeface="Microsoft YaHei"/>
+              </a:rPr>
+              <a:t/>
+            </a:r>
+          </a:p>
+          <a:p>
+            <a:pPr>
+              <a:spcAft>
+                <a:spcPts val="900"/>
+              </a:spcAft>
+            </a:pPr>
+            <a:r>
+              <a:rPr sz="2100" b="0">
+                <a:solidFill>
+                  <a:srgbClr val="213444"/>
+                </a:solidFill>
+                <a:latin typeface="Microsoft YaHei"/>
+                <a:ea typeface="Microsoft YaHei"/>
+              </a:rPr>
+              <a:t>成员B【待填写】：数据清洗、文本编码与测量核查（4—9页）</a:t>
+            </a:r>
+          </a:p>
+          <a:p>
+            <a:pPr>
+              <a:spcAft>
+                <a:spcPts val="900"/>
+              </a:spcAft>
+            </a:pPr>
+            <a:r>
+              <a:rPr sz="2100" b="0">
+                <a:solidFill>
+                  <a:srgbClr val="213444"/>
+                </a:solidFill>
+                <a:latin typeface="Microsoft YaHei"/>
+                <a:ea typeface="Microsoft YaHei"/>
+              </a:rPr>
+              <a:t/>
+            </a:r>
+          </a:p>
+          <a:p>
+            <a:pPr>
+              <a:spcAft>
+                <a:spcPts val="900"/>
+              </a:spcAft>
+            </a:pPr>
+            <a:r>
+              <a:rPr sz="2100" b="0">
+                <a:solidFill>
+                  <a:srgbClr val="213444"/>
+                </a:solidFill>
+                <a:latin typeface="Microsoft YaHei"/>
+                <a:ea typeface="Microsoft YaHei"/>
+              </a:rPr>
+              <a:t>成员C【待填写】：回归、稳健性与主题分析（10—15页）</a:t>
+            </a:r>
+          </a:p>
+          <a:p>
+            <a:pPr>
+              <a:spcAft>
+                <a:spcPts val="900"/>
+              </a:spcAft>
+            </a:pPr>
+            <a:r>
+              <a:rPr sz="2100" b="0">
+                <a:solidFill>
+                  <a:srgbClr val="213444"/>
+                </a:solidFill>
+                <a:latin typeface="Microsoft YaHei"/>
+                <a:ea typeface="Microsoft YaHei"/>
+              </a:rPr>
+              <a:t/>
+            </a:r>
+          </a:p>
+          <a:p>
+            <a:pPr>
+              <a:spcAft>
+                <a:spcPts val="900"/>
+              </a:spcAft>
+            </a:pPr>
+            <a:r>
+              <a:rPr sz="2100" b="0">
+                <a:solidFill>
+                  <a:srgbClr val="213444"/>
+                </a:solidFill>
+                <a:latin typeface="Microsoft YaHei"/>
+                <a:ea typeface="Microsoft YaHei"/>
+              </a:rPr>
+              <a:t>成员D【待填写】：评论内容、网络与综合解释（16—24页）</a:t>
+            </a:r>
+          </a:p>
+          <a:p>
+            <a:pPr>
+              <a:spcAft>
+                <a:spcPts val="900"/>
+              </a:spcAft>
+            </a:pPr>
+            <a:r>
+              <a:rPr sz="2100" b="0">
+                <a:solidFill>
+                  <a:srgbClr val="213444"/>
+                </a:solidFill>
+                <a:latin typeface="Microsoft YaHei"/>
+                <a:ea typeface="Microsoft YaHei"/>
+              </a:rPr>
+              <a:t/>
+            </a:r>
+          </a:p>
+          <a:p>
+            <a:pPr>
+              <a:spcAft>
+                <a:spcPts val="900"/>
+              </a:spcAft>
+            </a:pPr>
+            <a:r>
+              <a:rPr sz="2100" b="0">
+                <a:solidFill>
+                  <a:srgbClr val="213444"/>
+                </a:solidFill>
+                <a:latin typeface="Microsoft YaHei"/>
+                <a:ea typeface="Microsoft YaHei"/>
+              </a:rPr>
+              <a:t>建议分工须按真实人数和贡献修订。</a:t>
+            </a:r>
+          </a:p>
+        </p:txBody>
+      </p:sp>
+      <p:sp>
+        <p:nvSpPr>
+          <p:cNvPr id="5" name="TextBox 4"/>
+          <p:cNvSpPr txBox="1"/>
+          <p:nvPr/>
+        </p:nvSpPr>
+        <p:spPr>
+          <a:xfrm>
+            <a:off x="502920" y="6419088"/>
+            <a:ext cx="10789920" cy="228600"/>
+          </a:xfrm>
+          <a:prstGeom prst="rect">
+            <a:avLst/>
+          </a:prstGeom>
+          <a:noFill/>
+        </p:spPr>
+        <p:txBody>
+          <a:bodyPr wrap="square" lIns="0" rIns="0" tIns="0" bIns="0">
+            <a:spAutoFit/>
+          </a:bodyPr>
+          <a:lstStyle/>
+          <a:p>
+            <a:pPr>
+              <a:spcAft>
+                <a:spcPts val="900"/>
+              </a:spcAft>
+            </a:pPr>
+            <a:r>
+              <a:rPr sz="1000" b="0">
+                <a:solidFill>
+                  <a:srgbClr val="71818B"/>
+                </a:solidFill>
+                <a:latin typeface="Microsoft YaHei"/>
+                <a:ea typeface="Microsoft YaHei"/>
+              </a:rPr>
+              <a:t>Keep课程样本；观察性分析。全部数值与口径见分析报告及附带结果。</a:t>
+            </a:r>
+          </a:p>
+        </p:txBody>
+      </p:sp>
+      <p:sp>
+        <p:nvSpPr>
+          <p:cNvPr id="6" name="TextBox 5"/>
+          <p:cNvSpPr txBox="1"/>
+          <p:nvPr/>
+        </p:nvSpPr>
+        <p:spPr>
+          <a:xfrm>
+            <a:off x="11201400" y="6419088"/>
+            <a:ext cx="548640" cy="228600"/>
+          </a:xfrm>
+          <a:prstGeom prst="rect">
+            <a:avLst/>
+          </a:prstGeom>
+          <a:noFill/>
+        </p:spPr>
+        <p:txBody>
+          <a:bodyPr wrap="square" lIns="0" rIns="0" tIns="0" bIns="0">
+            <a:spAutoFit/>
+          </a:bodyPr>
+          <a:lstStyle/>
+          <a:p>
+            <a:pPr>
+              <a:spcAft>
+                <a:spcPts val="900"/>
+              </a:spcAft>
+            </a:pPr>
+            <a:r>
+              <a:rPr sz="1000" b="0">
+                <a:solidFill>
+                  <a:srgbClr val="356D9A"/>
+                </a:solidFill>
+                <a:latin typeface="Microsoft YaHei"/>
+                <a:ea typeface="Microsoft YaHei"/>
+              </a:rPr>
+              <a:t>24</a:t>
             </a:r>
           </a:p>
         </p:txBody>
@@ -9441,7 +10642,7 @@
                 <a:latin typeface="Microsoft YaHei"/>
                 <a:ea typeface="Microsoft YaHei"/>
               </a:rPr>
-              <a:t>研究意义与计划</a:t>
+              <a:t>研究逻辑：帖子关联与评论互动</a:t>
             </a:r>
           </a:p>
         </p:txBody>
@@ -9481,7 +10682,7 @@
                 <a:latin typeface="Microsoft YaHei"/>
                 <a:ea typeface="Microsoft YaHei"/>
               </a:rPr>
-              <a:t>在线社区可能有助于留存，社区互动与运动成效需要区分。[1]</a:t>
+              <a:t>帖子层面：描述差异 → 字面特征回归 → 主题补充。</a:t>
             </a:r>
           </a:p>
           <a:p>
@@ -9515,7 +10716,7 @@
                 <a:latin typeface="Microsoft YaHei"/>
                 <a:ea typeface="Microsoft YaHei"/>
               </a:rPr>
-              <a:t>计划：清洗 → 文本编码 → 固定效应回归 → 稳健性 → 网络 → 建议</a:t>
+              <a:t>评论层面：常见表达与角色 → 用户连接与集中度。</a:t>
             </a:r>
           </a:p>
           <a:p>
@@ -9549,7 +10750,7 @@
                 <a:latin typeface="Microsoft YaHei"/>
                 <a:ea typeface="Microsoft YaHei"/>
               </a:rPr>
-              <a:t>以上分析均已完成；后续实验仅为研究方案。</a:t>
+              <a:t>综合讨论两类证据，分别说明样本与测量边界。[1]</a:t>
             </a:r>
           </a:p>
         </p:txBody>
@@ -11351,35 +12552,119 @@
                 <a:latin typeface="Microsoft YaHei"/>
                 <a:ea typeface="Microsoft YaHei"/>
               </a:rPr>
-              <a:t>NMF补充识别内容表达模式</a:t>
-            </a:r>
-          </a:p>
-        </p:txBody>
-      </p:sp>
-      <p:pic>
-        <p:nvPicPr>
-          <p:cNvPr id="4" name="Picture 3" descr="09_topics.png"/>
-          <p:cNvPicPr>
-            <a:picLocks noChangeAspect="1"/>
-          </p:cNvPicPr>
+              <a:t>词典测量也需要接受检查</a:t>
+            </a:r>
+          </a:p>
+        </p:txBody>
+      </p:sp>
+      <p:sp>
+        <p:nvSpPr>
+          <p:cNvPr id="4" name="TextBox 3"/>
+          <p:cNvSpPr txBox="1"/>
           <p:nvPr/>
-        </p:nvPicPr>
-        <p:blipFill>
-          <a:blip r:embed="rId2"/>
-          <a:stretch>
-            <a:fillRect/>
-          </a:stretch>
-        </p:blipFill>
-        <p:spPr>
-          <a:xfrm>
-            <a:off x="480060" y="2519060"/>
-            <a:ext cx="7452360" cy="2688558"/>
-          </a:xfrm>
-          <a:prstGeom prst="rect">
-            <a:avLst/>
-          </a:prstGeom>
-        </p:spPr>
-      </p:pic>
+        </p:nvSpPr>
+        <p:spPr>
+          <a:xfrm>
+            <a:off x="731520" y="1874519"/>
+            <a:ext cx="10698480" cy="4297680"/>
+          </a:xfrm>
+          <a:prstGeom prst="rect">
+            <a:avLst/>
+          </a:prstGeom>
+          <a:noFill/>
+        </p:spPr>
+        <p:txBody>
+          <a:bodyPr wrap="square" lIns="0" rIns="0" tIns="0" bIns="0">
+            <a:spAutoFit/>
+          </a:bodyPr>
+          <a:lstStyle/>
+          <a:p>
+            <a:pPr>
+              <a:spcAft>
+                <a:spcPts val="900"/>
+              </a:spcAft>
+            </a:pPr>
+            <a:r>
+              <a:rPr sz="2400" b="0">
+                <a:solidFill>
+                  <a:srgbClr val="213444"/>
+                </a:solidFill>
+                <a:latin typeface="Microsoft YaHei"/>
+                <a:ea typeface="Microsoft YaHei"/>
+              </a:rPr>
+              <a:t>40个帖子—特征检查单元：按规则命中分层抽样，无点赞展示。</a:t>
+            </a:r>
+          </a:p>
+          <a:p>
+            <a:pPr>
+              <a:spcAft>
+                <a:spcPts val="900"/>
+              </a:spcAft>
+            </a:pPr>
+            <a:r>
+              <a:rPr sz="2400" b="0">
+                <a:solidFill>
+                  <a:srgbClr val="213444"/>
+                </a:solidFill>
+                <a:latin typeface="Microsoft YaHei"/>
+                <a:ea typeface="Microsoft YaHei"/>
+              </a:rPr>
+              <a:t/>
+            </a:r>
+          </a:p>
+          <a:p>
+            <a:pPr>
+              <a:spcAft>
+                <a:spcPts val="900"/>
+              </a:spcAft>
+            </a:pPr>
+            <a:r>
+              <a:rPr sz="2400" b="0">
+                <a:solidFill>
+                  <a:srgbClr val="213444"/>
+                </a:solidFill>
+                <a:latin typeface="Microsoft YaHei"/>
+                <a:ea typeface="Microsoft YaHei"/>
+              </a:rPr>
+              <a:t>“完成”可能指绘画；“一起”可能描述线下朋友；问号可能是反问。</a:t>
+            </a:r>
+          </a:p>
+          <a:p>
+            <a:pPr>
+              <a:spcAft>
+                <a:spcPts val="900"/>
+              </a:spcAft>
+            </a:pPr>
+            <a:r>
+              <a:rPr sz="2400" b="0">
+                <a:solidFill>
+                  <a:srgbClr val="213444"/>
+                </a:solidFill>
+                <a:latin typeface="Microsoft YaHei"/>
+                <a:ea typeface="Microsoft YaHei"/>
+              </a:rPr>
+              <a:t/>
+            </a:r>
+          </a:p>
+          <a:p>
+            <a:pPr>
+              <a:spcAft>
+                <a:spcPts val="900"/>
+              </a:spcAft>
+            </a:pPr>
+            <a:r>
+              <a:rPr sz="2400" b="0">
+                <a:solidFill>
+                  <a:srgbClr val="213444"/>
+                </a:solidFill>
+                <a:latin typeface="Microsoft YaHei"/>
+                <a:ea typeface="Microsoft YaHei"/>
+              </a:rPr>
+              <a:t>Codex辅助抽查，未做独立人工双编码；不宣称准确率。</a:t>
+            </a:r>
+          </a:p>
+        </p:txBody>
+      </p:sp>
       <p:sp>
         <p:nvSpPr>
           <p:cNvPr id="5" name="TextBox 4"/>
@@ -11388,8 +12673,8 @@
         </p:nvSpPr>
         <p:spPr>
           <a:xfrm>
-            <a:off x="8229600" y="1828800"/>
-            <a:ext cx="3383280" cy="4297680"/>
+            <a:off x="502920" y="6419088"/>
+            <a:ext cx="10789920" cy="228600"/>
           </a:xfrm>
           <a:prstGeom prst="rect">
             <a:avLst/>
@@ -11408,82 +12693,14 @@
               </a:spcAft>
             </a:pPr>
             <a:r>
-              <a:rPr sz="1900" b="0">
-                <a:solidFill>
-                  <a:srgbClr val="213444"/>
-                </a:solidFill>
-                <a:latin typeface="Microsoft YaHei"/>
-                <a:ea typeface="Microsoft YaHei"/>
-              </a:rPr>
-              <a:t>2,470帖、86位作者，1,046词项；主题数固定为5。</a:t>
-            </a:r>
-          </a:p>
-          <a:p>
-            <a:pPr>
-              <a:spcAft>
-                <a:spcPts val="900"/>
-              </a:spcAft>
-            </a:pPr>
-            <a:r>
-              <a:rPr sz="1900" b="0">
-                <a:solidFill>
-                  <a:srgbClr val="213444"/>
-                </a:solidFill>
-                <a:latin typeface="Microsoft YaHei"/>
-                <a:ea typeface="Microsoft YaHei"/>
-              </a:rPr>
-              <a:t/>
-            </a:r>
-          </a:p>
-          <a:p>
-            <a:pPr>
-              <a:spcAft>
-                <a:spcPts val="900"/>
-              </a:spcAft>
-            </a:pPr>
-            <a:r>
-              <a:rPr sz="1900" b="0">
-                <a:solidFill>
-                  <a:srgbClr val="213444"/>
-                </a:solidFill>
-                <a:latin typeface="Microsoft YaHei"/>
-                <a:ea typeface="Microsoft YaHei"/>
-              </a:rPr>
-              <a:t>运动与训练交流52.7%，生活感悟与问候35.8%。</a:t>
-            </a:r>
-          </a:p>
-          <a:p>
-            <a:pPr>
-              <a:spcAft>
-                <a:spcPts val="900"/>
-              </a:spcAft>
-            </a:pPr>
-            <a:r>
-              <a:rPr sz="1900" b="0">
-                <a:solidFill>
-                  <a:srgbClr val="213444"/>
-                </a:solidFill>
-                <a:latin typeface="Microsoft YaHei"/>
-                <a:ea typeface="Microsoft YaHei"/>
-              </a:rPr>
-              <a:t/>
-            </a:r>
-          </a:p>
-          <a:p>
-            <a:pPr>
-              <a:spcAft>
-                <a:spcPts val="900"/>
-              </a:spcAft>
-            </a:pPr>
-            <a:r>
-              <a:rPr sz="1900" b="0">
-                <a:solidFill>
-                  <a:srgbClr val="213444"/>
-                </a:solidFill>
-                <a:latin typeface="Microsoft YaHei"/>
-                <a:ea typeface="Microsoft YaHei"/>
-              </a:rPr>
-              <a:t>静蹲、骑行主题集中于少数作者，反映重复记录习惯。</a:t>
+              <a:rPr sz="1000" b="0">
+                <a:solidFill>
+                  <a:srgbClr val="71818B"/>
+                </a:solidFill>
+                <a:latin typeface="Microsoft YaHei"/>
+                <a:ea typeface="Microsoft YaHei"/>
+              </a:rPr>
+              <a:t>Keep课程样本；观察性分析。全部数值与口径见分析报告及附带结果。</a:t>
             </a:r>
           </a:p>
         </p:txBody>
@@ -11491,46 +12708,6 @@
       <p:sp>
         <p:nvSpPr>
           <p:cNvPr id="6" name="TextBox 5"/>
-          <p:cNvSpPr txBox="1"/>
-          <p:nvPr/>
-        </p:nvSpPr>
-        <p:spPr>
-          <a:xfrm>
-            <a:off x="502920" y="6419088"/>
-            <a:ext cx="10789920" cy="228600"/>
-          </a:xfrm>
-          <a:prstGeom prst="rect">
-            <a:avLst/>
-          </a:prstGeom>
-          <a:noFill/>
-        </p:spPr>
-        <p:txBody>
-          <a:bodyPr wrap="square" lIns="0" rIns="0" tIns="0" bIns="0">
-            <a:spAutoFit/>
-          </a:bodyPr>
-          <a:lstStyle/>
-          <a:p>
-            <a:pPr>
-              <a:spcAft>
-                <a:spcPts val="900"/>
-              </a:spcAft>
-            </a:pPr>
-            <a:r>
-              <a:rPr sz="1000" b="0">
-                <a:solidFill>
-                  <a:srgbClr val="71818B"/>
-                </a:solidFill>
-                <a:latin typeface="Microsoft YaHei"/>
-                <a:ea typeface="Microsoft YaHei"/>
-              </a:rPr>
-              <a:t>Keep课程样本；观察性分析。全部数值与口径见分析报告及附带结果。</a:t>
-            </a:r>
-          </a:p>
-        </p:txBody>
-      </p:sp>
-      <p:sp>
-        <p:nvSpPr>
-          <p:cNvPr id="7" name="TextBox 6"/>
           <p:cNvSpPr txBox="1"/>
           <p:nvPr/>
         </p:nvSpPr>

</xml_diff>

<commit_message>
Separate post topic analysis from comment analysis
</commit_message>
<xml_diff>
--- a/演示文稿.pptx
+++ b/演示文稿.pptx
@@ -875,7 +875,7 @@
           <a:lstStyle/>
           <a:p>
             <a:r>
-              <a:t>主题根据不含点赞数的词项和例文命名。主导类别互斥，软权重可以混合。静蹲主题最大作者占91.8%，骑行主题68.2%。</a:t>
+              <a:t>这一页属于RQ2，与第四章的词典回归共同研究帖子正文。主题根据不含点赞数的词项和例文命名。主导类别互斥，软权重可以混合。静蹲主题最大作者占91.8%，骑行主题68.2%。</a:t>
             </a:r>
           </a:p>
         </p:txBody>
@@ -945,7 +945,7 @@
           <a:lstStyle/>
           <a:p>
             <a:r>
-              <a:t>主题模型纳入至少3个有效词的正文，并排除8条成分贡献近零的记录，占全部帖25.9%。回归控制原词典及作者、日期等因素，区间未包含主题估计误差。</a:t>
+              <a:t>帖子主题分析及回归集中于报告第4.11—4.13节；下一部分转向第五章的评论分析。主题模型纳入至少3个有效词的正文，并排除8条成分贡献近零的记录，占全部帖25.9%。回归控制原词典及作者、日期等因素，区间未包含主题估计误差。</a:t>
             </a:r>
           </a:p>
         </p:txBody>
@@ -1295,7 +1295,7 @@
           <a:lstStyle/>
           <a:p>
             <a:r>
-              <a:t>RQ1由描述统计回答；RQ2由词典主回归、主题分析与主题回归回答；RQ3同时采用评论内容描述和网络分析。研究围绕帖子内容关联与评论互动两条线展开。</a:t>
+              <a:t>RQ1由描述统计回答；RQ2的词典主回归、帖子主题分析与主题回归统一放在第四章；RQ3的评论内容与网络分析统一放在第五章。研究围绕帖子内容关联与评论互动两条线展开。</a:t>
             </a:r>
           </a:p>
         </p:txBody>
@@ -6760,7 +6760,7 @@
                 <a:latin typeface="Microsoft YaHei"/>
                 <a:ea typeface="Microsoft YaHei"/>
               </a:rPr>
-              <a:t>KEEP COMMUNITY  /  小组项目  /  14</a:t>
+              <a:t>KEEP COMMUNITY  /  RQ2 · 帖子文本与点赞  /  14</a:t>
             </a:r>
           </a:p>
         </p:txBody>
@@ -6800,7 +6800,7 @@
                 <a:latin typeface="Microsoft YaHei"/>
                 <a:ea typeface="Microsoft YaHei"/>
               </a:rPr>
-              <a:t>NMF补充识别内容表达模式</a:t>
+              <a:t>帖子主题：NMF识别内容模式</a:t>
             </a:r>
           </a:p>
         </p:txBody>
@@ -7078,7 +7078,7 @@
                 <a:latin typeface="Microsoft YaHei"/>
                 <a:ea typeface="Microsoft YaHei"/>
               </a:rPr>
-              <a:t>KEEP COMMUNITY  /  小组项目  /  15</a:t>
+              <a:t>KEEP COMMUNITY  /  RQ2 · 帖子文本与点赞  /  15</a:t>
             </a:r>
           </a:p>
         </p:txBody>
@@ -7118,7 +7118,7 @@
                 <a:latin typeface="Microsoft YaHei"/>
                 <a:ea typeface="Microsoft YaHei"/>
               </a:rPr>
-              <a:t>主题回归仍未提供明确的增量证据</a:t>
+              <a:t>帖子主题与点赞：主题权重回归</a:t>
             </a:r>
           </a:p>
         </p:txBody>
@@ -7372,7 +7372,7 @@
                 <a:latin typeface="Microsoft YaHei"/>
                 <a:ea typeface="Microsoft YaHei"/>
               </a:rPr>
-              <a:t>KEEP COMMUNITY  /  小组项目  /  16</a:t>
+              <a:t>KEEP COMMUNITY  /  RQ3 · 评论内容与关系  /  16</a:t>
             </a:r>
           </a:p>
         </p:txBody>
@@ -7690,7 +7690,7 @@
                 <a:latin typeface="Microsoft YaHei"/>
                 <a:ea typeface="Microsoft YaHei"/>
               </a:rPr>
-              <a:t>KEEP COMMUNITY  /  小组项目  /  17</a:t>
+              <a:t>KEEP COMMUNITY  /  RQ3 · 评论内容与关系  /  17</a:t>
             </a:r>
           </a:p>
         </p:txBody>
@@ -8008,7 +8008,7 @@
                 <a:latin typeface="Microsoft YaHei"/>
                 <a:ea typeface="Microsoft YaHei"/>
               </a:rPr>
-              <a:t>KEEP COMMUNITY  /  小组项目  /  18</a:t>
+              <a:t>KEEP COMMUNITY  /  RQ3 · 评论内容与关系  /  18</a:t>
             </a:r>
           </a:p>
         </p:txBody>
@@ -8326,7 +8326,7 @@
                 <a:latin typeface="Microsoft YaHei"/>
                 <a:ea typeface="Microsoft YaHei"/>
               </a:rPr>
-              <a:t>KEEP COMMUNITY  /  小组项目  /  19</a:t>
+              <a:t>KEEP COMMUNITY  /  RQ3 · 评论内容与关系  /  19</a:t>
             </a:r>
           </a:p>
         </p:txBody>
@@ -8938,7 +8938,7 @@
                 <a:latin typeface="Microsoft YaHei"/>
                 <a:ea typeface="Microsoft YaHei"/>
               </a:rPr>
-              <a:t>KEEP COMMUNITY  /  小组项目  /  20</a:t>
+              <a:t>KEEP COMMUNITY  /  RQ3 · 评论内容与关系  /  20</a:t>
             </a:r>
           </a:p>
         </p:txBody>

</xml_diff>